<commit_message>
fix: prevent stale package import on Harvest Analysis startup
fix: prevent stale package import on Harvest Analysis startup
</commit_message>
<xml_diff>
--- a/docs/Project_Canary_Milestone_Update_Final.pptx
+++ b/docs/Project_Canary_Milestone_Update_Final.pptx
@@ -2,23 +2,23 @@
 <file path=ppt/presentation.xml><?xml version="1.0" encoding="utf-8"?>
 <p:presentation xmlns:p="http://schemas.openxmlformats.org/presentationml/2006/main">
   <p:sldMasterIdLst>
-    <p:sldMasterId xmlns:r="http://schemas.openxmlformats.org/officeDocument/2006/relationships" id="2147483648" r:id="Rbfff6806816a44ba"/>
+    <p:sldMasterId xmlns:r="http://schemas.openxmlformats.org/officeDocument/2006/relationships" id="2147483648" r:id="R7fc7ec1e51a948b5"/>
   </p:sldMasterIdLst>
   <p:notesMasterIdLst>
-    <p:notesMasterId xmlns:r="http://schemas.openxmlformats.org/officeDocument/2006/relationships" r:id="Rc8611ae88d424c37"/>
+    <p:notesMasterId xmlns:r="http://schemas.openxmlformats.org/officeDocument/2006/relationships" r:id="Re8735d462cef4beb"/>
   </p:notesMasterIdLst>
   <p:sldIdLst>
-    <p:sldId xmlns:r="http://schemas.openxmlformats.org/officeDocument/2006/relationships" id="256" r:id="Ra688a3dbf37d4cee"/>
-    <p:sldId xmlns:r="http://schemas.openxmlformats.org/officeDocument/2006/relationships" id="257" r:id="R169dfbcd47304faa"/>
-    <p:sldId xmlns:r="http://schemas.openxmlformats.org/officeDocument/2006/relationships" id="258" r:id="Rd4cb790b91ed45c4"/>
-    <p:sldId xmlns:r="http://schemas.openxmlformats.org/officeDocument/2006/relationships" id="259" r:id="Refb0c1acfd1b40f6"/>
-    <p:sldId xmlns:r="http://schemas.openxmlformats.org/officeDocument/2006/relationships" id="260" r:id="R1b9c93d971434a28"/>
-    <p:sldId xmlns:r="http://schemas.openxmlformats.org/officeDocument/2006/relationships" id="261" r:id="Ra201b71d4bf2476c"/>
-    <p:sldId xmlns:r="http://schemas.openxmlformats.org/officeDocument/2006/relationships" id="262" r:id="R0d73aa01b6fa4a89"/>
-    <p:sldId xmlns:r="http://schemas.openxmlformats.org/officeDocument/2006/relationships" id="263" r:id="R08820938f427405a"/>
-    <p:sldId xmlns:r="http://schemas.openxmlformats.org/officeDocument/2006/relationships" id="264" r:id="R7bd5ddcea31d42cd"/>
-    <p:sldId xmlns:r="http://schemas.openxmlformats.org/officeDocument/2006/relationships" id="265" r:id="R6d98e21b867a4eae"/>
-    <p:sldId xmlns:r="http://schemas.openxmlformats.org/officeDocument/2006/relationships" id="266" r:id="Rdc03b90cab7d47ed"/>
+    <p:sldId xmlns:r="http://schemas.openxmlformats.org/officeDocument/2006/relationships" id="256" r:id="R440d9eac0cd640cc"/>
+    <p:sldId xmlns:r="http://schemas.openxmlformats.org/officeDocument/2006/relationships" id="257" r:id="Rb1bc6a2822044d4e"/>
+    <p:sldId xmlns:r="http://schemas.openxmlformats.org/officeDocument/2006/relationships" id="258" r:id="Re3663def0f5041b6"/>
+    <p:sldId xmlns:r="http://schemas.openxmlformats.org/officeDocument/2006/relationships" id="259" r:id="R4e24eb4e32914483"/>
+    <p:sldId xmlns:r="http://schemas.openxmlformats.org/officeDocument/2006/relationships" id="260" r:id="R1629921faa7d455a"/>
+    <p:sldId xmlns:r="http://schemas.openxmlformats.org/officeDocument/2006/relationships" id="261" r:id="Rb328f64037334840"/>
+    <p:sldId xmlns:r="http://schemas.openxmlformats.org/officeDocument/2006/relationships" id="262" r:id="Rd871baf121294a80"/>
+    <p:sldId xmlns:r="http://schemas.openxmlformats.org/officeDocument/2006/relationships" id="263" r:id="R25f6eff006ff4d29"/>
+    <p:sldId xmlns:r="http://schemas.openxmlformats.org/officeDocument/2006/relationships" id="264" r:id="R26c4afa4aa9d4e1b"/>
+    <p:sldId xmlns:r="http://schemas.openxmlformats.org/officeDocument/2006/relationships" id="265" r:id="R83664a7062354999"/>
+    <p:sldId xmlns:r="http://schemas.openxmlformats.org/officeDocument/2006/relationships" id="266" r:id="R9d75a16a9b004b2c"/>
   </p:sldIdLst>
   <p:sldSz cx="12192000" cy="6858000"/>
   <p:notesSz cx="6858000" cy="9144000"/>
@@ -1082,7 +1082,7 @@
           <a:lstStyle xmlns:a="http://schemas.openxmlformats.org/drawingml/2006/main"/>
           <a:p xmlns:a="http://schemas.openxmlformats.org/drawingml/2006/main">
             <a:r>
-              <a:t>The best learned linear challenger was Ridge, but it was 5.7% worse than historical remaining gain and reached only 60.5% within 200 g. The approved gate requires 10% improvement and at least 70% within 200 g, so the baseline remains operational.</a:t>
+              <a:t>All learned challengers were worse than historical remaining gain on complete unseen cycles and had negative R². The approved gate requires 10% improvement, positive R², stability, and at least 70% within 200 g, so the baseline remains operational.</a:t>
             </a:r>
           </a:p>
           <a:p xmlns:a="http://schemas.openxmlformats.org/drawingml/2006/main">
@@ -1172,7 +1172,7 @@
           <a:lstStyle xmlns:a="http://schemas.openxmlformats.org/drawingml/2006/main"/>
           <a:p xmlns:a="http://schemas.openxmlformats.org/drawingml/2006/main">
             <a:r>
-              <a:t>Nested whole-cycle validation now selects ordinary linear regression for the continuous estimate. It improves cycle-balanced MAE by 14.5% and keeps positive R², but it does not validate 95% hit-versus-miss classification.</a:t>
+              <a:t>Recovery predicts remaining loss after today. Huber is the best learned research challenger, but the transparent age-band baseline remains operational because Huber does not pass every deployment gate.</a:t>
             </a:r>
           </a:p>
           <a:p xmlns:a="http://schemas.openxmlformats.org/drawingml/2006/main">
@@ -1440,7 +1440,7 @@
   </p:cSld>
   <p:clrMap bg1="lt1" tx1="dk1" bg2="lt2" tx2="dk2" accent1="accent1" accent2="accent2" accent3="accent3" accent4="accent4" accent5="accent5" accent6="accent6" hlink="hlink" folHlink="folHlink"/>
   <p:sldLayoutIdLst>
-    <p:sldLayoutId xmlns:r="http://schemas.openxmlformats.org/officeDocument/2006/relationships" id="2147483649" r:id="R72339124acc14a97"/>
+    <p:sldLayoutId xmlns:r="http://schemas.openxmlformats.org/officeDocument/2006/relationships" id="2147483649" r:id="R1236f5f433764c5d"/>
   </p:sldLayoutIdLst>
   <p:txStyles>
     <p:titleStyle>
@@ -1991,7 +1991,7 @@
           <p:cNvPr id="9" name="accent-bar">
             <a:extLst xmlns:a="http://schemas.openxmlformats.org/drawingml/2006/main">
               <a:ext uri="{FF2B5EF4-FFF2-40B4-BE49-F238E27FC236}">
-                <a16:creationId xmlns:a16="http://schemas.microsoft.com/office/drawing/2014/main" id="{78ECA869-145F-447A-B590-6881C482C806}"/>
+                <a16:creationId xmlns:a16="http://schemas.microsoft.com/office/drawing/2014/main" id="{EA2387DF-6D63-42B0-82EC-3F3C23DB3A13}"/>
               </a:ext>
             </a:extLst>
           </p:cNvPr>
@@ -2022,7 +2022,7 @@
           <p:cNvPr id="2" name="text-52-44">
             <a:extLst xmlns:a="http://schemas.openxmlformats.org/drawingml/2006/main">
               <a:ext uri="{FF2B5EF4-FFF2-40B4-BE49-F238E27FC236}">
-                <a16:creationId xmlns:a16="http://schemas.microsoft.com/office/drawing/2014/main" id="{A4574431-20D1-4B16-B51A-4E1D3846080C}"/>
+                <a16:creationId xmlns:a16="http://schemas.microsoft.com/office/drawing/2014/main" id="{7713246C-626B-46D7-AB89-359F7A1B3433}"/>
               </a:ext>
             </a:extLst>
           </p:cNvPr>
@@ -2080,7 +2080,7 @@
           <p:cNvPr id="3" name="text-52-174">
             <a:extLst xmlns:a="http://schemas.openxmlformats.org/drawingml/2006/main">
               <a:ext uri="{FF2B5EF4-FFF2-40B4-BE49-F238E27FC236}">
-                <a16:creationId xmlns:a16="http://schemas.microsoft.com/office/drawing/2014/main" id="{935CF6BF-B373-4133-89EA-F65A19B4846B}"/>
+                <a16:creationId xmlns:a16="http://schemas.microsoft.com/office/drawing/2014/main" id="{1D5B5B23-79DC-4348-839F-E086B7A63999}"/>
               </a:ext>
             </a:extLst>
           </p:cNvPr>
@@ -2161,7 +2161,7 @@
           <p:cNvPr id="4" name="text-56-430">
             <a:extLst xmlns:a="http://schemas.openxmlformats.org/drawingml/2006/main">
               <a:ext uri="{FF2B5EF4-FFF2-40B4-BE49-F238E27FC236}">
-                <a16:creationId xmlns:a16="http://schemas.microsoft.com/office/drawing/2014/main" id="{42850A74-1D1E-40CC-839F-8FC1B6D21263}"/>
+                <a16:creationId xmlns:a16="http://schemas.microsoft.com/office/drawing/2014/main" id="{BF98E6FC-917E-4B03-B68A-E805CFB4F0F7}"/>
               </a:ext>
             </a:extLst>
           </p:cNvPr>
@@ -2219,7 +2219,7 @@
           <p:cNvPr id="5" name="canary-mark">
             <a:extLst xmlns:a="http://schemas.openxmlformats.org/drawingml/2006/main">
               <a:ext uri="{FF2B5EF4-FFF2-40B4-BE49-F238E27FC236}">
-                <a16:creationId xmlns:a16="http://schemas.microsoft.com/office/drawing/2014/main" id="{B52E8F5C-EDB6-42C8-8CF6-084FCB16AE70}"/>
+                <a16:creationId xmlns:a16="http://schemas.microsoft.com/office/drawing/2014/main" id="{6811F040-20A1-4258-8A60-BA12F901C4E2}"/>
               </a:ext>
             </a:extLst>
           </p:cNvPr>
@@ -2250,7 +2250,7 @@
           <p:cNvPr id="6" name="text-980-116">
             <a:extLst xmlns:a="http://schemas.openxmlformats.org/drawingml/2006/main">
               <a:ext uri="{FF2B5EF4-FFF2-40B4-BE49-F238E27FC236}">
-                <a16:creationId xmlns:a16="http://schemas.microsoft.com/office/drawing/2014/main" id="{B432E4A4-176B-4BD5-BF3C-DEBBB0AE1DF6}"/>
+                <a16:creationId xmlns:a16="http://schemas.microsoft.com/office/drawing/2014/main" id="{111FC8AD-9715-4E24-B883-35E0BD55FA73}"/>
               </a:ext>
             </a:extLst>
           </p:cNvPr>
@@ -2308,7 +2308,7 @@
           <p:cNvPr id="7" name="text-958-248">
             <a:extLst xmlns:a="http://schemas.openxmlformats.org/drawingml/2006/main">
               <a:ext uri="{FF2B5EF4-FFF2-40B4-BE49-F238E27FC236}">
-                <a16:creationId xmlns:a16="http://schemas.microsoft.com/office/drawing/2014/main" id="{89D22A37-7203-4AA8-BF74-6FCBBACEE9DC}"/>
+                <a16:creationId xmlns:a16="http://schemas.microsoft.com/office/drawing/2014/main" id="{3E228C5E-735B-4164-BE9E-2753AB950EB4}"/>
               </a:ext>
             </a:extLst>
           </p:cNvPr>
@@ -2389,7 +2389,7 @@
           <p:cNvPr id="8" name="text-56-640">
             <a:extLst xmlns:a="http://schemas.openxmlformats.org/drawingml/2006/main">
               <a:ext uri="{FF2B5EF4-FFF2-40B4-BE49-F238E27FC236}">
-                <a16:creationId xmlns:a16="http://schemas.microsoft.com/office/drawing/2014/main" id="{884216BF-A226-47DD-81A8-8839F85ED5A9}"/>
+                <a16:creationId xmlns:a16="http://schemas.microsoft.com/office/drawing/2014/main" id="{BA010F29-A007-4D8B-8CE8-D5CEFB54921F}"/>
               </a:ext>
             </a:extLst>
           </p:cNvPr>
@@ -2445,7 +2445,7 @@
     </p:spTree>
     <p:extLst>
       <p:ext uri="{BB962C8B-B14F-4D97-AF65-F5344CB8AC3E}">
-        <p14:creationId xmlns:p14="http://schemas.microsoft.com/office/powerpoint/2010/main" val="1068573208"/>
+        <p14:creationId xmlns:p14="http://schemas.microsoft.com/office/powerpoint/2010/main" val="533049256"/>
       </p:ext>
     </p:extLst>
   </p:cSld>
@@ -2476,7 +2476,7 @@
           <p:cNvPr id="12" name="kicker-10">
             <a:extLst xmlns:a="http://schemas.openxmlformats.org/drawingml/2006/main">
               <a:ext uri="{FF2B5EF4-FFF2-40B4-BE49-F238E27FC236}">
-                <a16:creationId xmlns:a16="http://schemas.microsoft.com/office/drawing/2014/main" id="{C102CF1B-561A-48A6-816E-1305BEC6569C}"/>
+                <a16:creationId xmlns:a16="http://schemas.microsoft.com/office/drawing/2014/main" id="{B7FA8BA2-B052-474A-91AC-7BAA492EF7A0}"/>
               </a:ext>
             </a:extLst>
           </p:cNvPr>
@@ -2534,7 +2534,7 @@
           <p:cNvPr id="2" name="title-10">
             <a:extLst xmlns:a="http://schemas.openxmlformats.org/drawingml/2006/main">
               <a:ext uri="{FF2B5EF4-FFF2-40B4-BE49-F238E27FC236}">
-                <a16:creationId xmlns:a16="http://schemas.microsoft.com/office/drawing/2014/main" id="{CE7490AC-8CBA-44D8-B339-8AA1B38598BC}"/>
+                <a16:creationId xmlns:a16="http://schemas.microsoft.com/office/drawing/2014/main" id="{1FC29E76-BF52-44E2-98CE-6E88EAACF31E}"/>
               </a:ext>
             </a:extLst>
           </p:cNvPr>
@@ -2614,7 +2614,7 @@
           <p:cNvPr id="4" name="page-10">
             <a:extLst xmlns:a="http://schemas.openxmlformats.org/drawingml/2006/main">
               <a:ext uri="{FF2B5EF4-FFF2-40B4-BE49-F238E27FC236}">
-                <a16:creationId xmlns:a16="http://schemas.microsoft.com/office/drawing/2014/main" id="{9C694FCE-6653-4114-BF10-26818460E729}"/>
+                <a16:creationId xmlns:a16="http://schemas.microsoft.com/office/drawing/2014/main" id="{BF1284DF-7501-461F-906E-9E35DAE5D473}"/>
               </a:ext>
             </a:extLst>
           </p:cNvPr>
@@ -2672,7 +2672,7 @@
           <p:cNvPr id="5" name="text-52-176">
             <a:extLst xmlns:a="http://schemas.openxmlformats.org/drawingml/2006/main">
               <a:ext uri="{FF2B5EF4-FFF2-40B4-BE49-F238E27FC236}">
-                <a16:creationId xmlns:a16="http://schemas.microsoft.com/office/drawing/2014/main" id="{F9DEBCCD-BA14-40F5-8439-793663FA8DF0}"/>
+                <a16:creationId xmlns:a16="http://schemas.microsoft.com/office/drawing/2014/main" id="{C3B47CF3-C26E-479B-BA63-19BE510C1D9E}"/>
               </a:ext>
             </a:extLst>
           </p:cNvPr>
@@ -2730,7 +2730,7 @@
           <p:cNvPr id="6" name="text-52-228">
             <a:extLst xmlns:a="http://schemas.openxmlformats.org/drawingml/2006/main">
               <a:ext uri="{FF2B5EF4-FFF2-40B4-BE49-F238E27FC236}">
-                <a16:creationId xmlns:a16="http://schemas.microsoft.com/office/drawing/2014/main" id="{985D3524-EFA1-409D-B5CD-4E9F8A3D6FF7}"/>
+                <a16:creationId xmlns:a16="http://schemas.microsoft.com/office/drawing/2014/main" id="{326E3DB6-9196-45B2-95E5-B6E765B42E87}"/>
               </a:ext>
             </a:extLst>
           </p:cNvPr>
@@ -2922,7 +2922,7 @@
           <p:cNvPr id="8" name="text-684-176">
             <a:extLst xmlns:a="http://schemas.openxmlformats.org/drawingml/2006/main">
               <a:ext uri="{FF2B5EF4-FFF2-40B4-BE49-F238E27FC236}">
-                <a16:creationId xmlns:a16="http://schemas.microsoft.com/office/drawing/2014/main" id="{096405B1-B8E2-4E70-9584-53C2B170E70E}"/>
+                <a16:creationId xmlns:a16="http://schemas.microsoft.com/office/drawing/2014/main" id="{4964CF2D-AD95-4853-8867-2CB8E81E88FC}"/>
               </a:ext>
             </a:extLst>
           </p:cNvPr>
@@ -2980,7 +2980,7 @@
           <p:cNvPr id="9" name="text-684-228">
             <a:extLst xmlns:a="http://schemas.openxmlformats.org/drawingml/2006/main">
               <a:ext uri="{FF2B5EF4-FFF2-40B4-BE49-F238E27FC236}">
-                <a16:creationId xmlns:a16="http://schemas.microsoft.com/office/drawing/2014/main" id="{2BACF472-F890-4069-830D-893489CF74BD}"/>
+                <a16:creationId xmlns:a16="http://schemas.microsoft.com/office/drawing/2014/main" id="{BEB36494-5445-4E84-81A4-83D3202CA107}"/>
               </a:ext>
             </a:extLst>
           </p:cNvPr>
@@ -3178,7 +3178,7 @@
           <p:cNvPr id="10" name="defense-close">
             <a:extLst xmlns:a="http://schemas.openxmlformats.org/drawingml/2006/main">
               <a:ext uri="{FF2B5EF4-FFF2-40B4-BE49-F238E27FC236}">
-                <a16:creationId xmlns:a16="http://schemas.microsoft.com/office/drawing/2014/main" id="{34678BB4-0D18-484A-A5BD-9EAC454C7D3B}"/>
+                <a16:creationId xmlns:a16="http://schemas.microsoft.com/office/drawing/2014/main" id="{4338C21A-9EB2-4B29-BF7E-A857F56E3A6E}"/>
               </a:ext>
             </a:extLst>
           </p:cNvPr>
@@ -3209,7 +3209,7 @@
           <p:cNvPr id="11" name="text-74-629">
             <a:extLst xmlns:a="http://schemas.openxmlformats.org/drawingml/2006/main">
               <a:ext uri="{FF2B5EF4-FFF2-40B4-BE49-F238E27FC236}">
-                <a16:creationId xmlns:a16="http://schemas.microsoft.com/office/drawing/2014/main" id="{03E46881-0825-4DD0-99FF-F27E7960765D}"/>
+                <a16:creationId xmlns:a16="http://schemas.microsoft.com/office/drawing/2014/main" id="{2927EBA6-0F75-49ED-AC90-91FC823EDAC6}"/>
               </a:ext>
             </a:extLst>
           </p:cNvPr>
@@ -3265,7 +3265,7 @@
     </p:spTree>
     <p:extLst>
       <p:ext uri="{BB962C8B-B14F-4D97-AF65-F5344CB8AC3E}">
-        <p14:creationId xmlns:p14="http://schemas.microsoft.com/office/powerpoint/2010/main" val="1599094687"/>
+        <p14:creationId xmlns:p14="http://schemas.microsoft.com/office/powerpoint/2010/main" val="1340571219"/>
       </p:ext>
     </p:extLst>
   </p:cSld>
@@ -3296,7 +3296,7 @@
           <p:cNvPr id="7" name="text-52-54">
             <a:extLst xmlns:a="http://schemas.openxmlformats.org/drawingml/2006/main">
               <a:ext uri="{FF2B5EF4-FFF2-40B4-BE49-F238E27FC236}">
-                <a16:creationId xmlns:a16="http://schemas.microsoft.com/office/drawing/2014/main" id="{4850BFA4-FDE0-4773-9B35-3C7B1FE498BC}"/>
+                <a16:creationId xmlns:a16="http://schemas.microsoft.com/office/drawing/2014/main" id="{5BDF6492-B511-480D-B965-3C685CA4E9B2}"/>
               </a:ext>
             </a:extLst>
           </p:cNvPr>
@@ -3354,7 +3354,7 @@
           <p:cNvPr id="2" name="text-52-154">
             <a:extLst xmlns:a="http://schemas.openxmlformats.org/drawingml/2006/main">
               <a:ext uri="{FF2B5EF4-FFF2-40B4-BE49-F238E27FC236}">
-                <a16:creationId xmlns:a16="http://schemas.microsoft.com/office/drawing/2014/main" id="{F21C05FC-B1B9-4659-A73C-BEAC878A3056}"/>
+                <a16:creationId xmlns:a16="http://schemas.microsoft.com/office/drawing/2014/main" id="{41171BC1-0DFC-449C-99F4-AEDCF2DCB9F4}"/>
               </a:ext>
             </a:extLst>
           </p:cNvPr>
@@ -3412,7 +3412,7 @@
           <p:cNvPr id="3" name="text-52-334">
             <a:extLst xmlns:a="http://schemas.openxmlformats.org/drawingml/2006/main">
               <a:ext uri="{FF2B5EF4-FFF2-40B4-BE49-F238E27FC236}">
-                <a16:creationId xmlns:a16="http://schemas.microsoft.com/office/drawing/2014/main" id="{6E19C51B-555D-4550-8407-1EBECD65D0AD}"/>
+                <a16:creationId xmlns:a16="http://schemas.microsoft.com/office/drawing/2014/main" id="{1B2766BE-DD8E-417C-8BA1-CF797CAADB8E}"/>
               </a:ext>
             </a:extLst>
           </p:cNvPr>
@@ -3492,7 +3492,7 @@
           <p:cNvPr id="5" name="text-52-596">
             <a:extLst xmlns:a="http://schemas.openxmlformats.org/drawingml/2006/main">
               <a:ext uri="{FF2B5EF4-FFF2-40B4-BE49-F238E27FC236}">
-                <a16:creationId xmlns:a16="http://schemas.microsoft.com/office/drawing/2014/main" id="{073462F6-7640-43E0-8C0E-75B78A1BBB25}"/>
+                <a16:creationId xmlns:a16="http://schemas.microsoft.com/office/drawing/2014/main" id="{B518DF1A-A897-4A25-98AE-42C1B25DEB97}"/>
               </a:ext>
             </a:extLst>
           </p:cNvPr>
@@ -3550,7 +3550,7 @@
           <p:cNvPr id="6" name="text-760-606">
             <a:extLst xmlns:a="http://schemas.openxmlformats.org/drawingml/2006/main">
               <a:ext uri="{FF2B5EF4-FFF2-40B4-BE49-F238E27FC236}">
-                <a16:creationId xmlns:a16="http://schemas.microsoft.com/office/drawing/2014/main" id="{D4B4EE11-7861-4477-B15C-9D02DCEDC135}"/>
+                <a16:creationId xmlns:a16="http://schemas.microsoft.com/office/drawing/2014/main" id="{C1C7317D-371A-43B6-955A-2F8BDA90E875}"/>
               </a:ext>
             </a:extLst>
           </p:cNvPr>
@@ -3606,7 +3606,7 @@
     </p:spTree>
     <p:extLst>
       <p:ext uri="{BB962C8B-B14F-4D97-AF65-F5344CB8AC3E}">
-        <p14:creationId xmlns:p14="http://schemas.microsoft.com/office/powerpoint/2010/main" val="1245877835"/>
+        <p14:creationId xmlns:p14="http://schemas.microsoft.com/office/powerpoint/2010/main" val="837805800"/>
       </p:ext>
     </p:extLst>
   </p:cSld>
@@ -3637,7 +3637,7 @@
           <p:cNvPr id="19" name="kicker-2">
             <a:extLst xmlns:a="http://schemas.openxmlformats.org/drawingml/2006/main">
               <a:ext uri="{FF2B5EF4-FFF2-40B4-BE49-F238E27FC236}">
-                <a16:creationId xmlns:a16="http://schemas.microsoft.com/office/drawing/2014/main" id="{FA264A22-B0AD-4895-8CBE-A33762CBFB54}"/>
+                <a16:creationId xmlns:a16="http://schemas.microsoft.com/office/drawing/2014/main" id="{D72D4EA4-FA2B-4223-8CFB-CDB9605B109C}"/>
               </a:ext>
             </a:extLst>
           </p:cNvPr>
@@ -3695,7 +3695,7 @@
           <p:cNvPr id="2" name="title-2">
             <a:extLst xmlns:a="http://schemas.openxmlformats.org/drawingml/2006/main">
               <a:ext uri="{FF2B5EF4-FFF2-40B4-BE49-F238E27FC236}">
-                <a16:creationId xmlns:a16="http://schemas.microsoft.com/office/drawing/2014/main" id="{ABE6E09C-35DE-461A-9FB8-E76A724C41B0}"/>
+                <a16:creationId xmlns:a16="http://schemas.microsoft.com/office/drawing/2014/main" id="{6A953AAF-FE28-43A4-BE7E-1035C9A4B095}"/>
               </a:ext>
             </a:extLst>
           </p:cNvPr>
@@ -3775,7 +3775,7 @@
           <p:cNvPr id="4" name="page-2">
             <a:extLst xmlns:a="http://schemas.openxmlformats.org/drawingml/2006/main">
               <a:ext uri="{FF2B5EF4-FFF2-40B4-BE49-F238E27FC236}">
-                <a16:creationId xmlns:a16="http://schemas.microsoft.com/office/drawing/2014/main" id="{4BB792D5-2D2F-4E00-B29B-718C36030DEE}"/>
+                <a16:creationId xmlns:a16="http://schemas.microsoft.com/office/drawing/2014/main" id="{DD6F989A-5936-48D3-875F-F667FA6CA7C7}"/>
               </a:ext>
             </a:extLst>
           </p:cNvPr>
@@ -3833,7 +3833,7 @@
           <p:cNvPr id="5" name="text-84-186">
             <a:extLst xmlns:a="http://schemas.openxmlformats.org/drawingml/2006/main">
               <a:ext uri="{FF2B5EF4-FFF2-40B4-BE49-F238E27FC236}">
-                <a16:creationId xmlns:a16="http://schemas.microsoft.com/office/drawing/2014/main" id="{D9E1A3D8-8602-4091-ABED-3E7C0BF794B3}"/>
+                <a16:creationId xmlns:a16="http://schemas.microsoft.com/office/drawing/2014/main" id="{11D8EA19-325A-4D1A-B034-4E93872EDA5D}"/>
               </a:ext>
             </a:extLst>
           </p:cNvPr>
@@ -3913,7 +3913,7 @@
           <p:cNvPr id="7" name="text-98-398">
             <a:extLst xmlns:a="http://schemas.openxmlformats.org/drawingml/2006/main">
               <a:ext uri="{FF2B5EF4-FFF2-40B4-BE49-F238E27FC236}">
-                <a16:creationId xmlns:a16="http://schemas.microsoft.com/office/drawing/2014/main" id="{B0197A17-E79D-43B1-9BF4-78A9F55D3479}"/>
+                <a16:creationId xmlns:a16="http://schemas.microsoft.com/office/drawing/2014/main" id="{5D2DF764-F351-45B3-9D36-B1E9158D093E}"/>
               </a:ext>
             </a:extLst>
           </p:cNvPr>
@@ -3971,7 +3971,7 @@
           <p:cNvPr id="8" name="text-98-442">
             <a:extLst xmlns:a="http://schemas.openxmlformats.org/drawingml/2006/main">
               <a:ext uri="{FF2B5EF4-FFF2-40B4-BE49-F238E27FC236}">
-                <a16:creationId xmlns:a16="http://schemas.microsoft.com/office/drawing/2014/main" id="{594724FD-8D7C-4FAC-A645-3FDF3D559F21}"/>
+                <a16:creationId xmlns:a16="http://schemas.microsoft.com/office/drawing/2014/main" id="{B5536911-90A0-441A-940F-262D0385A72E}"/>
               </a:ext>
             </a:extLst>
           </p:cNvPr>
@@ -4029,7 +4029,7 @@
           <p:cNvPr id="9" name="text-98-490">
             <a:extLst xmlns:a="http://schemas.openxmlformats.org/drawingml/2006/main">
               <a:ext uri="{FF2B5EF4-FFF2-40B4-BE49-F238E27FC236}">
-                <a16:creationId xmlns:a16="http://schemas.microsoft.com/office/drawing/2014/main" id="{4E61C2C8-625E-427F-97C8-7445209B4863}"/>
+                <a16:creationId xmlns:a16="http://schemas.microsoft.com/office/drawing/2014/main" id="{875CFC19-0DB3-4EEE-8718-D7E125171B2D}"/>
               </a:ext>
             </a:extLst>
           </p:cNvPr>
@@ -4087,7 +4087,7 @@
           <p:cNvPr id="10" name="text-387-398">
             <a:extLst xmlns:a="http://schemas.openxmlformats.org/drawingml/2006/main">
               <a:ext uri="{FF2B5EF4-FFF2-40B4-BE49-F238E27FC236}">
-                <a16:creationId xmlns:a16="http://schemas.microsoft.com/office/drawing/2014/main" id="{2D1EA771-1FD3-484A-9020-B87E98992A0A}"/>
+                <a16:creationId xmlns:a16="http://schemas.microsoft.com/office/drawing/2014/main" id="{3B44B2CB-4A83-4838-8A8D-B97C4894DF35}"/>
               </a:ext>
             </a:extLst>
           </p:cNvPr>
@@ -4145,7 +4145,7 @@
           <p:cNvPr id="11" name="text-387-442">
             <a:extLst xmlns:a="http://schemas.openxmlformats.org/drawingml/2006/main">
               <a:ext uri="{FF2B5EF4-FFF2-40B4-BE49-F238E27FC236}">
-                <a16:creationId xmlns:a16="http://schemas.microsoft.com/office/drawing/2014/main" id="{75983335-8C60-4844-8CA4-63A8EFA97434}"/>
+                <a16:creationId xmlns:a16="http://schemas.microsoft.com/office/drawing/2014/main" id="{3FEE7A1C-6FB4-4C25-9E88-8901D0A16334}"/>
               </a:ext>
             </a:extLst>
           </p:cNvPr>
@@ -4203,7 +4203,7 @@
           <p:cNvPr id="12" name="text-387-490">
             <a:extLst xmlns:a="http://schemas.openxmlformats.org/drawingml/2006/main">
               <a:ext uri="{FF2B5EF4-FFF2-40B4-BE49-F238E27FC236}">
-                <a16:creationId xmlns:a16="http://schemas.microsoft.com/office/drawing/2014/main" id="{BD592ABB-2FE8-4673-BB8E-00B956FC5DFC}"/>
+                <a16:creationId xmlns:a16="http://schemas.microsoft.com/office/drawing/2014/main" id="{C7AE6F0D-DF65-4615-9562-B292C196D042}"/>
               </a:ext>
             </a:extLst>
           </p:cNvPr>
@@ -4261,7 +4261,7 @@
           <p:cNvPr id="13" name="text-676-398">
             <a:extLst xmlns:a="http://schemas.openxmlformats.org/drawingml/2006/main">
               <a:ext uri="{FF2B5EF4-FFF2-40B4-BE49-F238E27FC236}">
-                <a16:creationId xmlns:a16="http://schemas.microsoft.com/office/drawing/2014/main" id="{D1B6F2A8-1D54-4B08-99C3-A137D3E21128}"/>
+                <a16:creationId xmlns:a16="http://schemas.microsoft.com/office/drawing/2014/main" id="{F861D248-57F5-4BE2-8B13-7FCB04565E72}"/>
               </a:ext>
             </a:extLst>
           </p:cNvPr>
@@ -4319,7 +4319,7 @@
           <p:cNvPr id="14" name="text-676-442">
             <a:extLst xmlns:a="http://schemas.openxmlformats.org/drawingml/2006/main">
               <a:ext uri="{FF2B5EF4-FFF2-40B4-BE49-F238E27FC236}">
-                <a16:creationId xmlns:a16="http://schemas.microsoft.com/office/drawing/2014/main" id="{2E459477-3591-401F-87A9-AE57FEC192DF}"/>
+                <a16:creationId xmlns:a16="http://schemas.microsoft.com/office/drawing/2014/main" id="{B66D651D-8793-4A0F-9C5D-E30EF2AA8853}"/>
               </a:ext>
             </a:extLst>
           </p:cNvPr>
@@ -4377,7 +4377,7 @@
           <p:cNvPr id="15" name="text-676-490">
             <a:extLst xmlns:a="http://schemas.openxmlformats.org/drawingml/2006/main">
               <a:ext uri="{FF2B5EF4-FFF2-40B4-BE49-F238E27FC236}">
-                <a16:creationId xmlns:a16="http://schemas.microsoft.com/office/drawing/2014/main" id="{67FA000D-DBBD-44C1-80CD-A402D0B7C44D}"/>
+                <a16:creationId xmlns:a16="http://schemas.microsoft.com/office/drawing/2014/main" id="{7EFD02B3-204A-4C51-8BF2-5C9D1D4A53AD}"/>
               </a:ext>
             </a:extLst>
           </p:cNvPr>
@@ -4435,7 +4435,7 @@
           <p:cNvPr id="16" name="text-965-398">
             <a:extLst xmlns:a="http://schemas.openxmlformats.org/drawingml/2006/main">
               <a:ext uri="{FF2B5EF4-FFF2-40B4-BE49-F238E27FC236}">
-                <a16:creationId xmlns:a16="http://schemas.microsoft.com/office/drawing/2014/main" id="{37D31F50-DE3F-4824-B1AD-F6784F70E562}"/>
+                <a16:creationId xmlns:a16="http://schemas.microsoft.com/office/drawing/2014/main" id="{D4B354B5-C5C8-4603-9B8A-FA434542DCE9}"/>
               </a:ext>
             </a:extLst>
           </p:cNvPr>
@@ -4493,7 +4493,7 @@
           <p:cNvPr id="17" name="text-965-442">
             <a:extLst xmlns:a="http://schemas.openxmlformats.org/drawingml/2006/main">
               <a:ext uri="{FF2B5EF4-FFF2-40B4-BE49-F238E27FC236}">
-                <a16:creationId xmlns:a16="http://schemas.microsoft.com/office/drawing/2014/main" id="{71A7722A-B2E1-4FDB-BD66-8E91B78C774E}"/>
+                <a16:creationId xmlns:a16="http://schemas.microsoft.com/office/drawing/2014/main" id="{3B7901B7-F09F-408F-9931-1A69E48BC7FB}"/>
               </a:ext>
             </a:extLst>
           </p:cNvPr>
@@ -4551,7 +4551,7 @@
           <p:cNvPr id="18" name="text-965-490">
             <a:extLst xmlns:a="http://schemas.openxmlformats.org/drawingml/2006/main">
               <a:ext uri="{FF2B5EF4-FFF2-40B4-BE49-F238E27FC236}">
-                <a16:creationId xmlns:a16="http://schemas.microsoft.com/office/drawing/2014/main" id="{C5BA6C28-78B4-45E7-9D76-99ADE20989D1}"/>
+                <a16:creationId xmlns:a16="http://schemas.microsoft.com/office/drawing/2014/main" id="{D54F2D82-0A32-46FA-AF67-DEA51FB940AC}"/>
               </a:ext>
             </a:extLst>
           </p:cNvPr>
@@ -4607,7 +4607,7 @@
     </p:spTree>
     <p:extLst>
       <p:ext uri="{BB962C8B-B14F-4D97-AF65-F5344CB8AC3E}">
-        <p14:creationId xmlns:p14="http://schemas.microsoft.com/office/powerpoint/2010/main" val="309976280"/>
+        <p14:creationId xmlns:p14="http://schemas.microsoft.com/office/powerpoint/2010/main" val="345043275"/>
       </p:ext>
     </p:extLst>
   </p:cSld>
@@ -4638,7 +4638,7 @@
           <p:cNvPr id="33" name="kicker-3">
             <a:extLst xmlns:a="http://schemas.openxmlformats.org/drawingml/2006/main">
               <a:ext uri="{FF2B5EF4-FFF2-40B4-BE49-F238E27FC236}">
-                <a16:creationId xmlns:a16="http://schemas.microsoft.com/office/drawing/2014/main" id="{5F2A088F-3664-4CD8-9895-CE93021DD0D6}"/>
+                <a16:creationId xmlns:a16="http://schemas.microsoft.com/office/drawing/2014/main" id="{8ADEF045-9644-471D-9FBC-10785A230312}"/>
               </a:ext>
             </a:extLst>
           </p:cNvPr>
@@ -4696,7 +4696,7 @@
           <p:cNvPr id="2" name="title-3">
             <a:extLst xmlns:a="http://schemas.openxmlformats.org/drawingml/2006/main">
               <a:ext uri="{FF2B5EF4-FFF2-40B4-BE49-F238E27FC236}">
-                <a16:creationId xmlns:a16="http://schemas.microsoft.com/office/drawing/2014/main" id="{A311FEB9-F1E2-4B40-8F4B-FA9187B8A2A0}"/>
+                <a16:creationId xmlns:a16="http://schemas.microsoft.com/office/drawing/2014/main" id="{A429ACEC-5B25-4DD8-9DB0-42676B8BB6CF}"/>
               </a:ext>
             </a:extLst>
           </p:cNvPr>
@@ -4776,7 +4776,7 @@
           <p:cNvPr id="4" name="page-3">
             <a:extLst xmlns:a="http://schemas.openxmlformats.org/drawingml/2006/main">
               <a:ext uri="{FF2B5EF4-FFF2-40B4-BE49-F238E27FC236}">
-                <a16:creationId xmlns:a16="http://schemas.microsoft.com/office/drawing/2014/main" id="{131B6D9C-A1F3-46B5-8918-19A3F71143DB}"/>
+                <a16:creationId xmlns:a16="http://schemas.microsoft.com/office/drawing/2014/main" id="{FFC204EC-A7F6-41BB-9121-B0AF43F66ACA}"/>
               </a:ext>
             </a:extLst>
           </p:cNvPr>
@@ -4834,7 +4834,7 @@
           <p:cNvPr id="5" name="text-42-154">
             <a:extLst xmlns:a="http://schemas.openxmlformats.org/drawingml/2006/main">
               <a:ext uri="{FF2B5EF4-FFF2-40B4-BE49-F238E27FC236}">
-                <a16:creationId xmlns:a16="http://schemas.microsoft.com/office/drawing/2014/main" id="{30A090F7-15F5-4034-9787-0C70F9A37605}"/>
+                <a16:creationId xmlns:a16="http://schemas.microsoft.com/office/drawing/2014/main" id="{01A51147-A5CD-49A6-ABC1-39C5D6AD84D5}"/>
               </a:ext>
             </a:extLst>
           </p:cNvPr>
@@ -4892,7 +4892,7 @@
           <p:cNvPr id="6" name="">
             <a:extLst xmlns:a="http://schemas.openxmlformats.org/drawingml/2006/main">
               <a:ext uri="{FF2B5EF4-FFF2-40B4-BE49-F238E27FC236}">
-                <a16:creationId xmlns:a16="http://schemas.microsoft.com/office/drawing/2014/main" id="{AE3DCD31-40A3-407C-879B-156DF8555A81}"/>
+                <a16:creationId xmlns:a16="http://schemas.microsoft.com/office/drawing/2014/main" id="{6B5BA879-1EEF-4967-ABB7-FFE440AD81CF}"/>
               </a:ext>
             </a:extLst>
           </p:cNvPr>
@@ -4923,7 +4923,7 @@
           <p:cNvPr id="7" name="">
             <a:extLst xmlns:a="http://schemas.openxmlformats.org/drawingml/2006/main">
               <a:ext uri="{FF2B5EF4-FFF2-40B4-BE49-F238E27FC236}">
-                <a16:creationId xmlns:a16="http://schemas.microsoft.com/office/drawing/2014/main" id="{F846A979-4F4B-45F1-9411-475B14E321DA}"/>
+                <a16:creationId xmlns:a16="http://schemas.microsoft.com/office/drawing/2014/main" id="{5B2592DE-69BF-4502-90E5-3E3354DBFD64}"/>
               </a:ext>
             </a:extLst>
           </p:cNvPr>
@@ -4954,7 +4954,7 @@
           <p:cNvPr id="8" name="">
             <a:extLst xmlns:a="http://schemas.openxmlformats.org/drawingml/2006/main">
               <a:ext uri="{FF2B5EF4-FFF2-40B4-BE49-F238E27FC236}">
-                <a16:creationId xmlns:a16="http://schemas.microsoft.com/office/drawing/2014/main" id="{EDB11ED1-CE1B-43E2-9A11-A269793CE6CB}"/>
+                <a16:creationId xmlns:a16="http://schemas.microsoft.com/office/drawing/2014/main" id="{FB17FEBD-3535-45E0-8057-6D9B4016A48D}"/>
               </a:ext>
             </a:extLst>
           </p:cNvPr>
@@ -4985,7 +4985,7 @@
           <p:cNvPr id="9" name="">
             <a:extLst xmlns:a="http://schemas.openxmlformats.org/drawingml/2006/main">
               <a:ext uri="{FF2B5EF4-FFF2-40B4-BE49-F238E27FC236}">
-                <a16:creationId xmlns:a16="http://schemas.microsoft.com/office/drawing/2014/main" id="{C9EDFA2E-1B25-4B06-BF87-51CC36D62F4C}"/>
+                <a16:creationId xmlns:a16="http://schemas.microsoft.com/office/drawing/2014/main" id="{DDF8E33E-BBFE-43D8-9414-A722FDA5FF36}"/>
               </a:ext>
             </a:extLst>
           </p:cNvPr>
@@ -5016,7 +5016,7 @@
           <p:cNvPr id="10" name="text-48-256">
             <a:extLst xmlns:a="http://schemas.openxmlformats.org/drawingml/2006/main">
               <a:ext uri="{FF2B5EF4-FFF2-40B4-BE49-F238E27FC236}">
-                <a16:creationId xmlns:a16="http://schemas.microsoft.com/office/drawing/2014/main" id="{9B6C56E3-5849-43A8-8F8D-7FE712257B6A}"/>
+                <a16:creationId xmlns:a16="http://schemas.microsoft.com/office/drawing/2014/main" id="{8B8B7860-EF39-4684-8E24-3078BBA7402C}"/>
               </a:ext>
             </a:extLst>
           </p:cNvPr>
@@ -5096,7 +5096,7 @@
           <p:cNvPr id="12" name="text-48-318">
             <a:extLst xmlns:a="http://schemas.openxmlformats.org/drawingml/2006/main">
               <a:ext uri="{FF2B5EF4-FFF2-40B4-BE49-F238E27FC236}">
-                <a16:creationId xmlns:a16="http://schemas.microsoft.com/office/drawing/2014/main" id="{412B94B4-002D-4203-B481-1C49561BC153}"/>
+                <a16:creationId xmlns:a16="http://schemas.microsoft.com/office/drawing/2014/main" id="{636F314B-C351-45E3-B035-FC81CF530C53}"/>
               </a:ext>
             </a:extLst>
           </p:cNvPr>
@@ -5154,7 +5154,7 @@
           <p:cNvPr id="13" name="text-48-390">
             <a:extLst xmlns:a="http://schemas.openxmlformats.org/drawingml/2006/main">
               <a:ext uri="{FF2B5EF4-FFF2-40B4-BE49-F238E27FC236}">
-                <a16:creationId xmlns:a16="http://schemas.microsoft.com/office/drawing/2014/main" id="{DB3B14F1-0B5B-456A-AF94-AEFD775E4569}"/>
+                <a16:creationId xmlns:a16="http://schemas.microsoft.com/office/drawing/2014/main" id="{C64D43B7-4FEE-4345-B023-62B90B648878}"/>
               </a:ext>
             </a:extLst>
           </p:cNvPr>
@@ -5212,7 +5212,7 @@
           <p:cNvPr id="14" name="text-286-256">
             <a:extLst xmlns:a="http://schemas.openxmlformats.org/drawingml/2006/main">
               <a:ext uri="{FF2B5EF4-FFF2-40B4-BE49-F238E27FC236}">
-                <a16:creationId xmlns:a16="http://schemas.microsoft.com/office/drawing/2014/main" id="{DB47BF99-2B82-4EBC-B84E-84C0DDAB581C}"/>
+                <a16:creationId xmlns:a16="http://schemas.microsoft.com/office/drawing/2014/main" id="{95940C9C-2F4C-4518-9FCF-D6CA7310DA97}"/>
               </a:ext>
             </a:extLst>
           </p:cNvPr>
@@ -5292,7 +5292,7 @@
           <p:cNvPr id="16" name="text-286-318">
             <a:extLst xmlns:a="http://schemas.openxmlformats.org/drawingml/2006/main">
               <a:ext uri="{FF2B5EF4-FFF2-40B4-BE49-F238E27FC236}">
-                <a16:creationId xmlns:a16="http://schemas.microsoft.com/office/drawing/2014/main" id="{222B276E-A5D4-4652-9EFF-D13F04A95CBE}"/>
+                <a16:creationId xmlns:a16="http://schemas.microsoft.com/office/drawing/2014/main" id="{71AF4E6C-A5D9-4D59-B31F-8E10FDF9AC8A}"/>
               </a:ext>
             </a:extLst>
           </p:cNvPr>
@@ -5350,7 +5350,7 @@
           <p:cNvPr id="17" name="text-286-390">
             <a:extLst xmlns:a="http://schemas.openxmlformats.org/drawingml/2006/main">
               <a:ext uri="{FF2B5EF4-FFF2-40B4-BE49-F238E27FC236}">
-                <a16:creationId xmlns:a16="http://schemas.microsoft.com/office/drawing/2014/main" id="{A4569498-CB0A-49E4-9399-C4480061B755}"/>
+                <a16:creationId xmlns:a16="http://schemas.microsoft.com/office/drawing/2014/main" id="{2B21F99C-760E-4E7E-B2E9-1090812FFC3C}"/>
               </a:ext>
             </a:extLst>
           </p:cNvPr>
@@ -5408,7 +5408,7 @@
           <p:cNvPr id="18" name="text-524-256">
             <a:extLst xmlns:a="http://schemas.openxmlformats.org/drawingml/2006/main">
               <a:ext uri="{FF2B5EF4-FFF2-40B4-BE49-F238E27FC236}">
-                <a16:creationId xmlns:a16="http://schemas.microsoft.com/office/drawing/2014/main" id="{00DF893C-F914-409E-B79E-90519D9E86BF}"/>
+                <a16:creationId xmlns:a16="http://schemas.microsoft.com/office/drawing/2014/main" id="{FC162171-66E6-48DE-9E4B-47F5B0D65867}"/>
               </a:ext>
             </a:extLst>
           </p:cNvPr>
@@ -5488,7 +5488,7 @@
           <p:cNvPr id="20" name="text-524-318">
             <a:extLst xmlns:a="http://schemas.openxmlformats.org/drawingml/2006/main">
               <a:ext uri="{FF2B5EF4-FFF2-40B4-BE49-F238E27FC236}">
-                <a16:creationId xmlns:a16="http://schemas.microsoft.com/office/drawing/2014/main" id="{861F0270-29B8-48CA-85D0-33881FF89608}"/>
+                <a16:creationId xmlns:a16="http://schemas.microsoft.com/office/drawing/2014/main" id="{15B1B8FC-449A-4674-889D-2EBBB63A6D53}"/>
               </a:ext>
             </a:extLst>
           </p:cNvPr>
@@ -5546,7 +5546,7 @@
           <p:cNvPr id="21" name="text-524-390">
             <a:extLst xmlns:a="http://schemas.openxmlformats.org/drawingml/2006/main">
               <a:ext uri="{FF2B5EF4-FFF2-40B4-BE49-F238E27FC236}">
-                <a16:creationId xmlns:a16="http://schemas.microsoft.com/office/drawing/2014/main" id="{53262A19-6CB5-4E09-996D-4F9D1E013329}"/>
+                <a16:creationId xmlns:a16="http://schemas.microsoft.com/office/drawing/2014/main" id="{2FBF2FF5-7C61-4E52-87BD-7AD6DC32781C}"/>
               </a:ext>
             </a:extLst>
           </p:cNvPr>
@@ -5627,7 +5627,7 @@
           <p:cNvPr id="22" name="text-762-256">
             <a:extLst xmlns:a="http://schemas.openxmlformats.org/drawingml/2006/main">
               <a:ext uri="{FF2B5EF4-FFF2-40B4-BE49-F238E27FC236}">
-                <a16:creationId xmlns:a16="http://schemas.microsoft.com/office/drawing/2014/main" id="{BDB59CF2-F633-4B03-BA7E-DF2C4D71E240}"/>
+                <a16:creationId xmlns:a16="http://schemas.microsoft.com/office/drawing/2014/main" id="{7F220484-6C4C-4413-A022-1F815B82C159}"/>
               </a:ext>
             </a:extLst>
           </p:cNvPr>
@@ -5707,7 +5707,7 @@
           <p:cNvPr id="24" name="text-762-318">
             <a:extLst xmlns:a="http://schemas.openxmlformats.org/drawingml/2006/main">
               <a:ext uri="{FF2B5EF4-FFF2-40B4-BE49-F238E27FC236}">
-                <a16:creationId xmlns:a16="http://schemas.microsoft.com/office/drawing/2014/main" id="{23CD55C0-F8F3-4FEB-ABBA-6939436D609E}"/>
+                <a16:creationId xmlns:a16="http://schemas.microsoft.com/office/drawing/2014/main" id="{62FC1CCC-ABC2-4C41-9E1A-6E57C2EC6623}"/>
               </a:ext>
             </a:extLst>
           </p:cNvPr>
@@ -5765,7 +5765,7 @@
           <p:cNvPr id="25" name="text-762-390">
             <a:extLst xmlns:a="http://schemas.openxmlformats.org/drawingml/2006/main">
               <a:ext uri="{FF2B5EF4-FFF2-40B4-BE49-F238E27FC236}">
-                <a16:creationId xmlns:a16="http://schemas.microsoft.com/office/drawing/2014/main" id="{C302C978-E247-4748-B413-368FDDCF7A32}"/>
+                <a16:creationId xmlns:a16="http://schemas.microsoft.com/office/drawing/2014/main" id="{3ECE0F2F-1C36-49B3-AF52-BD100E29B00F}"/>
               </a:ext>
             </a:extLst>
           </p:cNvPr>
@@ -5846,7 +5846,7 @@
           <p:cNvPr id="26" name="text-1000-256">
             <a:extLst xmlns:a="http://schemas.openxmlformats.org/drawingml/2006/main">
               <a:ext uri="{FF2B5EF4-FFF2-40B4-BE49-F238E27FC236}">
-                <a16:creationId xmlns:a16="http://schemas.microsoft.com/office/drawing/2014/main" id="{8EFAE9B9-C220-4F81-82EA-9648A000DA70}"/>
+                <a16:creationId xmlns:a16="http://schemas.microsoft.com/office/drawing/2014/main" id="{B154EEA3-ABC8-4104-8E62-AE9C0CD94B50}"/>
               </a:ext>
             </a:extLst>
           </p:cNvPr>
@@ -5926,7 +5926,7 @@
           <p:cNvPr id="28" name="text-1000-318">
             <a:extLst xmlns:a="http://schemas.openxmlformats.org/drawingml/2006/main">
               <a:ext uri="{FF2B5EF4-FFF2-40B4-BE49-F238E27FC236}">
-                <a16:creationId xmlns:a16="http://schemas.microsoft.com/office/drawing/2014/main" id="{94AEAEC8-487F-499F-99BD-AC3C9FDE9FDD}"/>
+                <a16:creationId xmlns:a16="http://schemas.microsoft.com/office/drawing/2014/main" id="{66373F43-ABC8-4564-A877-2C47B8E5091B}"/>
               </a:ext>
             </a:extLst>
           </p:cNvPr>
@@ -5984,7 +5984,7 @@
           <p:cNvPr id="29" name="text-1000-390">
             <a:extLst xmlns:a="http://schemas.openxmlformats.org/drawingml/2006/main">
               <a:ext uri="{FF2B5EF4-FFF2-40B4-BE49-F238E27FC236}">
-                <a16:creationId xmlns:a16="http://schemas.microsoft.com/office/drawing/2014/main" id="{BDA85E85-DC2E-4646-BCB0-618C8659779F}"/>
+                <a16:creationId xmlns:a16="http://schemas.microsoft.com/office/drawing/2014/main" id="{9ED6C9B7-E57A-456C-A845-79E950751A03}"/>
               </a:ext>
             </a:extLst>
           </p:cNvPr>
@@ -6065,7 +6065,7 @@
           <p:cNvPr id="30" name="leakage-callout">
             <a:extLst xmlns:a="http://schemas.openxmlformats.org/drawingml/2006/main">
               <a:ext uri="{FF2B5EF4-FFF2-40B4-BE49-F238E27FC236}">
-                <a16:creationId xmlns:a16="http://schemas.microsoft.com/office/drawing/2014/main" id="{0A2C1C45-5980-4F76-9A46-2C97E3F25A2B}"/>
+                <a16:creationId xmlns:a16="http://schemas.microsoft.com/office/drawing/2014/main" id="{6B768058-7E14-4A50-9355-8F8FF1944D49}"/>
               </a:ext>
             </a:extLst>
           </p:cNvPr>
@@ -6096,7 +6096,7 @@
           <p:cNvPr id="31" name="text-64-570">
             <a:extLst xmlns:a="http://schemas.openxmlformats.org/drawingml/2006/main">
               <a:ext uri="{FF2B5EF4-FFF2-40B4-BE49-F238E27FC236}">
-                <a16:creationId xmlns:a16="http://schemas.microsoft.com/office/drawing/2014/main" id="{AE8B27EE-C7B0-4F76-B5F2-5E7353E81B53}"/>
+                <a16:creationId xmlns:a16="http://schemas.microsoft.com/office/drawing/2014/main" id="{4BAB6A45-8A70-4AB9-9BC3-1520A2197209}"/>
               </a:ext>
             </a:extLst>
           </p:cNvPr>
@@ -6154,7 +6154,7 @@
           <p:cNvPr id="32" name="text-276-568">
             <a:extLst xmlns:a="http://schemas.openxmlformats.org/drawingml/2006/main">
               <a:ext uri="{FF2B5EF4-FFF2-40B4-BE49-F238E27FC236}">
-                <a16:creationId xmlns:a16="http://schemas.microsoft.com/office/drawing/2014/main" id="{1D9A87BE-3A94-4F2E-B906-CB206E1C2438}"/>
+                <a16:creationId xmlns:a16="http://schemas.microsoft.com/office/drawing/2014/main" id="{09CF6C49-1B5D-431D-92B8-EF5F5314DD24}"/>
               </a:ext>
             </a:extLst>
           </p:cNvPr>
@@ -6210,7 +6210,7 @@
     </p:spTree>
     <p:extLst>
       <p:ext uri="{BB962C8B-B14F-4D97-AF65-F5344CB8AC3E}">
-        <p14:creationId xmlns:p14="http://schemas.microsoft.com/office/powerpoint/2010/main" val="557177113"/>
+        <p14:creationId xmlns:p14="http://schemas.microsoft.com/office/powerpoint/2010/main" val="1494167972"/>
       </p:ext>
     </p:extLst>
   </p:cSld>
@@ -6241,7 +6241,7 @@
           <p:cNvPr id="21" name="kicker-4">
             <a:extLst xmlns:a="http://schemas.openxmlformats.org/drawingml/2006/main">
               <a:ext uri="{FF2B5EF4-FFF2-40B4-BE49-F238E27FC236}">
-                <a16:creationId xmlns:a16="http://schemas.microsoft.com/office/drawing/2014/main" id="{410CDE4C-AE06-42E9-8B44-953C14F7F37D}"/>
+                <a16:creationId xmlns:a16="http://schemas.microsoft.com/office/drawing/2014/main" id="{3BA99739-9F3D-4258-A78C-29E9AE1DBF41}"/>
               </a:ext>
             </a:extLst>
           </p:cNvPr>
@@ -6299,7 +6299,7 @@
           <p:cNvPr id="2" name="title-4">
             <a:extLst xmlns:a="http://schemas.openxmlformats.org/drawingml/2006/main">
               <a:ext uri="{FF2B5EF4-FFF2-40B4-BE49-F238E27FC236}">
-                <a16:creationId xmlns:a16="http://schemas.microsoft.com/office/drawing/2014/main" id="{1460248E-2025-42FB-B647-0C895F50DA2A}"/>
+                <a16:creationId xmlns:a16="http://schemas.microsoft.com/office/drawing/2014/main" id="{207F54E8-5935-4BF2-93C7-B51B1F5AC70D}"/>
               </a:ext>
             </a:extLst>
           </p:cNvPr>
@@ -6379,7 +6379,7 @@
           <p:cNvPr id="4" name="page-4">
             <a:extLst xmlns:a="http://schemas.openxmlformats.org/drawingml/2006/main">
               <a:ext uri="{FF2B5EF4-FFF2-40B4-BE49-F238E27FC236}">
-                <a16:creationId xmlns:a16="http://schemas.microsoft.com/office/drawing/2014/main" id="{70BDA9CA-15AB-4BFB-ADF0-D23AA4698977}"/>
+                <a16:creationId xmlns:a16="http://schemas.microsoft.com/office/drawing/2014/main" id="{37A84958-FECB-4985-9416-E0164BF7D52E}"/>
               </a:ext>
             </a:extLst>
           </p:cNvPr>
@@ -6437,7 +6437,7 @@
           <p:cNvPr id="5" name="text-52-178">
             <a:extLst xmlns:a="http://schemas.openxmlformats.org/drawingml/2006/main">
               <a:ext uri="{FF2B5EF4-FFF2-40B4-BE49-F238E27FC236}">
-                <a16:creationId xmlns:a16="http://schemas.microsoft.com/office/drawing/2014/main" id="{FF455C3E-6537-4683-A5A8-B931EF191D1A}"/>
+                <a16:creationId xmlns:a16="http://schemas.microsoft.com/office/drawing/2014/main" id="{16731FB9-9C4E-4376-A5A7-0863E3FD5C1F}"/>
               </a:ext>
             </a:extLst>
           </p:cNvPr>
@@ -6495,7 +6495,7 @@
           <p:cNvPr id="6" name="text-52-270">
             <a:extLst xmlns:a="http://schemas.openxmlformats.org/drawingml/2006/main">
               <a:ext uri="{FF2B5EF4-FFF2-40B4-BE49-F238E27FC236}">
-                <a16:creationId xmlns:a16="http://schemas.microsoft.com/office/drawing/2014/main" id="{36D7C383-A9F5-44FA-A70B-0F9181C77317}"/>
+                <a16:creationId xmlns:a16="http://schemas.microsoft.com/office/drawing/2014/main" id="{4102E469-B854-4214-A6E8-5087384DE34D}"/>
               </a:ext>
             </a:extLst>
           </p:cNvPr>
@@ -6553,7 +6553,7 @@
           <p:cNvPr id="7" name="text-52-334">
             <a:extLst xmlns:a="http://schemas.openxmlformats.org/drawingml/2006/main">
               <a:ext uri="{FF2B5EF4-FFF2-40B4-BE49-F238E27FC236}">
-                <a16:creationId xmlns:a16="http://schemas.microsoft.com/office/drawing/2014/main" id="{A26DE6B7-8E79-4B8D-B8B9-188E09AC5A51}"/>
+                <a16:creationId xmlns:a16="http://schemas.microsoft.com/office/drawing/2014/main" id="{8E2B7022-D862-44E4-8785-8682688321A0}"/>
               </a:ext>
             </a:extLst>
           </p:cNvPr>
@@ -6633,7 +6633,7 @@
           <p:cNvPr id="9" name="text-52-458">
             <a:extLst xmlns:a="http://schemas.openxmlformats.org/drawingml/2006/main">
               <a:ext uri="{FF2B5EF4-FFF2-40B4-BE49-F238E27FC236}">
-                <a16:creationId xmlns:a16="http://schemas.microsoft.com/office/drawing/2014/main" id="{E7C4BE62-CBCA-4426-B7CA-8239A9A9A830}"/>
+                <a16:creationId xmlns:a16="http://schemas.microsoft.com/office/drawing/2014/main" id="{96661211-F9EC-4F19-ACD8-6D565B4A6016}"/>
               </a:ext>
             </a:extLst>
           </p:cNvPr>
@@ -6714,7 +6714,7 @@
           <p:cNvPr id="10" name="text-445-178">
             <a:extLst xmlns:a="http://schemas.openxmlformats.org/drawingml/2006/main">
               <a:ext uri="{FF2B5EF4-FFF2-40B4-BE49-F238E27FC236}">
-                <a16:creationId xmlns:a16="http://schemas.microsoft.com/office/drawing/2014/main" id="{B20BBB2A-A8F1-49D5-9FB5-4E6B86A2D35E}"/>
+                <a16:creationId xmlns:a16="http://schemas.microsoft.com/office/drawing/2014/main" id="{C3B67B38-AA06-4B09-B011-5EBFDD43AF94}"/>
               </a:ext>
             </a:extLst>
           </p:cNvPr>
@@ -6772,7 +6772,7 @@
           <p:cNvPr id="11" name="text-445-270">
             <a:extLst xmlns:a="http://schemas.openxmlformats.org/drawingml/2006/main">
               <a:ext uri="{FF2B5EF4-FFF2-40B4-BE49-F238E27FC236}">
-                <a16:creationId xmlns:a16="http://schemas.microsoft.com/office/drawing/2014/main" id="{F52C9EF6-8223-4479-8D61-6207C7997E02}"/>
+                <a16:creationId xmlns:a16="http://schemas.microsoft.com/office/drawing/2014/main" id="{E38CBAEA-B6A5-4C00-A217-0492CA7F4EB4}"/>
               </a:ext>
             </a:extLst>
           </p:cNvPr>
@@ -6830,7 +6830,7 @@
           <p:cNvPr id="12" name="text-445-334">
             <a:extLst xmlns:a="http://schemas.openxmlformats.org/drawingml/2006/main">
               <a:ext uri="{FF2B5EF4-FFF2-40B4-BE49-F238E27FC236}">
-                <a16:creationId xmlns:a16="http://schemas.microsoft.com/office/drawing/2014/main" id="{8BA7F732-AB23-49F7-884A-C459B93218B5}"/>
+                <a16:creationId xmlns:a16="http://schemas.microsoft.com/office/drawing/2014/main" id="{295AEAB1-E008-418C-81E4-964759DFBB88}"/>
               </a:ext>
             </a:extLst>
           </p:cNvPr>
@@ -6910,7 +6910,7 @@
           <p:cNvPr id="14" name="text-445-458">
             <a:extLst xmlns:a="http://schemas.openxmlformats.org/drawingml/2006/main">
               <a:ext uri="{FF2B5EF4-FFF2-40B4-BE49-F238E27FC236}">
-                <a16:creationId xmlns:a16="http://schemas.microsoft.com/office/drawing/2014/main" id="{CB33B579-ABF8-4D6B-9866-9CE91C2D5FCB}"/>
+                <a16:creationId xmlns:a16="http://schemas.microsoft.com/office/drawing/2014/main" id="{DE47FC0D-9E4A-4333-8BD2-75CEA5A963F0}"/>
               </a:ext>
             </a:extLst>
           </p:cNvPr>
@@ -6991,7 +6991,7 @@
           <p:cNvPr id="15" name="text-838-178">
             <a:extLst xmlns:a="http://schemas.openxmlformats.org/drawingml/2006/main">
               <a:ext uri="{FF2B5EF4-FFF2-40B4-BE49-F238E27FC236}">
-                <a16:creationId xmlns:a16="http://schemas.microsoft.com/office/drawing/2014/main" id="{AA6F9BF1-2737-41B8-BF8C-7BBEE8C25A38}"/>
+                <a16:creationId xmlns:a16="http://schemas.microsoft.com/office/drawing/2014/main" id="{292BC474-DD48-4F93-AFA5-4CEFDE0594E4}"/>
               </a:ext>
             </a:extLst>
           </p:cNvPr>
@@ -7049,7 +7049,7 @@
           <p:cNvPr id="16" name="text-838-270">
             <a:extLst xmlns:a="http://schemas.openxmlformats.org/drawingml/2006/main">
               <a:ext uri="{FF2B5EF4-FFF2-40B4-BE49-F238E27FC236}">
-                <a16:creationId xmlns:a16="http://schemas.microsoft.com/office/drawing/2014/main" id="{59C73B14-A2BD-4AAF-8D15-BC4A41E3F439}"/>
+                <a16:creationId xmlns:a16="http://schemas.microsoft.com/office/drawing/2014/main" id="{2FB99055-2A91-481A-A608-FA48919D9AA9}"/>
               </a:ext>
             </a:extLst>
           </p:cNvPr>
@@ -7107,7 +7107,7 @@
           <p:cNvPr id="17" name="text-838-334">
             <a:extLst xmlns:a="http://schemas.openxmlformats.org/drawingml/2006/main">
               <a:ext uri="{FF2B5EF4-FFF2-40B4-BE49-F238E27FC236}">
-                <a16:creationId xmlns:a16="http://schemas.microsoft.com/office/drawing/2014/main" id="{C739C652-3B17-4088-90DB-13353A7CF486}"/>
+                <a16:creationId xmlns:a16="http://schemas.microsoft.com/office/drawing/2014/main" id="{DA1B0D5F-B433-495C-9B89-5A6182162999}"/>
               </a:ext>
             </a:extLst>
           </p:cNvPr>
@@ -7187,7 +7187,7 @@
           <p:cNvPr id="19" name="text-838-458">
             <a:extLst xmlns:a="http://schemas.openxmlformats.org/drawingml/2006/main">
               <a:ext uri="{FF2B5EF4-FFF2-40B4-BE49-F238E27FC236}">
-                <a16:creationId xmlns:a16="http://schemas.microsoft.com/office/drawing/2014/main" id="{59B6C90F-D12C-41AE-8D7A-A14F427F45B8}"/>
+                <a16:creationId xmlns:a16="http://schemas.microsoft.com/office/drawing/2014/main" id="{D08A6DA6-EF4C-4992-9A62-5771097F0556}"/>
               </a:ext>
             </a:extLst>
           </p:cNvPr>
@@ -7268,7 +7268,7 @@
           <p:cNvPr id="20" name="text-52-626">
             <a:extLst xmlns:a="http://schemas.openxmlformats.org/drawingml/2006/main">
               <a:ext uri="{FF2B5EF4-FFF2-40B4-BE49-F238E27FC236}">
-                <a16:creationId xmlns:a16="http://schemas.microsoft.com/office/drawing/2014/main" id="{BD0638B2-D052-4F48-8178-FF3474EBE651}"/>
+                <a16:creationId xmlns:a16="http://schemas.microsoft.com/office/drawing/2014/main" id="{25927480-4B79-41A7-BAB8-01E4F10F6E08}"/>
               </a:ext>
             </a:extLst>
           </p:cNvPr>
@@ -7324,7 +7324,7 @@
     </p:spTree>
     <p:extLst>
       <p:ext uri="{BB962C8B-B14F-4D97-AF65-F5344CB8AC3E}">
-        <p14:creationId xmlns:p14="http://schemas.microsoft.com/office/powerpoint/2010/main" val="974251794"/>
+        <p14:creationId xmlns:p14="http://schemas.microsoft.com/office/powerpoint/2010/main" val="680022473"/>
       </p:ext>
     </p:extLst>
   </p:cSld>
@@ -7355,7 +7355,7 @@
           <p:cNvPr id="27" name="kicker-5">
             <a:extLst xmlns:a="http://schemas.openxmlformats.org/drawingml/2006/main">
               <a:ext uri="{FF2B5EF4-FFF2-40B4-BE49-F238E27FC236}">
-                <a16:creationId xmlns:a16="http://schemas.microsoft.com/office/drawing/2014/main" id="{462B1772-43D2-438E-8092-EA845CA4E1D5}"/>
+                <a16:creationId xmlns:a16="http://schemas.microsoft.com/office/drawing/2014/main" id="{D4BFE8D1-B218-40B1-9CA6-F24BC931166E}"/>
               </a:ext>
             </a:extLst>
           </p:cNvPr>
@@ -7413,7 +7413,7 @@
           <p:cNvPr id="2" name="title-5">
             <a:extLst xmlns:a="http://schemas.openxmlformats.org/drawingml/2006/main">
               <a:ext uri="{FF2B5EF4-FFF2-40B4-BE49-F238E27FC236}">
-                <a16:creationId xmlns:a16="http://schemas.microsoft.com/office/drawing/2014/main" id="{36AC24D0-5FBA-4251-BB12-1815480627FE}"/>
+                <a16:creationId xmlns:a16="http://schemas.microsoft.com/office/drawing/2014/main" id="{D43F3F71-BBE9-4537-9375-A1FE9163EAD7}"/>
               </a:ext>
             </a:extLst>
           </p:cNvPr>
@@ -7493,7 +7493,7 @@
           <p:cNvPr id="4" name="page-5">
             <a:extLst xmlns:a="http://schemas.openxmlformats.org/drawingml/2006/main">
               <a:ext uri="{FF2B5EF4-FFF2-40B4-BE49-F238E27FC236}">
-                <a16:creationId xmlns:a16="http://schemas.microsoft.com/office/drawing/2014/main" id="{B11BFDCF-F846-4596-BDFA-197F7B302387}"/>
+                <a16:creationId xmlns:a16="http://schemas.microsoft.com/office/drawing/2014/main" id="{FAB844FB-65C3-4DD4-B9B3-3E18233B1E41}"/>
               </a:ext>
             </a:extLst>
           </p:cNvPr>
@@ -7551,7 +7551,7 @@
           <p:cNvPr id="5" name="text-48-178">
             <a:extLst xmlns:a="http://schemas.openxmlformats.org/drawingml/2006/main">
               <a:ext uri="{FF2B5EF4-FFF2-40B4-BE49-F238E27FC236}">
-                <a16:creationId xmlns:a16="http://schemas.microsoft.com/office/drawing/2014/main" id="{8CA4D048-8B12-4801-A53C-74A0F0F7BF4B}"/>
+                <a16:creationId xmlns:a16="http://schemas.microsoft.com/office/drawing/2014/main" id="{70272385-6FCC-4FBF-94D6-3BB978B79FF3}"/>
               </a:ext>
             </a:extLst>
           </p:cNvPr>
@@ -7609,7 +7609,7 @@
           <p:cNvPr id="6" name="text-180-180">
             <a:extLst xmlns:a="http://schemas.openxmlformats.org/drawingml/2006/main">
               <a:ext uri="{FF2B5EF4-FFF2-40B4-BE49-F238E27FC236}">
-                <a16:creationId xmlns:a16="http://schemas.microsoft.com/office/drawing/2014/main" id="{B7AF9E64-BD2C-433E-AFCE-5F6FAFE29EC0}"/>
+                <a16:creationId xmlns:a16="http://schemas.microsoft.com/office/drawing/2014/main" id="{35EA0333-DDCA-4BFB-826D-0E7CC26383E8}"/>
               </a:ext>
             </a:extLst>
           </p:cNvPr>
@@ -7667,7 +7667,7 @@
           <p:cNvPr id="7" name="text-180-224">
             <a:extLst xmlns:a="http://schemas.openxmlformats.org/drawingml/2006/main">
               <a:ext uri="{FF2B5EF4-FFF2-40B4-BE49-F238E27FC236}">
-                <a16:creationId xmlns:a16="http://schemas.microsoft.com/office/drawing/2014/main" id="{D4F4AF42-BD9D-42D3-BEF1-BB098EC7A743}"/>
+                <a16:creationId xmlns:a16="http://schemas.microsoft.com/office/drawing/2014/main" id="{23C1BD59-3B38-44A8-82F8-5822AE925D82}"/>
               </a:ext>
             </a:extLst>
           </p:cNvPr>
@@ -7747,7 +7747,7 @@
           <p:cNvPr id="9" name="text-652-178">
             <a:extLst xmlns:a="http://schemas.openxmlformats.org/drawingml/2006/main">
               <a:ext uri="{FF2B5EF4-FFF2-40B4-BE49-F238E27FC236}">
-                <a16:creationId xmlns:a16="http://schemas.microsoft.com/office/drawing/2014/main" id="{A5F720CF-BE24-4FF4-8653-02C1EBBA0E0F}"/>
+                <a16:creationId xmlns:a16="http://schemas.microsoft.com/office/drawing/2014/main" id="{32CAABB6-0285-4B79-BA5B-6FB3B0CDAF3C}"/>
               </a:ext>
             </a:extLst>
           </p:cNvPr>
@@ -7805,7 +7805,7 @@
           <p:cNvPr id="10" name="text-784-180">
             <a:extLst xmlns:a="http://schemas.openxmlformats.org/drawingml/2006/main">
               <a:ext uri="{FF2B5EF4-FFF2-40B4-BE49-F238E27FC236}">
-                <a16:creationId xmlns:a16="http://schemas.microsoft.com/office/drawing/2014/main" id="{F1ABC323-1BE0-40C3-B233-9A3386C529C6}"/>
+                <a16:creationId xmlns:a16="http://schemas.microsoft.com/office/drawing/2014/main" id="{85E9AD82-C80A-4C27-9CE4-8E9585F10961}"/>
               </a:ext>
             </a:extLst>
           </p:cNvPr>
@@ -7863,7 +7863,7 @@
           <p:cNvPr id="11" name="text-784-224">
             <a:extLst xmlns:a="http://schemas.openxmlformats.org/drawingml/2006/main">
               <a:ext uri="{FF2B5EF4-FFF2-40B4-BE49-F238E27FC236}">
-                <a16:creationId xmlns:a16="http://schemas.microsoft.com/office/drawing/2014/main" id="{4F9D91B8-5538-484F-A599-BA1C4BAB297A}"/>
+                <a16:creationId xmlns:a16="http://schemas.microsoft.com/office/drawing/2014/main" id="{A5FD5530-6562-40D3-B1F5-E2C66C9E285B}"/>
               </a:ext>
             </a:extLst>
           </p:cNvPr>
@@ -7943,7 +7943,7 @@
           <p:cNvPr id="13" name="text-48-398">
             <a:extLst xmlns:a="http://schemas.openxmlformats.org/drawingml/2006/main">
               <a:ext uri="{FF2B5EF4-FFF2-40B4-BE49-F238E27FC236}">
-                <a16:creationId xmlns:a16="http://schemas.microsoft.com/office/drawing/2014/main" id="{B4BECD89-804E-4C5D-BFEC-564ADA250DBD}"/>
+                <a16:creationId xmlns:a16="http://schemas.microsoft.com/office/drawing/2014/main" id="{60E07D2A-87E2-4AD1-8265-1627FD94FEC5}"/>
               </a:ext>
             </a:extLst>
           </p:cNvPr>
@@ -8001,7 +8001,7 @@
           <p:cNvPr id="14" name="text-180-400">
             <a:extLst xmlns:a="http://schemas.openxmlformats.org/drawingml/2006/main">
               <a:ext uri="{FF2B5EF4-FFF2-40B4-BE49-F238E27FC236}">
-                <a16:creationId xmlns:a16="http://schemas.microsoft.com/office/drawing/2014/main" id="{7E58239F-346C-43FD-BD85-A14FD2026947}"/>
+                <a16:creationId xmlns:a16="http://schemas.microsoft.com/office/drawing/2014/main" id="{C65F2A97-7542-4365-85C9-F87DADD46C76}"/>
               </a:ext>
             </a:extLst>
           </p:cNvPr>
@@ -8059,7 +8059,7 @@
           <p:cNvPr id="15" name="text-180-444">
             <a:extLst xmlns:a="http://schemas.openxmlformats.org/drawingml/2006/main">
               <a:ext uri="{FF2B5EF4-FFF2-40B4-BE49-F238E27FC236}">
-                <a16:creationId xmlns:a16="http://schemas.microsoft.com/office/drawing/2014/main" id="{61834B7E-1C9D-46DE-8A67-20CB7DA27891}"/>
+                <a16:creationId xmlns:a16="http://schemas.microsoft.com/office/drawing/2014/main" id="{7F59C50C-2529-4ED8-A2E6-114090AB819A}"/>
               </a:ext>
             </a:extLst>
           </p:cNvPr>
@@ -8139,7 +8139,7 @@
           <p:cNvPr id="17" name="text-652-398">
             <a:extLst xmlns:a="http://schemas.openxmlformats.org/drawingml/2006/main">
               <a:ext uri="{FF2B5EF4-FFF2-40B4-BE49-F238E27FC236}">
-                <a16:creationId xmlns:a16="http://schemas.microsoft.com/office/drawing/2014/main" id="{1A3C149B-8027-4F91-8A51-9F532F57FB43}"/>
+                <a16:creationId xmlns:a16="http://schemas.microsoft.com/office/drawing/2014/main" id="{89CB64FB-7DF7-40C2-BED9-93458E5A2680}"/>
               </a:ext>
             </a:extLst>
           </p:cNvPr>
@@ -8197,7 +8197,7 @@
           <p:cNvPr id="18" name="text-784-400">
             <a:extLst xmlns:a="http://schemas.openxmlformats.org/drawingml/2006/main">
               <a:ext uri="{FF2B5EF4-FFF2-40B4-BE49-F238E27FC236}">
-                <a16:creationId xmlns:a16="http://schemas.microsoft.com/office/drawing/2014/main" id="{895F186F-AF00-4DA8-A7F0-B457768EDC0F}"/>
+                <a16:creationId xmlns:a16="http://schemas.microsoft.com/office/drawing/2014/main" id="{DCD6CC3A-0885-48EB-9D25-E2C5306F038B}"/>
               </a:ext>
             </a:extLst>
           </p:cNvPr>
@@ -8255,7 +8255,7 @@
           <p:cNvPr id="19" name="text-784-444">
             <a:extLst xmlns:a="http://schemas.openxmlformats.org/drawingml/2006/main">
               <a:ext uri="{FF2B5EF4-FFF2-40B4-BE49-F238E27FC236}">
-                <a16:creationId xmlns:a16="http://schemas.microsoft.com/office/drawing/2014/main" id="{4C605559-3206-4A3E-9D0A-B95C8FF4BAEF}"/>
+                <a16:creationId xmlns:a16="http://schemas.microsoft.com/office/drawing/2014/main" id="{DACB016E-67D2-46E2-8E1A-74E02493D9DA}"/>
               </a:ext>
             </a:extLst>
           </p:cNvPr>
@@ -8335,7 +8335,7 @@
           <p:cNvPr id="21" name="risk-label-band">
             <a:extLst xmlns:a="http://schemas.openxmlformats.org/drawingml/2006/main">
               <a:ext uri="{FF2B5EF4-FFF2-40B4-BE49-F238E27FC236}">
-                <a16:creationId xmlns:a16="http://schemas.microsoft.com/office/drawing/2014/main" id="{42DECC82-7F39-467D-9AB1-097A2F808C06}"/>
+                <a16:creationId xmlns:a16="http://schemas.microsoft.com/office/drawing/2014/main" id="{4F77F35A-525D-46B1-9561-AC36491E40A4}"/>
               </a:ext>
             </a:extLst>
           </p:cNvPr>
@@ -8366,7 +8366,7 @@
           <p:cNvPr id="22" name="text-72-612">
             <a:extLst xmlns:a="http://schemas.openxmlformats.org/drawingml/2006/main">
               <a:ext uri="{FF2B5EF4-FFF2-40B4-BE49-F238E27FC236}">
-                <a16:creationId xmlns:a16="http://schemas.microsoft.com/office/drawing/2014/main" id="{A868FD6C-7F36-4961-8AE1-D6AA1611B40C}"/>
+                <a16:creationId xmlns:a16="http://schemas.microsoft.com/office/drawing/2014/main" id="{B2D9A163-C3E8-4CE1-B31E-407CCE9B14EC}"/>
               </a:ext>
             </a:extLst>
           </p:cNvPr>
@@ -8424,7 +8424,7 @@
           <p:cNvPr id="23" name="text-230-608">
             <a:extLst xmlns:a="http://schemas.openxmlformats.org/drawingml/2006/main">
               <a:ext uri="{FF2B5EF4-FFF2-40B4-BE49-F238E27FC236}">
-                <a16:creationId xmlns:a16="http://schemas.microsoft.com/office/drawing/2014/main" id="{AC16A6AD-A2AB-4B06-8CAB-65447DA53E35}"/>
+                <a16:creationId xmlns:a16="http://schemas.microsoft.com/office/drawing/2014/main" id="{D98172E9-0B0A-490B-8B5B-69BFEFB16ED1}"/>
               </a:ext>
             </a:extLst>
           </p:cNvPr>
@@ -8482,7 +8482,7 @@
           <p:cNvPr id="24" name="text-446-608">
             <a:extLst xmlns:a="http://schemas.openxmlformats.org/drawingml/2006/main">
               <a:ext uri="{FF2B5EF4-FFF2-40B4-BE49-F238E27FC236}">
-                <a16:creationId xmlns:a16="http://schemas.microsoft.com/office/drawing/2014/main" id="{8ACC5E6A-4B56-447F-9E04-DBAF339C1695}"/>
+                <a16:creationId xmlns:a16="http://schemas.microsoft.com/office/drawing/2014/main" id="{F935AC17-C7B7-4D83-A72B-1DB5B0860B8B}"/>
               </a:ext>
             </a:extLst>
           </p:cNvPr>
@@ -8540,7 +8540,7 @@
           <p:cNvPr id="25" name="text-690-608">
             <a:extLst xmlns:a="http://schemas.openxmlformats.org/drawingml/2006/main">
               <a:ext uri="{FF2B5EF4-FFF2-40B4-BE49-F238E27FC236}">
-                <a16:creationId xmlns:a16="http://schemas.microsoft.com/office/drawing/2014/main" id="{446D934B-3EDD-483B-BEC7-2D7ACB0BB870}"/>
+                <a16:creationId xmlns:a16="http://schemas.microsoft.com/office/drawing/2014/main" id="{0D80589B-E7E1-4BC0-A9AB-12ECCB3AF1CB}"/>
               </a:ext>
             </a:extLst>
           </p:cNvPr>
@@ -8598,7 +8598,7 @@
           <p:cNvPr id="26" name="text-900-608">
             <a:extLst xmlns:a="http://schemas.openxmlformats.org/drawingml/2006/main">
               <a:ext uri="{FF2B5EF4-FFF2-40B4-BE49-F238E27FC236}">
-                <a16:creationId xmlns:a16="http://schemas.microsoft.com/office/drawing/2014/main" id="{2CC6CEE4-6562-452F-B64C-0341FAEB4EBA}"/>
+                <a16:creationId xmlns:a16="http://schemas.microsoft.com/office/drawing/2014/main" id="{3CA52EE6-2AF3-4151-83A8-49F9433C7AA1}"/>
               </a:ext>
             </a:extLst>
           </p:cNvPr>
@@ -8654,7 +8654,7 @@
     </p:spTree>
     <p:extLst>
       <p:ext uri="{BB962C8B-B14F-4D97-AF65-F5344CB8AC3E}">
-        <p14:creationId xmlns:p14="http://schemas.microsoft.com/office/powerpoint/2010/main" val="2026504390"/>
+        <p14:creationId xmlns:p14="http://schemas.microsoft.com/office/powerpoint/2010/main" val="1445291598"/>
       </p:ext>
     </p:extLst>
   </p:cSld>
@@ -8685,7 +8685,7 @@
           <p:cNvPr id="56" name="kicker-6">
             <a:extLst xmlns:a="http://schemas.openxmlformats.org/drawingml/2006/main">
               <a:ext uri="{FF2B5EF4-FFF2-40B4-BE49-F238E27FC236}">
-                <a16:creationId xmlns:a16="http://schemas.microsoft.com/office/drawing/2014/main" id="{CDA7F709-0E22-4AFA-944B-A81FC7B3ECFA}"/>
+                <a16:creationId xmlns:a16="http://schemas.microsoft.com/office/drawing/2014/main" id="{9CF1D95A-3F90-4BB3-95C3-F767ABA6E3F8}"/>
               </a:ext>
             </a:extLst>
           </p:cNvPr>
@@ -8743,7 +8743,7 @@
           <p:cNvPr id="2" name="title-6">
             <a:extLst xmlns:a="http://schemas.openxmlformats.org/drawingml/2006/main">
               <a:ext uri="{FF2B5EF4-FFF2-40B4-BE49-F238E27FC236}">
-                <a16:creationId xmlns:a16="http://schemas.microsoft.com/office/drawing/2014/main" id="{02607A59-AB0E-4172-BC25-053F23D09EF1}"/>
+                <a16:creationId xmlns:a16="http://schemas.microsoft.com/office/drawing/2014/main" id="{A7F39BB5-8651-4134-81F8-21C5402F1679}"/>
               </a:ext>
             </a:extLst>
           </p:cNvPr>
@@ -8823,7 +8823,7 @@
           <p:cNvPr id="4" name="page-6">
             <a:extLst xmlns:a="http://schemas.openxmlformats.org/drawingml/2006/main">
               <a:ext uri="{FF2B5EF4-FFF2-40B4-BE49-F238E27FC236}">
-                <a16:creationId xmlns:a16="http://schemas.microsoft.com/office/drawing/2014/main" id="{EB3F0657-C85D-4BB5-8657-9E0CD3B0810F}"/>
+                <a16:creationId xmlns:a16="http://schemas.microsoft.com/office/drawing/2014/main" id="{E7A983CB-0DF5-412A-9238-B0506603922B}"/>
               </a:ext>
             </a:extLst>
           </p:cNvPr>
@@ -8881,7 +8881,7 @@
           <p:cNvPr id="5" name="text-42-148">
             <a:extLst xmlns:a="http://schemas.openxmlformats.org/drawingml/2006/main">
               <a:ext uri="{FF2B5EF4-FFF2-40B4-BE49-F238E27FC236}">
-                <a16:creationId xmlns:a16="http://schemas.microsoft.com/office/drawing/2014/main" id="{2B444560-51B7-4F6E-81CA-57922AD4DC24}"/>
+                <a16:creationId xmlns:a16="http://schemas.microsoft.com/office/drawing/2014/main" id="{132383C9-C69A-4943-BAFD-AAAAF99D4F0D}"/>
               </a:ext>
             </a:extLst>
           </p:cNvPr>
@@ -8929,7 +8929,7 @@
                 <a:ea typeface="Helvetica Neue"/>
                 <a:cs typeface="Helvetica Neue"/>
               </a:rPr>
-              <a:t>Y: observed building average weight on Day 35</a:t>
+              <a:t>Y: remaining gain from the checkpoint to Day 35</a:t>
             </a:r>
           </a:p>
         </p:txBody>
@@ -8939,7 +8939,7 @@
           <p:cNvPr id="6" name="text-42-184">
             <a:extLst xmlns:a="http://schemas.openxmlformats.org/drawingml/2006/main">
               <a:ext uri="{FF2B5EF4-FFF2-40B4-BE49-F238E27FC236}">
-                <a16:creationId xmlns:a16="http://schemas.microsoft.com/office/drawing/2014/main" id="{ED802948-923B-4872-BFC0-233F3C905F48}"/>
+                <a16:creationId xmlns:a16="http://schemas.microsoft.com/office/drawing/2014/main" id="{9672DEC8-CF5A-4E32-A464-BEF2B3579BEA}"/>
               </a:ext>
             </a:extLst>
           </p:cNvPr>
@@ -8997,7 +8997,7 @@
           <p:cNvPr id="7" name="model-table-header-278">
             <a:extLst xmlns:a="http://schemas.openxmlformats.org/drawingml/2006/main">
               <a:ext uri="{FF2B5EF4-FFF2-40B4-BE49-F238E27FC236}">
-                <a16:creationId xmlns:a16="http://schemas.microsoft.com/office/drawing/2014/main" id="{1D709B4C-7FFD-4018-9B2A-43EFDF129F6A}"/>
+                <a16:creationId xmlns:a16="http://schemas.microsoft.com/office/drawing/2014/main" id="{0A2DE2A4-5041-4C16-8FDC-86AC12BDB427}"/>
               </a:ext>
             </a:extLst>
           </p:cNvPr>
@@ -9028,7 +9028,7 @@
           <p:cNvPr id="8" name="text-50-288">
             <a:extLst xmlns:a="http://schemas.openxmlformats.org/drawingml/2006/main">
               <a:ext uri="{FF2B5EF4-FFF2-40B4-BE49-F238E27FC236}">
-                <a16:creationId xmlns:a16="http://schemas.microsoft.com/office/drawing/2014/main" id="{96E63424-66CB-4236-8676-B1C92FFDCD49}"/>
+                <a16:creationId xmlns:a16="http://schemas.microsoft.com/office/drawing/2014/main" id="{2466D8E4-4C85-4E05-8EA1-1E120C00E512}"/>
               </a:ext>
             </a:extLst>
           </p:cNvPr>
@@ -9040,7 +9040,7 @@
         <p:spPr>
           <a:xfrm xmlns:a="http://schemas.openxmlformats.org/drawingml/2006/main">
             <a:off x="476250" y="2743200"/>
-            <a:ext cx="1485900" cy="209550"/>
+            <a:ext cx="1371600" cy="209550"/>
           </a:xfrm>
           <a:prstGeom xmlns:a="http://schemas.openxmlformats.org/drawingml/2006/main" prst="rect">
             <a:avLst/>
@@ -9083,21 +9083,21 @@
       </p:sp>
       <p:sp>
         <p:nvSpPr>
-          <p:cNvPr id="9" name="text-222-288">
-            <a:extLst xmlns:a="http://schemas.openxmlformats.org/drawingml/2006/main">
-              <a:ext uri="{FF2B5EF4-FFF2-40B4-BE49-F238E27FC236}">
-                <a16:creationId xmlns:a16="http://schemas.microsoft.com/office/drawing/2014/main" id="{20840555-25A1-400F-8AA5-C9DE06F76D82}"/>
-              </a:ext>
-            </a:extLst>
-          </p:cNvPr>
-          <p:cNvSpPr>
-            <a:spLocks xmlns:a="http://schemas.openxmlformats.org/drawingml/2006/main" noGrp="1"/>
-          </p:cNvSpPr>
-          <p:nvPr/>
-        </p:nvSpPr>
-        <p:spPr>
-          <a:xfrm xmlns:a="http://schemas.openxmlformats.org/drawingml/2006/main">
-            <a:off x="2114550" y="2743200"/>
+          <p:cNvPr id="9" name="text-210-288">
+            <a:extLst xmlns:a="http://schemas.openxmlformats.org/drawingml/2006/main">
+              <a:ext uri="{FF2B5EF4-FFF2-40B4-BE49-F238E27FC236}">
+                <a16:creationId xmlns:a16="http://schemas.microsoft.com/office/drawing/2014/main" id="{531239B7-33CE-46A6-980A-469BB610B91E}"/>
+              </a:ext>
+            </a:extLst>
+          </p:cNvPr>
+          <p:cNvSpPr>
+            <a:spLocks xmlns:a="http://schemas.openxmlformats.org/drawingml/2006/main" noGrp="1"/>
+          </p:cNvSpPr>
+          <p:nvPr/>
+        </p:nvSpPr>
+        <p:spPr>
+          <a:xfrm xmlns:a="http://schemas.openxmlformats.org/drawingml/2006/main">
+            <a:off x="2000250" y="2743200"/>
             <a:ext cx="685800" cy="209550"/>
           </a:xfrm>
           <a:prstGeom xmlns:a="http://schemas.openxmlformats.org/drawingml/2006/main" prst="rect">
@@ -9141,21 +9141,21 @@
       </p:sp>
       <p:sp>
         <p:nvSpPr>
-          <p:cNvPr id="10" name="text-310-288">
-            <a:extLst xmlns:a="http://schemas.openxmlformats.org/drawingml/2006/main">
-              <a:ext uri="{FF2B5EF4-FFF2-40B4-BE49-F238E27FC236}">
-                <a16:creationId xmlns:a16="http://schemas.microsoft.com/office/drawing/2014/main" id="{D5BBAE3B-D8C4-45E9-8E49-256E22CEFC44}"/>
-              </a:ext>
-            </a:extLst>
-          </p:cNvPr>
-          <p:cNvSpPr>
-            <a:spLocks xmlns:a="http://schemas.openxmlformats.org/drawingml/2006/main" noGrp="1"/>
-          </p:cNvSpPr>
-          <p:nvPr/>
-        </p:nvSpPr>
-        <p:spPr>
-          <a:xfrm xmlns:a="http://schemas.openxmlformats.org/drawingml/2006/main">
-            <a:off x="2952750" y="2743200"/>
+          <p:cNvPr id="10" name="text-298-288">
+            <a:extLst xmlns:a="http://schemas.openxmlformats.org/drawingml/2006/main">
+              <a:ext uri="{FF2B5EF4-FFF2-40B4-BE49-F238E27FC236}">
+                <a16:creationId xmlns:a16="http://schemas.microsoft.com/office/drawing/2014/main" id="{853C4A39-FFB6-4E66-B04B-1D00771D1C8C}"/>
+              </a:ext>
+            </a:extLst>
+          </p:cNvPr>
+          <p:cNvSpPr>
+            <a:spLocks xmlns:a="http://schemas.openxmlformats.org/drawingml/2006/main" noGrp="1"/>
+          </p:cNvSpPr>
+          <p:nvPr/>
+        </p:nvSpPr>
+        <p:spPr>
+          <a:xfrm xmlns:a="http://schemas.openxmlformats.org/drawingml/2006/main">
+            <a:off x="2838450" y="2743200"/>
             <a:ext cx="628650" cy="209550"/>
           </a:xfrm>
           <a:prstGeom xmlns:a="http://schemas.openxmlformats.org/drawingml/2006/main" prst="rect">
@@ -9199,22 +9199,22 @@
       </p:sp>
       <p:sp>
         <p:nvSpPr>
-          <p:cNvPr id="11" name="text-392-288">
-            <a:extLst xmlns:a="http://schemas.openxmlformats.org/drawingml/2006/main">
-              <a:ext uri="{FF2B5EF4-FFF2-40B4-BE49-F238E27FC236}">
-                <a16:creationId xmlns:a16="http://schemas.microsoft.com/office/drawing/2014/main" id="{332A8004-35EB-4880-8E2C-6A04B8FD4283}"/>
-              </a:ext>
-            </a:extLst>
-          </p:cNvPr>
-          <p:cNvSpPr>
-            <a:spLocks xmlns:a="http://schemas.openxmlformats.org/drawingml/2006/main" noGrp="1"/>
-          </p:cNvSpPr>
-          <p:nvPr/>
-        </p:nvSpPr>
-        <p:spPr>
-          <a:xfrm xmlns:a="http://schemas.openxmlformats.org/drawingml/2006/main">
-            <a:off x="3733800" y="2743200"/>
-            <a:ext cx="400050" cy="209550"/>
+          <p:cNvPr id="11" name="text-380-288">
+            <a:extLst xmlns:a="http://schemas.openxmlformats.org/drawingml/2006/main">
+              <a:ext uri="{FF2B5EF4-FFF2-40B4-BE49-F238E27FC236}">
+                <a16:creationId xmlns:a16="http://schemas.microsoft.com/office/drawing/2014/main" id="{7F335500-D074-4F56-92A4-F5A1E54DAF8B}"/>
+              </a:ext>
+            </a:extLst>
+          </p:cNvPr>
+          <p:cNvSpPr>
+            <a:spLocks xmlns:a="http://schemas.openxmlformats.org/drawingml/2006/main" noGrp="1"/>
+          </p:cNvSpPr>
+          <p:nvPr/>
+        </p:nvSpPr>
+        <p:spPr>
+          <a:xfrm xmlns:a="http://schemas.openxmlformats.org/drawingml/2006/main">
+            <a:off x="3619500" y="2743200"/>
+            <a:ext cx="533400" cy="209550"/>
           </a:xfrm>
           <a:prstGeom xmlns:a="http://schemas.openxmlformats.org/drawingml/2006/main" prst="rect">
             <a:avLst/>
@@ -9257,22 +9257,22 @@
       </p:sp>
       <p:sp>
         <p:nvSpPr>
-          <p:cNvPr id="12" name="text-450-288">
-            <a:extLst xmlns:a="http://schemas.openxmlformats.org/drawingml/2006/main">
-              <a:ext uri="{FF2B5EF4-FFF2-40B4-BE49-F238E27FC236}">
-                <a16:creationId xmlns:a16="http://schemas.microsoft.com/office/drawing/2014/main" id="{4816A46F-E207-4865-B06A-6202B896E5B6}"/>
-              </a:ext>
-            </a:extLst>
-          </p:cNvPr>
-          <p:cNvSpPr>
-            <a:spLocks xmlns:a="http://schemas.openxmlformats.org/drawingml/2006/main" noGrp="1"/>
-          </p:cNvSpPr>
-          <p:nvPr/>
-        </p:nvSpPr>
-        <p:spPr>
-          <a:xfrm xmlns:a="http://schemas.openxmlformats.org/drawingml/2006/main">
-            <a:off x="4286250" y="2743200"/>
-            <a:ext cx="971550" cy="209550"/>
+          <p:cNvPr id="12" name="text-452-288">
+            <a:extLst xmlns:a="http://schemas.openxmlformats.org/drawingml/2006/main">
+              <a:ext uri="{FF2B5EF4-FFF2-40B4-BE49-F238E27FC236}">
+                <a16:creationId xmlns:a16="http://schemas.microsoft.com/office/drawing/2014/main" id="{FF867964-5209-487F-ADE2-6C83290802A9}"/>
+              </a:ext>
+            </a:extLst>
+          </p:cNvPr>
+          <p:cNvSpPr>
+            <a:spLocks xmlns:a="http://schemas.openxmlformats.org/drawingml/2006/main" noGrp="1"/>
+          </p:cNvSpPr>
+          <p:nvPr/>
+        </p:nvSpPr>
+        <p:spPr>
+          <a:xfrm xmlns:a="http://schemas.openxmlformats.org/drawingml/2006/main">
+            <a:off x="4305300" y="2743200"/>
+            <a:ext cx="952500" cy="209550"/>
           </a:xfrm>
           <a:prstGeom xmlns:a="http://schemas.openxmlformats.org/drawingml/2006/main" prst="rect">
             <a:avLst/>
@@ -9318,7 +9318,7 @@
           <p:cNvPr id="13" name="model-table-row-278-0">
             <a:extLst xmlns:a="http://schemas.openxmlformats.org/drawingml/2006/main">
               <a:ext uri="{FF2B5EF4-FFF2-40B4-BE49-F238E27FC236}">
-                <a16:creationId xmlns:a16="http://schemas.microsoft.com/office/drawing/2014/main" id="{569DD01D-8BBF-4DBE-BC91-0F69D60A2963}"/>
+                <a16:creationId xmlns:a16="http://schemas.microsoft.com/office/drawing/2014/main" id="{82E1DCAC-FF25-4E5E-AB23-166BAF89661C}"/>
               </a:ext>
             </a:extLst>
           </p:cNvPr>
@@ -9371,7 +9371,7 @@
           <p:cNvPr id="15" name="text-50-330">
             <a:extLst xmlns:a="http://schemas.openxmlformats.org/drawingml/2006/main">
               <a:ext uri="{FF2B5EF4-FFF2-40B4-BE49-F238E27FC236}">
-                <a16:creationId xmlns:a16="http://schemas.microsoft.com/office/drawing/2014/main" id="{DC20FF63-F485-4688-A994-D1EBFA1BF95A}"/>
+                <a16:creationId xmlns:a16="http://schemas.microsoft.com/office/drawing/2014/main" id="{281114EB-1A20-445D-A70A-C5AE41F4A436}"/>
               </a:ext>
             </a:extLst>
           </p:cNvPr>
@@ -9383,7 +9383,7 @@
         <p:spPr>
           <a:xfrm xmlns:a="http://schemas.openxmlformats.org/drawingml/2006/main">
             <a:off x="476250" y="3143250"/>
-            <a:ext cx="1485900" cy="219075"/>
+            <a:ext cx="1371600" cy="219075"/>
           </a:xfrm>
           <a:prstGeom xmlns:a="http://schemas.openxmlformats.org/drawingml/2006/main" prst="rect">
             <a:avLst/>
@@ -9426,21 +9426,21 @@
       </p:sp>
       <p:sp>
         <p:nvSpPr>
-          <p:cNvPr id="16" name="text-222-330">
-            <a:extLst xmlns:a="http://schemas.openxmlformats.org/drawingml/2006/main">
-              <a:ext uri="{FF2B5EF4-FFF2-40B4-BE49-F238E27FC236}">
-                <a16:creationId xmlns:a16="http://schemas.microsoft.com/office/drawing/2014/main" id="{2E8AF447-3550-4216-841A-5B84B32B162A}"/>
-              </a:ext>
-            </a:extLst>
-          </p:cNvPr>
-          <p:cNvSpPr>
-            <a:spLocks xmlns:a="http://schemas.openxmlformats.org/drawingml/2006/main" noGrp="1"/>
-          </p:cNvSpPr>
-          <p:nvPr/>
-        </p:nvSpPr>
-        <p:spPr>
-          <a:xfrm xmlns:a="http://schemas.openxmlformats.org/drawingml/2006/main">
-            <a:off x="2114550" y="3143250"/>
+          <p:cNvPr id="16" name="text-210-330">
+            <a:extLst xmlns:a="http://schemas.openxmlformats.org/drawingml/2006/main">
+              <a:ext uri="{FF2B5EF4-FFF2-40B4-BE49-F238E27FC236}">
+                <a16:creationId xmlns:a16="http://schemas.microsoft.com/office/drawing/2014/main" id="{89E1D0D0-0457-4B93-94D4-6681D078F1B1}"/>
+              </a:ext>
+            </a:extLst>
+          </p:cNvPr>
+          <p:cNvSpPr>
+            <a:spLocks xmlns:a="http://schemas.openxmlformats.org/drawingml/2006/main" noGrp="1"/>
+          </p:cNvSpPr>
+          <p:nvPr/>
+        </p:nvSpPr>
+        <p:spPr>
+          <a:xfrm xmlns:a="http://schemas.openxmlformats.org/drawingml/2006/main">
+            <a:off x="2000250" y="3143250"/>
             <a:ext cx="685800" cy="219075"/>
           </a:xfrm>
           <a:prstGeom xmlns:a="http://schemas.openxmlformats.org/drawingml/2006/main" prst="rect">
@@ -9484,21 +9484,21 @@
       </p:sp>
       <p:sp>
         <p:nvSpPr>
-          <p:cNvPr id="17" name="text-310-330">
-            <a:extLst xmlns:a="http://schemas.openxmlformats.org/drawingml/2006/main">
-              <a:ext uri="{FF2B5EF4-FFF2-40B4-BE49-F238E27FC236}">
-                <a16:creationId xmlns:a16="http://schemas.microsoft.com/office/drawing/2014/main" id="{6CDFC17D-AFC3-4E93-A408-1CDE515F64BC}"/>
-              </a:ext>
-            </a:extLst>
-          </p:cNvPr>
-          <p:cNvSpPr>
-            <a:spLocks xmlns:a="http://schemas.openxmlformats.org/drawingml/2006/main" noGrp="1"/>
-          </p:cNvSpPr>
-          <p:nvPr/>
-        </p:nvSpPr>
-        <p:spPr>
-          <a:xfrm xmlns:a="http://schemas.openxmlformats.org/drawingml/2006/main">
-            <a:off x="2952750" y="3143250"/>
+          <p:cNvPr id="17" name="text-298-330">
+            <a:extLst xmlns:a="http://schemas.openxmlformats.org/drawingml/2006/main">
+              <a:ext uri="{FF2B5EF4-FFF2-40B4-BE49-F238E27FC236}">
+                <a16:creationId xmlns:a16="http://schemas.microsoft.com/office/drawing/2014/main" id="{2D0EA35F-5A39-4734-8EC1-EF10A4E90FE3}"/>
+              </a:ext>
+            </a:extLst>
+          </p:cNvPr>
+          <p:cNvSpPr>
+            <a:spLocks xmlns:a="http://schemas.openxmlformats.org/drawingml/2006/main" noGrp="1"/>
+          </p:cNvSpPr>
+          <p:nvPr/>
+        </p:nvSpPr>
+        <p:spPr>
+          <a:xfrm xmlns:a="http://schemas.openxmlformats.org/drawingml/2006/main">
+            <a:off x="2838450" y="3143250"/>
             <a:ext cx="628650" cy="219075"/>
           </a:xfrm>
           <a:prstGeom xmlns:a="http://schemas.openxmlformats.org/drawingml/2006/main" prst="rect">
@@ -9542,22 +9542,22 @@
       </p:sp>
       <p:sp>
         <p:nvSpPr>
-          <p:cNvPr id="18" name="text-392-330">
-            <a:extLst xmlns:a="http://schemas.openxmlformats.org/drawingml/2006/main">
-              <a:ext uri="{FF2B5EF4-FFF2-40B4-BE49-F238E27FC236}">
-                <a16:creationId xmlns:a16="http://schemas.microsoft.com/office/drawing/2014/main" id="{D5D9C3D5-6A84-46A0-B71A-7DC591D0B041}"/>
-              </a:ext>
-            </a:extLst>
-          </p:cNvPr>
-          <p:cNvSpPr>
-            <a:spLocks xmlns:a="http://schemas.openxmlformats.org/drawingml/2006/main" noGrp="1"/>
-          </p:cNvSpPr>
-          <p:nvPr/>
-        </p:nvSpPr>
-        <p:spPr>
-          <a:xfrm xmlns:a="http://schemas.openxmlformats.org/drawingml/2006/main">
-            <a:off x="3733800" y="3143250"/>
-            <a:ext cx="400050" cy="219075"/>
+          <p:cNvPr id="18" name="text-380-330">
+            <a:extLst xmlns:a="http://schemas.openxmlformats.org/drawingml/2006/main">
+              <a:ext uri="{FF2B5EF4-FFF2-40B4-BE49-F238E27FC236}">
+                <a16:creationId xmlns:a16="http://schemas.microsoft.com/office/drawing/2014/main" id="{89D42C6A-6565-4FD7-8305-A0B463582B71}"/>
+              </a:ext>
+            </a:extLst>
+          </p:cNvPr>
+          <p:cNvSpPr>
+            <a:spLocks xmlns:a="http://schemas.openxmlformats.org/drawingml/2006/main" noGrp="1"/>
+          </p:cNvSpPr>
+          <p:nvPr/>
+        </p:nvSpPr>
+        <p:spPr>
+          <a:xfrm xmlns:a="http://schemas.openxmlformats.org/drawingml/2006/main">
+            <a:off x="3619500" y="3143250"/>
+            <a:ext cx="533400" cy="219075"/>
           </a:xfrm>
           <a:prstGeom xmlns:a="http://schemas.openxmlformats.org/drawingml/2006/main" prst="rect">
             <a:avLst/>
@@ -9600,22 +9600,22 @@
       </p:sp>
       <p:sp>
         <p:nvSpPr>
-          <p:cNvPr id="19" name="text-450-330">
-            <a:extLst xmlns:a="http://schemas.openxmlformats.org/drawingml/2006/main">
-              <a:ext uri="{FF2B5EF4-FFF2-40B4-BE49-F238E27FC236}">
-                <a16:creationId xmlns:a16="http://schemas.microsoft.com/office/drawing/2014/main" id="{55D120FB-2109-44C2-B905-3F56164777EB}"/>
-              </a:ext>
-            </a:extLst>
-          </p:cNvPr>
-          <p:cNvSpPr>
-            <a:spLocks xmlns:a="http://schemas.openxmlformats.org/drawingml/2006/main" noGrp="1"/>
-          </p:cNvSpPr>
-          <p:nvPr/>
-        </p:nvSpPr>
-        <p:spPr>
-          <a:xfrm xmlns:a="http://schemas.openxmlformats.org/drawingml/2006/main">
-            <a:off x="4286250" y="3143250"/>
-            <a:ext cx="971550" cy="219075"/>
+          <p:cNvPr id="19" name="text-452-330">
+            <a:extLst xmlns:a="http://schemas.openxmlformats.org/drawingml/2006/main">
+              <a:ext uri="{FF2B5EF4-FFF2-40B4-BE49-F238E27FC236}">
+                <a16:creationId xmlns:a16="http://schemas.microsoft.com/office/drawing/2014/main" id="{73D49CC4-998D-467B-9941-0F29FA8D9883}"/>
+              </a:ext>
+            </a:extLst>
+          </p:cNvPr>
+          <p:cNvSpPr>
+            <a:spLocks xmlns:a="http://schemas.openxmlformats.org/drawingml/2006/main" noGrp="1"/>
+          </p:cNvSpPr>
+          <p:nvPr/>
+        </p:nvSpPr>
+        <p:spPr>
+          <a:xfrm xmlns:a="http://schemas.openxmlformats.org/drawingml/2006/main">
+            <a:off x="4305300" y="3143250"/>
+            <a:ext cx="952500" cy="219075"/>
           </a:xfrm>
           <a:prstGeom xmlns:a="http://schemas.openxmlformats.org/drawingml/2006/main" prst="rect">
             <a:avLst/>
@@ -9661,7 +9661,7 @@
           <p:cNvPr id="20" name="model-table-row-278-1">
             <a:extLst xmlns:a="http://schemas.openxmlformats.org/drawingml/2006/main">
               <a:ext uri="{FF2B5EF4-FFF2-40B4-BE49-F238E27FC236}">
-                <a16:creationId xmlns:a16="http://schemas.microsoft.com/office/drawing/2014/main" id="{0621C609-D878-47C0-9785-966798D6E067}"/>
+                <a16:creationId xmlns:a16="http://schemas.microsoft.com/office/drawing/2014/main" id="{021ABF55-AE52-41F0-961C-FD48A0A33541}"/>
               </a:ext>
             </a:extLst>
           </p:cNvPr>
@@ -9714,7 +9714,7 @@
           <p:cNvPr id="22" name="text-50-373">
             <a:extLst xmlns:a="http://schemas.openxmlformats.org/drawingml/2006/main">
               <a:ext uri="{FF2B5EF4-FFF2-40B4-BE49-F238E27FC236}">
-                <a16:creationId xmlns:a16="http://schemas.microsoft.com/office/drawing/2014/main" id="{0C1D3319-493A-49AD-BCAB-05A1F36C6E68}"/>
+                <a16:creationId xmlns:a16="http://schemas.microsoft.com/office/drawing/2014/main" id="{9AA8FFBA-98AB-4C41-9B25-6E767016309E}"/>
               </a:ext>
             </a:extLst>
           </p:cNvPr>
@@ -9726,7 +9726,7 @@
         <p:spPr>
           <a:xfrm xmlns:a="http://schemas.openxmlformats.org/drawingml/2006/main">
             <a:off x="476250" y="3552825"/>
-            <a:ext cx="1485900" cy="219075"/>
+            <a:ext cx="1371600" cy="219075"/>
           </a:xfrm>
           <a:prstGeom xmlns:a="http://schemas.openxmlformats.org/drawingml/2006/main" prst="rect">
             <a:avLst/>
@@ -9762,28 +9762,28 @@
                 <a:ea typeface="Helvetica Neue"/>
                 <a:cs typeface="Helvetica Neue"/>
               </a:rPr>
-              <a:t>Linear regression</a:t>
-            </a:r>
-          </a:p>
-        </p:txBody>
-      </p:sp>
-      <p:sp>
-        <p:nvSpPr>
-          <p:cNvPr id="23" name="text-222-373">
-            <a:extLst xmlns:a="http://schemas.openxmlformats.org/drawingml/2006/main">
-              <a:ext uri="{FF2B5EF4-FFF2-40B4-BE49-F238E27FC236}">
-                <a16:creationId xmlns:a16="http://schemas.microsoft.com/office/drawing/2014/main" id="{383CB6C2-53B1-4819-9863-857039836B4A}"/>
-              </a:ext>
-            </a:extLst>
-          </p:cNvPr>
-          <p:cNvSpPr>
-            <a:spLocks xmlns:a="http://schemas.openxmlformats.org/drawingml/2006/main" noGrp="1"/>
-          </p:cNvSpPr>
-          <p:nvPr/>
-        </p:nvSpPr>
-        <p:spPr>
-          <a:xfrm xmlns:a="http://schemas.openxmlformats.org/drawingml/2006/main">
-            <a:off x="2114550" y="3552825"/>
+              <a:t>Checkpoint linear</a:t>
+            </a:r>
+          </a:p>
+        </p:txBody>
+      </p:sp>
+      <p:sp>
+        <p:nvSpPr>
+          <p:cNvPr id="23" name="text-210-373">
+            <a:extLst xmlns:a="http://schemas.openxmlformats.org/drawingml/2006/main">
+              <a:ext uri="{FF2B5EF4-FFF2-40B4-BE49-F238E27FC236}">
+                <a16:creationId xmlns:a16="http://schemas.microsoft.com/office/drawing/2014/main" id="{187F10C8-6107-4E63-9FA8-A4A33E40BF3B}"/>
+              </a:ext>
+            </a:extLst>
+          </p:cNvPr>
+          <p:cNvSpPr>
+            <a:spLocks xmlns:a="http://schemas.openxmlformats.org/drawingml/2006/main" noGrp="1"/>
+          </p:cNvSpPr>
+          <p:nvPr/>
+        </p:nvSpPr>
+        <p:spPr>
+          <a:xfrm xmlns:a="http://schemas.openxmlformats.org/drawingml/2006/main">
+            <a:off x="2000250" y="3552825"/>
             <a:ext cx="685800" cy="219075"/>
           </a:xfrm>
           <a:prstGeom xmlns:a="http://schemas.openxmlformats.org/drawingml/2006/main" prst="rect">
@@ -9820,28 +9820,28 @@
                 <a:ea typeface="Helvetica Neue"/>
                 <a:cs typeface="Helvetica Neue"/>
               </a:rPr>
-              <a:t>209 g</a:t>
-            </a:r>
-          </a:p>
-        </p:txBody>
-      </p:sp>
-      <p:sp>
-        <p:nvSpPr>
-          <p:cNvPr id="24" name="text-310-373">
-            <a:extLst xmlns:a="http://schemas.openxmlformats.org/drawingml/2006/main">
-              <a:ext uri="{FF2B5EF4-FFF2-40B4-BE49-F238E27FC236}">
-                <a16:creationId xmlns:a16="http://schemas.microsoft.com/office/drawing/2014/main" id="{4E3E1E9F-0F8D-4094-967D-17EDCD120AE8}"/>
-              </a:ext>
-            </a:extLst>
-          </p:cNvPr>
-          <p:cNvSpPr>
-            <a:spLocks xmlns:a="http://schemas.openxmlformats.org/drawingml/2006/main" noGrp="1"/>
-          </p:cNvSpPr>
-          <p:nvPr/>
-        </p:nvSpPr>
-        <p:spPr>
-          <a:xfrm xmlns:a="http://schemas.openxmlformats.org/drawingml/2006/main">
-            <a:off x="2952750" y="3552825"/>
+              <a:t>208 g</a:t>
+            </a:r>
+          </a:p>
+        </p:txBody>
+      </p:sp>
+      <p:sp>
+        <p:nvSpPr>
+          <p:cNvPr id="24" name="text-298-373">
+            <a:extLst xmlns:a="http://schemas.openxmlformats.org/drawingml/2006/main">
+              <a:ext uri="{FF2B5EF4-FFF2-40B4-BE49-F238E27FC236}">
+                <a16:creationId xmlns:a16="http://schemas.microsoft.com/office/drawing/2014/main" id="{C742929E-1BBE-4F80-BBD7-885C7B13E814}"/>
+              </a:ext>
+            </a:extLst>
+          </p:cNvPr>
+          <p:cNvSpPr>
+            <a:spLocks xmlns:a="http://schemas.openxmlformats.org/drawingml/2006/main" noGrp="1"/>
+          </p:cNvSpPr>
+          <p:nvPr/>
+        </p:nvSpPr>
+        <p:spPr>
+          <a:xfrm xmlns:a="http://schemas.openxmlformats.org/drawingml/2006/main">
+            <a:off x="2838450" y="3552825"/>
             <a:ext cx="628650" cy="219075"/>
           </a:xfrm>
           <a:prstGeom xmlns:a="http://schemas.openxmlformats.org/drawingml/2006/main" prst="rect">
@@ -9885,35 +9885,35 @@
       </p:sp>
       <p:sp>
         <p:nvSpPr>
-          <p:cNvPr id="25" name="text-392-373">
-            <a:extLst xmlns:a="http://schemas.openxmlformats.org/drawingml/2006/main">
-              <a:ext uri="{FF2B5EF4-FFF2-40B4-BE49-F238E27FC236}">
-                <a16:creationId xmlns:a16="http://schemas.microsoft.com/office/drawing/2014/main" id="{D164B9E7-8AD3-476E-A059-10CE4C3032C6}"/>
-              </a:ext>
-            </a:extLst>
-          </p:cNvPr>
-          <p:cNvSpPr>
-            <a:spLocks xmlns:a="http://schemas.openxmlformats.org/drawingml/2006/main" noGrp="1"/>
-          </p:cNvSpPr>
-          <p:nvPr/>
-        </p:nvSpPr>
-        <p:spPr>
-          <a:xfrm xmlns:a="http://schemas.openxmlformats.org/drawingml/2006/main">
-            <a:off x="3733800" y="3552825"/>
-            <a:ext cx="400050" cy="219075"/>
-          </a:xfrm>
-          <a:prstGeom xmlns:a="http://schemas.openxmlformats.org/drawingml/2006/main" prst="rect">
-            <a:avLst/>
-          </a:prstGeom>
-          <a:noFill xmlns:a="http://schemas.openxmlformats.org/drawingml/2006/main"/>
-          <a:ln xmlns:a="http://schemas.openxmlformats.org/drawingml/2006/main" w="0">
-            <a:noFill/>
-            <a:prstDash val="solid"/>
-          </a:ln>
-        </p:spPr>
-        <p:txBody>
-          <a:bodyPr xmlns:a="http://schemas.openxmlformats.org/drawingml/2006/main" wrap="square" lIns="0" tIns="0" rIns="0" bIns="0" anchor="t">
-            <a:normAutofit fontScale="97411"/>
+          <p:cNvPr id="25" name="text-380-373">
+            <a:extLst xmlns:a="http://schemas.openxmlformats.org/drawingml/2006/main">
+              <a:ext uri="{FF2B5EF4-FFF2-40B4-BE49-F238E27FC236}">
+                <a16:creationId xmlns:a16="http://schemas.microsoft.com/office/drawing/2014/main" id="{EC6DB04A-8E04-4555-8F8C-A2B8FBB2ECFD}"/>
+              </a:ext>
+            </a:extLst>
+          </p:cNvPr>
+          <p:cNvSpPr>
+            <a:spLocks xmlns:a="http://schemas.openxmlformats.org/drawingml/2006/main" noGrp="1"/>
+          </p:cNvSpPr>
+          <p:nvPr/>
+        </p:nvSpPr>
+        <p:spPr>
+          <a:xfrm xmlns:a="http://schemas.openxmlformats.org/drawingml/2006/main">
+            <a:off x="3619500" y="3552825"/>
+            <a:ext cx="533400" cy="219075"/>
+          </a:xfrm>
+          <a:prstGeom xmlns:a="http://schemas.openxmlformats.org/drawingml/2006/main" prst="rect">
+            <a:avLst/>
+          </a:prstGeom>
+          <a:noFill xmlns:a="http://schemas.openxmlformats.org/drawingml/2006/main"/>
+          <a:ln xmlns:a="http://schemas.openxmlformats.org/drawingml/2006/main" w="0">
+            <a:noFill/>
+            <a:prstDash val="solid"/>
+          </a:ln>
+        </p:spPr>
+        <p:txBody>
+          <a:bodyPr xmlns:a="http://schemas.openxmlformats.org/drawingml/2006/main" wrap="square" lIns="0" tIns="0" rIns="0" bIns="0" anchor="t">
+            <a:normAutofit fontScale="100000"/>
           </a:bodyPr>
           <a:lstStyle xmlns:a="http://schemas.openxmlformats.org/drawingml/2006/main"/>
           <a:p xmlns:a="http://schemas.openxmlformats.org/drawingml/2006/main">
@@ -9936,29 +9936,29 @@
                 <a:ea typeface="Helvetica Neue"/>
                 <a:cs typeface="Helvetica Neue"/>
               </a:rPr>
-              <a:t>−0.114</a:t>
-            </a:r>
-          </a:p>
-        </p:txBody>
-      </p:sp>
-      <p:sp>
-        <p:nvSpPr>
-          <p:cNvPr id="26" name="text-450-373">
-            <a:extLst xmlns:a="http://schemas.openxmlformats.org/drawingml/2006/main">
-              <a:ext uri="{FF2B5EF4-FFF2-40B4-BE49-F238E27FC236}">
-                <a16:creationId xmlns:a16="http://schemas.microsoft.com/office/drawing/2014/main" id="{687C9BC6-1D94-4926-A0AA-B1BC1003B389}"/>
-              </a:ext>
-            </a:extLst>
-          </p:cNvPr>
-          <p:cNvSpPr>
-            <a:spLocks xmlns:a="http://schemas.openxmlformats.org/drawingml/2006/main" noGrp="1"/>
-          </p:cNvSpPr>
-          <p:nvPr/>
-        </p:nvSpPr>
-        <p:spPr>
-          <a:xfrm xmlns:a="http://schemas.openxmlformats.org/drawingml/2006/main">
-            <a:off x="4286250" y="3552825"/>
-            <a:ext cx="971550" cy="219075"/>
+              <a:t>−0.118</a:t>
+            </a:r>
+          </a:p>
+        </p:txBody>
+      </p:sp>
+      <p:sp>
+        <p:nvSpPr>
+          <p:cNvPr id="26" name="text-452-373">
+            <a:extLst xmlns:a="http://schemas.openxmlformats.org/drawingml/2006/main">
+              <a:ext uri="{FF2B5EF4-FFF2-40B4-BE49-F238E27FC236}">
+                <a16:creationId xmlns:a16="http://schemas.microsoft.com/office/drawing/2014/main" id="{28923B13-A5A8-42BD-9ADA-644903062E61}"/>
+              </a:ext>
+            </a:extLst>
+          </p:cNvPr>
+          <p:cNvSpPr>
+            <a:spLocks xmlns:a="http://schemas.openxmlformats.org/drawingml/2006/main" noGrp="1"/>
+          </p:cNvSpPr>
+          <p:nvPr/>
+        </p:nvSpPr>
+        <p:spPr>
+          <a:xfrm xmlns:a="http://schemas.openxmlformats.org/drawingml/2006/main">
+            <a:off x="4305300" y="3552825"/>
+            <a:ext cx="952500" cy="219075"/>
           </a:xfrm>
           <a:prstGeom xmlns:a="http://schemas.openxmlformats.org/drawingml/2006/main" prst="rect">
             <a:avLst/>
@@ -10004,7 +10004,7 @@
           <p:cNvPr id="27" name="model-table-row-278-2">
             <a:extLst xmlns:a="http://schemas.openxmlformats.org/drawingml/2006/main">
               <a:ext uri="{FF2B5EF4-FFF2-40B4-BE49-F238E27FC236}">
-                <a16:creationId xmlns:a16="http://schemas.microsoft.com/office/drawing/2014/main" id="{0E8E9951-71F8-42F3-8099-1288A38C63FD}"/>
+                <a16:creationId xmlns:a16="http://schemas.microsoft.com/office/drawing/2014/main" id="{C848B679-0051-4D48-BE21-E49C9B31E3CF}"/>
               </a:ext>
             </a:extLst>
           </p:cNvPr>
@@ -10057,7 +10057,7 @@
           <p:cNvPr id="29" name="text-50-416">
             <a:extLst xmlns:a="http://schemas.openxmlformats.org/drawingml/2006/main">
               <a:ext uri="{FF2B5EF4-FFF2-40B4-BE49-F238E27FC236}">
-                <a16:creationId xmlns:a16="http://schemas.microsoft.com/office/drawing/2014/main" id="{FA07B4BE-FAC8-4B56-8045-030F0C325251}"/>
+                <a16:creationId xmlns:a16="http://schemas.microsoft.com/office/drawing/2014/main" id="{CBCF4C4D-C83E-4963-B823-38E9157962B8}"/>
               </a:ext>
             </a:extLst>
           </p:cNvPr>
@@ -10069,7 +10069,7 @@
         <p:spPr>
           <a:xfrm xmlns:a="http://schemas.openxmlformats.org/drawingml/2006/main">
             <a:off x="476250" y="3962400"/>
-            <a:ext cx="1485900" cy="219075"/>
+            <a:ext cx="1371600" cy="219075"/>
           </a:xfrm>
           <a:prstGeom xmlns:a="http://schemas.openxmlformats.org/drawingml/2006/main" prst="rect">
             <a:avLst/>
@@ -10105,28 +10105,28 @@
                 <a:ea typeface="Helvetica Neue"/>
                 <a:cs typeface="Helvetica Neue"/>
               </a:rPr>
-              <a:t>Ridge regression</a:t>
-            </a:r>
-          </a:p>
-        </p:txBody>
-      </p:sp>
-      <p:sp>
-        <p:nvSpPr>
-          <p:cNvPr id="30" name="text-222-416">
-            <a:extLst xmlns:a="http://schemas.openxmlformats.org/drawingml/2006/main">
-              <a:ext uri="{FF2B5EF4-FFF2-40B4-BE49-F238E27FC236}">
-                <a16:creationId xmlns:a16="http://schemas.microsoft.com/office/drawing/2014/main" id="{DF8B5663-D6C2-463F-9359-E50B98070299}"/>
-              </a:ext>
-            </a:extLst>
-          </p:cNvPr>
-          <p:cNvSpPr>
-            <a:spLocks xmlns:a="http://schemas.openxmlformats.org/drawingml/2006/main" noGrp="1"/>
-          </p:cNvSpPr>
-          <p:nvPr/>
-        </p:nvSpPr>
-        <p:spPr>
-          <a:xfrm xmlns:a="http://schemas.openxmlformats.org/drawingml/2006/main">
-            <a:off x="2114550" y="3962400"/>
+              <a:t>Ridge</a:t>
+            </a:r>
+          </a:p>
+        </p:txBody>
+      </p:sp>
+      <p:sp>
+        <p:nvSpPr>
+          <p:cNvPr id="30" name="text-210-416">
+            <a:extLst xmlns:a="http://schemas.openxmlformats.org/drawingml/2006/main">
+              <a:ext uri="{FF2B5EF4-FFF2-40B4-BE49-F238E27FC236}">
+                <a16:creationId xmlns:a16="http://schemas.microsoft.com/office/drawing/2014/main" id="{746BB3FE-2837-4021-997F-25E5C24D92FD}"/>
+              </a:ext>
+            </a:extLst>
+          </p:cNvPr>
+          <p:cNvSpPr>
+            <a:spLocks xmlns:a="http://schemas.openxmlformats.org/drawingml/2006/main" noGrp="1"/>
+          </p:cNvSpPr>
+          <p:nvPr/>
+        </p:nvSpPr>
+        <p:spPr>
+          <a:xfrm xmlns:a="http://schemas.openxmlformats.org/drawingml/2006/main">
+            <a:off x="2000250" y="3962400"/>
             <a:ext cx="685800" cy="219075"/>
           </a:xfrm>
           <a:prstGeom xmlns:a="http://schemas.openxmlformats.org/drawingml/2006/main" prst="rect">
@@ -10163,28 +10163,28 @@
                 <a:ea typeface="Helvetica Neue"/>
                 <a:cs typeface="Helvetica Neue"/>
               </a:rPr>
-              <a:t>193 g</a:t>
-            </a:r>
-          </a:p>
-        </p:txBody>
-      </p:sp>
-      <p:sp>
-        <p:nvSpPr>
-          <p:cNvPr id="31" name="text-310-416">
-            <a:extLst xmlns:a="http://schemas.openxmlformats.org/drawingml/2006/main">
-              <a:ext uri="{FF2B5EF4-FFF2-40B4-BE49-F238E27FC236}">
-                <a16:creationId xmlns:a16="http://schemas.microsoft.com/office/drawing/2014/main" id="{2917BB75-CB53-423C-BE0A-6EE29AC084ED}"/>
-              </a:ext>
-            </a:extLst>
-          </p:cNvPr>
-          <p:cNvSpPr>
-            <a:spLocks xmlns:a="http://schemas.openxmlformats.org/drawingml/2006/main" noGrp="1"/>
-          </p:cNvSpPr>
-          <p:nvPr/>
-        </p:nvSpPr>
-        <p:spPr>
-          <a:xfrm xmlns:a="http://schemas.openxmlformats.org/drawingml/2006/main">
-            <a:off x="2952750" y="3962400"/>
+              <a:t>200 g</a:t>
+            </a:r>
+          </a:p>
+        </p:txBody>
+      </p:sp>
+      <p:sp>
+        <p:nvSpPr>
+          <p:cNvPr id="31" name="text-298-416">
+            <a:extLst xmlns:a="http://schemas.openxmlformats.org/drawingml/2006/main">
+              <a:ext uri="{FF2B5EF4-FFF2-40B4-BE49-F238E27FC236}">
+                <a16:creationId xmlns:a16="http://schemas.microsoft.com/office/drawing/2014/main" id="{AA6C2901-9C61-41A2-BC98-612D896C41AE}"/>
+              </a:ext>
+            </a:extLst>
+          </p:cNvPr>
+          <p:cNvSpPr>
+            <a:spLocks xmlns:a="http://schemas.openxmlformats.org/drawingml/2006/main" noGrp="1"/>
+          </p:cNvSpPr>
+          <p:nvPr/>
+        </p:nvSpPr>
+        <p:spPr>
+          <a:xfrm xmlns:a="http://schemas.openxmlformats.org/drawingml/2006/main">
+            <a:off x="2838450" y="3962400"/>
             <a:ext cx="628650" cy="219075"/>
           </a:xfrm>
           <a:prstGeom xmlns:a="http://schemas.openxmlformats.org/drawingml/2006/main" prst="rect">
@@ -10221,29 +10221,29 @@
                 <a:ea typeface="Helvetica Neue"/>
                 <a:cs typeface="Helvetica Neue"/>
               </a:rPr>
-              <a:t>252 g</a:t>
-            </a:r>
-          </a:p>
-        </p:txBody>
-      </p:sp>
-      <p:sp>
-        <p:nvSpPr>
-          <p:cNvPr id="32" name="text-392-416">
-            <a:extLst xmlns:a="http://schemas.openxmlformats.org/drawingml/2006/main">
-              <a:ext uri="{FF2B5EF4-FFF2-40B4-BE49-F238E27FC236}">
-                <a16:creationId xmlns:a16="http://schemas.microsoft.com/office/drawing/2014/main" id="{533ADAAF-CC14-44D8-832A-860735F63626}"/>
-              </a:ext>
-            </a:extLst>
-          </p:cNvPr>
-          <p:cNvSpPr>
-            <a:spLocks xmlns:a="http://schemas.openxmlformats.org/drawingml/2006/main" noGrp="1"/>
-          </p:cNvSpPr>
-          <p:nvPr/>
-        </p:nvSpPr>
-        <p:spPr>
-          <a:xfrm xmlns:a="http://schemas.openxmlformats.org/drawingml/2006/main">
-            <a:off x="3733800" y="3962400"/>
-            <a:ext cx="400050" cy="219075"/>
+              <a:t>264 g</a:t>
+            </a:r>
+          </a:p>
+        </p:txBody>
+      </p:sp>
+      <p:sp>
+        <p:nvSpPr>
+          <p:cNvPr id="32" name="text-380-416">
+            <a:extLst xmlns:a="http://schemas.openxmlformats.org/drawingml/2006/main">
+              <a:ext uri="{FF2B5EF4-FFF2-40B4-BE49-F238E27FC236}">
+                <a16:creationId xmlns:a16="http://schemas.microsoft.com/office/drawing/2014/main" id="{90824C64-4465-4835-9C49-22589D42E8E3}"/>
+              </a:ext>
+            </a:extLst>
+          </p:cNvPr>
+          <p:cNvSpPr>
+            <a:spLocks xmlns:a="http://schemas.openxmlformats.org/drawingml/2006/main" noGrp="1"/>
+          </p:cNvSpPr>
+          <p:nvPr/>
+        </p:nvSpPr>
+        <p:spPr>
+          <a:xfrm xmlns:a="http://schemas.openxmlformats.org/drawingml/2006/main">
+            <a:off x="3619500" y="3962400"/>
+            <a:ext cx="533400" cy="219075"/>
           </a:xfrm>
           <a:prstGeom xmlns:a="http://schemas.openxmlformats.org/drawingml/2006/main" prst="rect">
             <a:avLst/>
@@ -10279,29 +10279,29 @@
                 <a:ea typeface="Helvetica Neue"/>
                 <a:cs typeface="Helvetica Neue"/>
               </a:rPr>
-              <a:t>0.048</a:t>
-            </a:r>
-          </a:p>
-        </p:txBody>
-      </p:sp>
-      <p:sp>
-        <p:nvSpPr>
-          <p:cNvPr id="33" name="text-450-416">
-            <a:extLst xmlns:a="http://schemas.openxmlformats.org/drawingml/2006/main">
-              <a:ext uri="{FF2B5EF4-FFF2-40B4-BE49-F238E27FC236}">
-                <a16:creationId xmlns:a16="http://schemas.microsoft.com/office/drawing/2014/main" id="{5719D8E0-E8D7-41DC-890E-D78BF12F591C}"/>
-              </a:ext>
-            </a:extLst>
-          </p:cNvPr>
-          <p:cNvSpPr>
-            <a:spLocks xmlns:a="http://schemas.openxmlformats.org/drawingml/2006/main" noGrp="1"/>
-          </p:cNvSpPr>
-          <p:nvPr/>
-        </p:nvSpPr>
-        <p:spPr>
-          <a:xfrm xmlns:a="http://schemas.openxmlformats.org/drawingml/2006/main">
-            <a:off x="4286250" y="3962400"/>
-            <a:ext cx="971550" cy="219075"/>
+              <a:t>−0.045</a:t>
+            </a:r>
+          </a:p>
+        </p:txBody>
+      </p:sp>
+      <p:sp>
+        <p:nvSpPr>
+          <p:cNvPr id="33" name="text-452-416">
+            <a:extLst xmlns:a="http://schemas.openxmlformats.org/drawingml/2006/main">
+              <a:ext uri="{FF2B5EF4-FFF2-40B4-BE49-F238E27FC236}">
+                <a16:creationId xmlns:a16="http://schemas.microsoft.com/office/drawing/2014/main" id="{058B3BB1-B091-4DEA-A896-0944BB5F0F1F}"/>
+              </a:ext>
+            </a:extLst>
+          </p:cNvPr>
+          <p:cNvSpPr>
+            <a:spLocks xmlns:a="http://schemas.openxmlformats.org/drawingml/2006/main" noGrp="1"/>
+          </p:cNvSpPr>
+          <p:nvPr/>
+        </p:nvSpPr>
+        <p:spPr>
+          <a:xfrm xmlns:a="http://schemas.openxmlformats.org/drawingml/2006/main">
+            <a:off x="4305300" y="3962400"/>
+            <a:ext cx="952500" cy="219075"/>
           </a:xfrm>
           <a:prstGeom xmlns:a="http://schemas.openxmlformats.org/drawingml/2006/main" prst="rect">
             <a:avLst/>
@@ -10337,7 +10337,7 @@
                 <a:ea typeface="Helvetica Neue"/>
                 <a:cs typeface="Helvetica Neue"/>
               </a:rPr>
-              <a:t>Best learned</a:t>
+              <a:t>Compared</a:t>
             </a:r>
           </a:p>
         </p:txBody>
@@ -10347,7 +10347,7 @@
           <p:cNvPr id="34" name="model-table-row-278-3">
             <a:extLst xmlns:a="http://schemas.openxmlformats.org/drawingml/2006/main">
               <a:ext uri="{FF2B5EF4-FFF2-40B4-BE49-F238E27FC236}">
-                <a16:creationId xmlns:a16="http://schemas.microsoft.com/office/drawing/2014/main" id="{4CDA5F7F-B01B-4B62-A3D9-CAD804181389}"/>
+                <a16:creationId xmlns:a16="http://schemas.microsoft.com/office/drawing/2014/main" id="{58C7AF02-5971-4F1C-9D2E-ACEAC0B2C1D3}"/>
               </a:ext>
             </a:extLst>
           </p:cNvPr>
@@ -10400,7 +10400,7 @@
           <p:cNvPr id="36" name="text-50-459">
             <a:extLst xmlns:a="http://schemas.openxmlformats.org/drawingml/2006/main">
               <a:ext uri="{FF2B5EF4-FFF2-40B4-BE49-F238E27FC236}">
-                <a16:creationId xmlns:a16="http://schemas.microsoft.com/office/drawing/2014/main" id="{19CFFC7C-A5F2-444C-A43C-1D04ABCC2FF0}"/>
+                <a16:creationId xmlns:a16="http://schemas.microsoft.com/office/drawing/2014/main" id="{3050CDE9-C6AA-464A-9582-F30F988E6335}"/>
               </a:ext>
             </a:extLst>
           </p:cNvPr>
@@ -10412,7 +10412,7 @@
         <p:spPr>
           <a:xfrm xmlns:a="http://schemas.openxmlformats.org/drawingml/2006/main">
             <a:off x="476250" y="4371975"/>
-            <a:ext cx="1485900" cy="219075"/>
+            <a:ext cx="1371600" cy="219075"/>
           </a:xfrm>
           <a:prstGeom xmlns:a="http://schemas.openxmlformats.org/drawingml/2006/main" prst="rect">
             <a:avLst/>
@@ -10448,28 +10448,28 @@
                 <a:ea typeface="Helvetica Neue"/>
                 <a:cs typeface="Helvetica Neue"/>
               </a:rPr>
-              <a:t>Gradient Boosting</a:t>
-            </a:r>
-          </a:p>
-        </p:txBody>
-      </p:sp>
-      <p:sp>
-        <p:nvSpPr>
-          <p:cNvPr id="37" name="text-222-459">
-            <a:extLst xmlns:a="http://schemas.openxmlformats.org/drawingml/2006/main">
-              <a:ext uri="{FF2B5EF4-FFF2-40B4-BE49-F238E27FC236}">
-                <a16:creationId xmlns:a16="http://schemas.microsoft.com/office/drawing/2014/main" id="{98721DE1-E9E4-417C-B327-DFA9B8A2D275}"/>
-              </a:ext>
-            </a:extLst>
-          </p:cNvPr>
-          <p:cNvSpPr>
-            <a:spLocks xmlns:a="http://schemas.openxmlformats.org/drawingml/2006/main" noGrp="1"/>
-          </p:cNvSpPr>
-          <p:nvPr/>
-        </p:nvSpPr>
-        <p:spPr>
-          <a:xfrm xmlns:a="http://schemas.openxmlformats.org/drawingml/2006/main">
-            <a:off x="2114550" y="4371975"/>
+              <a:t>Robust Huber</a:t>
+            </a:r>
+          </a:p>
+        </p:txBody>
+      </p:sp>
+      <p:sp>
+        <p:nvSpPr>
+          <p:cNvPr id="37" name="text-210-459">
+            <a:extLst xmlns:a="http://schemas.openxmlformats.org/drawingml/2006/main">
+              <a:ext uri="{FF2B5EF4-FFF2-40B4-BE49-F238E27FC236}">
+                <a16:creationId xmlns:a16="http://schemas.microsoft.com/office/drawing/2014/main" id="{1B9C9B63-2051-4D66-B8C0-34C41A3352B3}"/>
+              </a:ext>
+            </a:extLst>
+          </p:cNvPr>
+          <p:cNvSpPr>
+            <a:spLocks xmlns:a="http://schemas.openxmlformats.org/drawingml/2006/main" noGrp="1"/>
+          </p:cNvSpPr>
+          <p:nvPr/>
+        </p:nvSpPr>
+        <p:spPr>
+          <a:xfrm xmlns:a="http://schemas.openxmlformats.org/drawingml/2006/main">
+            <a:off x="2000250" y="4371975"/>
             <a:ext cx="685800" cy="219075"/>
           </a:xfrm>
           <a:prstGeom xmlns:a="http://schemas.openxmlformats.org/drawingml/2006/main" prst="rect">
@@ -10506,28 +10506,28 @@
                 <a:ea typeface="Helvetica Neue"/>
                 <a:cs typeface="Helvetica Neue"/>
               </a:rPr>
-              <a:t>189 g</a:t>
-            </a:r>
-          </a:p>
-        </p:txBody>
-      </p:sp>
-      <p:sp>
-        <p:nvSpPr>
-          <p:cNvPr id="38" name="text-310-459">
-            <a:extLst xmlns:a="http://schemas.openxmlformats.org/drawingml/2006/main">
-              <a:ext uri="{FF2B5EF4-FFF2-40B4-BE49-F238E27FC236}">
-                <a16:creationId xmlns:a16="http://schemas.microsoft.com/office/drawing/2014/main" id="{C28DA12F-EAD3-4188-B8AF-47779AC659BD}"/>
-              </a:ext>
-            </a:extLst>
-          </p:cNvPr>
-          <p:cNvSpPr>
-            <a:spLocks xmlns:a="http://schemas.openxmlformats.org/drawingml/2006/main" noGrp="1"/>
-          </p:cNvSpPr>
-          <p:nvPr/>
-        </p:nvSpPr>
-        <p:spPr>
-          <a:xfrm xmlns:a="http://schemas.openxmlformats.org/drawingml/2006/main">
-            <a:off x="2952750" y="4371975"/>
+              <a:t>223 g</a:t>
+            </a:r>
+          </a:p>
+        </p:txBody>
+      </p:sp>
+      <p:sp>
+        <p:nvSpPr>
+          <p:cNvPr id="38" name="text-298-459">
+            <a:extLst xmlns:a="http://schemas.openxmlformats.org/drawingml/2006/main">
+              <a:ext uri="{FF2B5EF4-FFF2-40B4-BE49-F238E27FC236}">
+                <a16:creationId xmlns:a16="http://schemas.microsoft.com/office/drawing/2014/main" id="{04EBEEC0-7528-4D04-9372-2252F207A967}"/>
+              </a:ext>
+            </a:extLst>
+          </p:cNvPr>
+          <p:cNvSpPr>
+            <a:spLocks xmlns:a="http://schemas.openxmlformats.org/drawingml/2006/main" noGrp="1"/>
+          </p:cNvSpPr>
+          <p:nvPr/>
+        </p:nvSpPr>
+        <p:spPr>
+          <a:xfrm xmlns:a="http://schemas.openxmlformats.org/drawingml/2006/main">
+            <a:off x="2838450" y="4371975"/>
             <a:ext cx="628650" cy="219075"/>
           </a:xfrm>
           <a:prstGeom xmlns:a="http://schemas.openxmlformats.org/drawingml/2006/main" prst="rect">
@@ -10564,29 +10564,29 @@
                 <a:ea typeface="Helvetica Neue"/>
                 <a:cs typeface="Helvetica Neue"/>
               </a:rPr>
-              <a:t>256 g</a:t>
-            </a:r>
-          </a:p>
-        </p:txBody>
-      </p:sp>
-      <p:sp>
-        <p:nvSpPr>
-          <p:cNvPr id="39" name="text-392-459">
-            <a:extLst xmlns:a="http://schemas.openxmlformats.org/drawingml/2006/main">
-              <a:ext uri="{FF2B5EF4-FFF2-40B4-BE49-F238E27FC236}">
-                <a16:creationId xmlns:a16="http://schemas.microsoft.com/office/drawing/2014/main" id="{2C1A5BA7-0173-442F-A092-7BBF93CF9873}"/>
-              </a:ext>
-            </a:extLst>
-          </p:cNvPr>
-          <p:cNvSpPr>
-            <a:spLocks xmlns:a="http://schemas.openxmlformats.org/drawingml/2006/main" noGrp="1"/>
-          </p:cNvSpPr>
-          <p:nvPr/>
-        </p:nvSpPr>
-        <p:spPr>
-          <a:xfrm xmlns:a="http://schemas.openxmlformats.org/drawingml/2006/main">
-            <a:off x="3733800" y="4371975"/>
-            <a:ext cx="400050" cy="219075"/>
+              <a:t>276 g</a:t>
+            </a:r>
+          </a:p>
+        </p:txBody>
+      </p:sp>
+      <p:sp>
+        <p:nvSpPr>
+          <p:cNvPr id="39" name="text-380-459">
+            <a:extLst xmlns:a="http://schemas.openxmlformats.org/drawingml/2006/main">
+              <a:ext uri="{FF2B5EF4-FFF2-40B4-BE49-F238E27FC236}">
+                <a16:creationId xmlns:a16="http://schemas.microsoft.com/office/drawing/2014/main" id="{7EA5FCBA-53C2-43AA-86B7-C9ED5D689D52}"/>
+              </a:ext>
+            </a:extLst>
+          </p:cNvPr>
+          <p:cNvSpPr>
+            <a:spLocks xmlns:a="http://schemas.openxmlformats.org/drawingml/2006/main" noGrp="1"/>
+          </p:cNvSpPr>
+          <p:nvPr/>
+        </p:nvSpPr>
+        <p:spPr>
+          <a:xfrm xmlns:a="http://schemas.openxmlformats.org/drawingml/2006/main">
+            <a:off x="3619500" y="4371975"/>
+            <a:ext cx="533400" cy="219075"/>
           </a:xfrm>
           <a:prstGeom xmlns:a="http://schemas.openxmlformats.org/drawingml/2006/main" prst="rect">
             <a:avLst/>
@@ -10622,29 +10622,29 @@
                 <a:ea typeface="Helvetica Neue"/>
                 <a:cs typeface="Helvetica Neue"/>
               </a:rPr>
-              <a:t>0.018</a:t>
-            </a:r>
-          </a:p>
-        </p:txBody>
-      </p:sp>
-      <p:sp>
-        <p:nvSpPr>
-          <p:cNvPr id="40" name="text-450-459">
-            <a:extLst xmlns:a="http://schemas.openxmlformats.org/drawingml/2006/main">
-              <a:ext uri="{FF2B5EF4-FFF2-40B4-BE49-F238E27FC236}">
-                <a16:creationId xmlns:a16="http://schemas.microsoft.com/office/drawing/2014/main" id="{FDD47ABE-9E50-4DD6-BB19-C1466A172160}"/>
-              </a:ext>
-            </a:extLst>
-          </p:cNvPr>
-          <p:cNvSpPr>
-            <a:spLocks xmlns:a="http://schemas.openxmlformats.org/drawingml/2006/main" noGrp="1"/>
-          </p:cNvSpPr>
-          <p:nvPr/>
-        </p:nvSpPr>
-        <p:spPr>
-          <a:xfrm xmlns:a="http://schemas.openxmlformats.org/drawingml/2006/main">
-            <a:off x="4286250" y="4371975"/>
-            <a:ext cx="971550" cy="219075"/>
+              <a:t>−0.144</a:t>
+            </a:r>
+          </a:p>
+        </p:txBody>
+      </p:sp>
+      <p:sp>
+        <p:nvSpPr>
+          <p:cNvPr id="40" name="text-452-459">
+            <a:extLst xmlns:a="http://schemas.openxmlformats.org/drawingml/2006/main">
+              <a:ext uri="{FF2B5EF4-FFF2-40B4-BE49-F238E27FC236}">
+                <a16:creationId xmlns:a16="http://schemas.microsoft.com/office/drawing/2014/main" id="{49280F14-8CDB-407B-B4FE-0C410932A002}"/>
+              </a:ext>
+            </a:extLst>
+          </p:cNvPr>
+          <p:cNvSpPr>
+            <a:spLocks xmlns:a="http://schemas.openxmlformats.org/drawingml/2006/main" noGrp="1"/>
+          </p:cNvSpPr>
+          <p:nvPr/>
+        </p:nvSpPr>
+        <p:spPr>
+          <a:xfrm xmlns:a="http://schemas.openxmlformats.org/drawingml/2006/main">
+            <a:off x="4305300" y="4371975"/>
+            <a:ext cx="952500" cy="219075"/>
           </a:xfrm>
           <a:prstGeom xmlns:a="http://schemas.openxmlformats.org/drawingml/2006/main" prst="rect">
             <a:avLst/>
@@ -10690,7 +10690,7 @@
           <p:cNvPr id="41" name="model-table-row-278-4">
             <a:extLst xmlns:a="http://schemas.openxmlformats.org/drawingml/2006/main">
               <a:ext uri="{FF2B5EF4-FFF2-40B4-BE49-F238E27FC236}">
-                <a16:creationId xmlns:a16="http://schemas.microsoft.com/office/drawing/2014/main" id="{CD0DD320-FBFD-4B6D-A636-6A1D8938E88C}"/>
+                <a16:creationId xmlns:a16="http://schemas.microsoft.com/office/drawing/2014/main" id="{A0493B00-F0CA-4E17-B66B-EB045DAC9510}"/>
               </a:ext>
             </a:extLst>
           </p:cNvPr>
@@ -10743,7 +10743,7 @@
           <p:cNvPr id="43" name="text-50-502">
             <a:extLst xmlns:a="http://schemas.openxmlformats.org/drawingml/2006/main">
               <a:ext uri="{FF2B5EF4-FFF2-40B4-BE49-F238E27FC236}">
-                <a16:creationId xmlns:a16="http://schemas.microsoft.com/office/drawing/2014/main" id="{938C518A-95FC-4F3F-81D6-66FAABFE2F43}"/>
+                <a16:creationId xmlns:a16="http://schemas.microsoft.com/office/drawing/2014/main" id="{005ACF08-CC22-4622-8BFD-6CC976289E20}"/>
               </a:ext>
             </a:extLst>
           </p:cNvPr>
@@ -10755,7 +10755,7 @@
         <p:spPr>
           <a:xfrm xmlns:a="http://schemas.openxmlformats.org/drawingml/2006/main">
             <a:off x="476250" y="4781550"/>
-            <a:ext cx="1485900" cy="219075"/>
+            <a:ext cx="1371600" cy="219075"/>
           </a:xfrm>
           <a:prstGeom xmlns:a="http://schemas.openxmlformats.org/drawingml/2006/main" prst="rect">
             <a:avLst/>
@@ -10791,28 +10791,28 @@
                 <a:ea typeface="Helvetica Neue"/>
                 <a:cs typeface="Helvetica Neue"/>
               </a:rPr>
-              <a:t>XGBoost</a:t>
-            </a:r>
-          </a:p>
-        </p:txBody>
-      </p:sp>
-      <p:sp>
-        <p:nvSpPr>
-          <p:cNvPr id="44" name="text-222-502">
-            <a:extLst xmlns:a="http://schemas.openxmlformats.org/drawingml/2006/main">
-              <a:ext uri="{FF2B5EF4-FFF2-40B4-BE49-F238E27FC236}">
-                <a16:creationId xmlns:a16="http://schemas.microsoft.com/office/drawing/2014/main" id="{48B4BD4E-C203-458B-A703-81D1BD57A675}"/>
-              </a:ext>
-            </a:extLst>
-          </p:cNvPr>
-          <p:cNvSpPr>
-            <a:spLocks xmlns:a="http://schemas.openxmlformats.org/drawingml/2006/main" noGrp="1"/>
-          </p:cNvSpPr>
-          <p:nvPr/>
-        </p:nvSpPr>
-        <p:spPr>
-          <a:xfrm xmlns:a="http://schemas.openxmlformats.org/drawingml/2006/main">
-            <a:off x="2114550" y="4781550"/>
+              <a:t>Gradient Boosting</a:t>
+            </a:r>
+          </a:p>
+        </p:txBody>
+      </p:sp>
+      <p:sp>
+        <p:nvSpPr>
+          <p:cNvPr id="44" name="text-210-502">
+            <a:extLst xmlns:a="http://schemas.openxmlformats.org/drawingml/2006/main">
+              <a:ext uri="{FF2B5EF4-FFF2-40B4-BE49-F238E27FC236}">
+                <a16:creationId xmlns:a16="http://schemas.microsoft.com/office/drawing/2014/main" id="{532A814D-E999-4EB4-B9B5-C54A6A3604D9}"/>
+              </a:ext>
+            </a:extLst>
+          </p:cNvPr>
+          <p:cNvSpPr>
+            <a:spLocks xmlns:a="http://schemas.openxmlformats.org/drawingml/2006/main" noGrp="1"/>
+          </p:cNvSpPr>
+          <p:nvPr/>
+        </p:nvSpPr>
+        <p:spPr>
+          <a:xfrm xmlns:a="http://schemas.openxmlformats.org/drawingml/2006/main">
+            <a:off x="2000250" y="4781550"/>
             <a:ext cx="685800" cy="219075"/>
           </a:xfrm>
           <a:prstGeom xmlns:a="http://schemas.openxmlformats.org/drawingml/2006/main" prst="rect">
@@ -10849,28 +10849,28 @@
                 <a:ea typeface="Helvetica Neue"/>
                 <a:cs typeface="Helvetica Neue"/>
               </a:rPr>
-              <a:t>—</a:t>
-            </a:r>
-          </a:p>
-        </p:txBody>
-      </p:sp>
-      <p:sp>
-        <p:nvSpPr>
-          <p:cNvPr id="45" name="text-310-502">
-            <a:extLst xmlns:a="http://schemas.openxmlformats.org/drawingml/2006/main">
-              <a:ext uri="{FF2B5EF4-FFF2-40B4-BE49-F238E27FC236}">
-                <a16:creationId xmlns:a16="http://schemas.microsoft.com/office/drawing/2014/main" id="{E5337B9B-B729-403C-8459-32431A4B2F5F}"/>
-              </a:ext>
-            </a:extLst>
-          </p:cNvPr>
-          <p:cNvSpPr>
-            <a:spLocks xmlns:a="http://schemas.openxmlformats.org/drawingml/2006/main" noGrp="1"/>
-          </p:cNvSpPr>
-          <p:nvPr/>
-        </p:nvSpPr>
-        <p:spPr>
-          <a:xfrm xmlns:a="http://schemas.openxmlformats.org/drawingml/2006/main">
-            <a:off x="2952750" y="4781550"/>
+              <a:t>207 g</a:t>
+            </a:r>
+          </a:p>
+        </p:txBody>
+      </p:sp>
+      <p:sp>
+        <p:nvSpPr>
+          <p:cNvPr id="45" name="text-298-502">
+            <a:extLst xmlns:a="http://schemas.openxmlformats.org/drawingml/2006/main">
+              <a:ext uri="{FF2B5EF4-FFF2-40B4-BE49-F238E27FC236}">
+                <a16:creationId xmlns:a16="http://schemas.microsoft.com/office/drawing/2014/main" id="{4370039C-373D-403D-8A92-B301D1E54866}"/>
+              </a:ext>
+            </a:extLst>
+          </p:cNvPr>
+          <p:cNvSpPr>
+            <a:spLocks xmlns:a="http://schemas.openxmlformats.org/drawingml/2006/main" noGrp="1"/>
+          </p:cNvSpPr>
+          <p:nvPr/>
+        </p:nvSpPr>
+        <p:spPr>
+          <a:xfrm xmlns:a="http://schemas.openxmlformats.org/drawingml/2006/main">
+            <a:off x="2838450" y="4781550"/>
             <a:ext cx="628650" cy="219075"/>
           </a:xfrm>
           <a:prstGeom xmlns:a="http://schemas.openxmlformats.org/drawingml/2006/main" prst="rect">
@@ -10907,29 +10907,29 @@
                 <a:ea typeface="Helvetica Neue"/>
                 <a:cs typeface="Helvetica Neue"/>
               </a:rPr>
-              <a:t>—</a:t>
-            </a:r>
-          </a:p>
-        </p:txBody>
-      </p:sp>
-      <p:sp>
-        <p:nvSpPr>
-          <p:cNvPr id="46" name="text-392-502">
-            <a:extLst xmlns:a="http://schemas.openxmlformats.org/drawingml/2006/main">
-              <a:ext uri="{FF2B5EF4-FFF2-40B4-BE49-F238E27FC236}">
-                <a16:creationId xmlns:a16="http://schemas.microsoft.com/office/drawing/2014/main" id="{C63191C5-F995-478B-AB4C-C1EFCAF02349}"/>
-              </a:ext>
-            </a:extLst>
-          </p:cNvPr>
-          <p:cNvSpPr>
-            <a:spLocks xmlns:a="http://schemas.openxmlformats.org/drawingml/2006/main" noGrp="1"/>
-          </p:cNvSpPr>
-          <p:nvPr/>
-        </p:nvSpPr>
-        <p:spPr>
-          <a:xfrm xmlns:a="http://schemas.openxmlformats.org/drawingml/2006/main">
-            <a:off x="3733800" y="4781550"/>
-            <a:ext cx="400050" cy="219075"/>
+              <a:t>262 g</a:t>
+            </a:r>
+          </a:p>
+        </p:txBody>
+      </p:sp>
+      <p:sp>
+        <p:nvSpPr>
+          <p:cNvPr id="46" name="text-380-502">
+            <a:extLst xmlns:a="http://schemas.openxmlformats.org/drawingml/2006/main">
+              <a:ext uri="{FF2B5EF4-FFF2-40B4-BE49-F238E27FC236}">
+                <a16:creationId xmlns:a16="http://schemas.microsoft.com/office/drawing/2014/main" id="{FEFFE23D-5AAE-4C41-89A1-9A5C4FC91DAB}"/>
+              </a:ext>
+            </a:extLst>
+          </p:cNvPr>
+          <p:cNvSpPr>
+            <a:spLocks xmlns:a="http://schemas.openxmlformats.org/drawingml/2006/main" noGrp="1"/>
+          </p:cNvSpPr>
+          <p:nvPr/>
+        </p:nvSpPr>
+        <p:spPr>
+          <a:xfrm xmlns:a="http://schemas.openxmlformats.org/drawingml/2006/main">
+            <a:off x="3619500" y="4781550"/>
+            <a:ext cx="533400" cy="219075"/>
           </a:xfrm>
           <a:prstGeom xmlns:a="http://schemas.openxmlformats.org/drawingml/2006/main" prst="rect">
             <a:avLst/>
@@ -10965,29 +10965,29 @@
                 <a:ea typeface="Helvetica Neue"/>
                 <a:cs typeface="Helvetica Neue"/>
               </a:rPr>
-              <a:t>—</a:t>
-            </a:r>
-          </a:p>
-        </p:txBody>
-      </p:sp>
-      <p:sp>
-        <p:nvSpPr>
-          <p:cNvPr id="47" name="text-450-502">
-            <a:extLst xmlns:a="http://schemas.openxmlformats.org/drawingml/2006/main">
-              <a:ext uri="{FF2B5EF4-FFF2-40B4-BE49-F238E27FC236}">
-                <a16:creationId xmlns:a16="http://schemas.microsoft.com/office/drawing/2014/main" id="{8076047C-BB15-45B5-91EC-3746F4FD5664}"/>
-              </a:ext>
-            </a:extLst>
-          </p:cNvPr>
-          <p:cNvSpPr>
-            <a:spLocks xmlns:a="http://schemas.openxmlformats.org/drawingml/2006/main" noGrp="1"/>
-          </p:cNvSpPr>
-          <p:nvPr/>
-        </p:nvSpPr>
-        <p:spPr>
-          <a:xfrm xmlns:a="http://schemas.openxmlformats.org/drawingml/2006/main">
-            <a:off x="4286250" y="4781550"/>
-            <a:ext cx="971550" cy="219075"/>
+              <a:t>−0.026</a:t>
+            </a:r>
+          </a:p>
+        </p:txBody>
+      </p:sp>
+      <p:sp>
+        <p:nvSpPr>
+          <p:cNvPr id="47" name="text-452-502">
+            <a:extLst xmlns:a="http://schemas.openxmlformats.org/drawingml/2006/main">
+              <a:ext uri="{FF2B5EF4-FFF2-40B4-BE49-F238E27FC236}">
+                <a16:creationId xmlns:a16="http://schemas.microsoft.com/office/drawing/2014/main" id="{D11FB852-F242-452F-84C1-B1B665B2E6A5}"/>
+              </a:ext>
+            </a:extLst>
+          </p:cNvPr>
+          <p:cNvSpPr>
+            <a:spLocks xmlns:a="http://schemas.openxmlformats.org/drawingml/2006/main" noGrp="1"/>
+          </p:cNvSpPr>
+          <p:nvPr/>
+        </p:nvSpPr>
+        <p:spPr>
+          <a:xfrm xmlns:a="http://schemas.openxmlformats.org/drawingml/2006/main">
+            <a:off x="4305300" y="4781550"/>
+            <a:ext cx="952500" cy="219075"/>
           </a:xfrm>
           <a:prstGeom xmlns:a="http://schemas.openxmlformats.org/drawingml/2006/main" prst="rect">
             <a:avLst/>
@@ -11023,7 +11023,7 @@
                 <a:ea typeface="Helvetica Neue"/>
                 <a:cs typeface="Helvetica Neue"/>
               </a:rPr>
-              <a:t>Unavailable</a:t>
+              <a:t>Best learned</a:t>
             </a:r>
           </a:p>
         </p:txBody>
@@ -11033,7 +11033,7 @@
           <p:cNvPr id="48" name="text-760-190">
             <a:extLst xmlns:a="http://schemas.openxmlformats.org/drawingml/2006/main">
               <a:ext uri="{FF2B5EF4-FFF2-40B4-BE49-F238E27FC236}">
-                <a16:creationId xmlns:a16="http://schemas.microsoft.com/office/drawing/2014/main" id="{783969F2-59D7-4086-8264-0B36C89B79E7}"/>
+                <a16:creationId xmlns:a16="http://schemas.microsoft.com/office/drawing/2014/main" id="{B5D9B444-4E17-4654-BD79-AA7D0969EB59}"/>
               </a:ext>
             </a:extLst>
           </p:cNvPr>
@@ -11091,7 +11091,7 @@
           <p:cNvPr id="49" name="text-760-256">
             <a:extLst xmlns:a="http://schemas.openxmlformats.org/drawingml/2006/main">
               <a:ext uri="{FF2B5EF4-FFF2-40B4-BE49-F238E27FC236}">
-                <a16:creationId xmlns:a16="http://schemas.microsoft.com/office/drawing/2014/main" id="{1555E1EE-FC1A-4E51-B89F-483C80F38C6D}"/>
+                <a16:creationId xmlns:a16="http://schemas.microsoft.com/office/drawing/2014/main" id="{D57A3473-35C2-4482-8BBF-130EF15FA5BA}"/>
               </a:ext>
             </a:extLst>
           </p:cNvPr>
@@ -11149,7 +11149,7 @@
           <p:cNvPr id="50" name="text-760-334">
             <a:extLst xmlns:a="http://schemas.openxmlformats.org/drawingml/2006/main">
               <a:ext uri="{FF2B5EF4-FFF2-40B4-BE49-F238E27FC236}">
-                <a16:creationId xmlns:a16="http://schemas.microsoft.com/office/drawing/2014/main" id="{290E586B-A0D4-4556-B99D-11E6F48EA899}"/>
+                <a16:creationId xmlns:a16="http://schemas.microsoft.com/office/drawing/2014/main" id="{8B9DF599-249F-40BC-A0FF-074455F7DC1B}"/>
               </a:ext>
             </a:extLst>
           </p:cNvPr>
@@ -11207,7 +11207,7 @@
           <p:cNvPr id="51" name="text-760-400">
             <a:extLst xmlns:a="http://schemas.openxmlformats.org/drawingml/2006/main">
               <a:ext uri="{FF2B5EF4-FFF2-40B4-BE49-F238E27FC236}">
-                <a16:creationId xmlns:a16="http://schemas.microsoft.com/office/drawing/2014/main" id="{AB7A39BE-EE47-46D4-BD48-9DBBC6D2818F}"/>
+                <a16:creationId xmlns:a16="http://schemas.microsoft.com/office/drawing/2014/main" id="{8C33CD9F-5F2B-41FB-8EC4-C4E883830A65}"/>
               </a:ext>
             </a:extLst>
           </p:cNvPr>
@@ -11265,7 +11265,7 @@
           <p:cNvPr id="52" name="text-760-478">
             <a:extLst xmlns:a="http://schemas.openxmlformats.org/drawingml/2006/main">
               <a:ext uri="{FF2B5EF4-FFF2-40B4-BE49-F238E27FC236}">
-                <a16:creationId xmlns:a16="http://schemas.microsoft.com/office/drawing/2014/main" id="{92CCFC6A-3D66-4044-AB90-0985A1DB90D8}"/>
+                <a16:creationId xmlns:a16="http://schemas.microsoft.com/office/drawing/2014/main" id="{90593BED-AA63-4E0E-A538-B1626D2C5C23}"/>
               </a:ext>
             </a:extLst>
           </p:cNvPr>
@@ -11323,7 +11323,7 @@
           <p:cNvPr id="53" name="text-760-544">
             <a:extLst xmlns:a="http://schemas.openxmlformats.org/drawingml/2006/main">
               <a:ext uri="{FF2B5EF4-FFF2-40B4-BE49-F238E27FC236}">
-                <a16:creationId xmlns:a16="http://schemas.microsoft.com/office/drawing/2014/main" id="{8CE8DE17-A8D2-4B2F-889D-7A537153E673}"/>
+                <a16:creationId xmlns:a16="http://schemas.microsoft.com/office/drawing/2014/main" id="{EFBBCB39-E724-4925-91BE-0AD226891AA5}"/>
               </a:ext>
             </a:extLst>
           </p:cNvPr>
@@ -11381,7 +11381,7 @@
           <p:cNvPr id="54" name="text-760-590">
             <a:extLst xmlns:a="http://schemas.openxmlformats.org/drawingml/2006/main">
               <a:ext uri="{FF2B5EF4-FFF2-40B4-BE49-F238E27FC236}">
-                <a16:creationId xmlns:a16="http://schemas.microsoft.com/office/drawing/2014/main" id="{1DC3C0B1-D523-4A43-BF9F-162847DFE434}"/>
+                <a16:creationId xmlns:a16="http://schemas.microsoft.com/office/drawing/2014/main" id="{C6C0B931-4CBC-49F0-A8A6-C5CF2E12EC1A}"/>
               </a:ext>
             </a:extLst>
           </p:cNvPr>
@@ -11439,7 +11439,7 @@
           <p:cNvPr id="55" name="text-978-584">
             <a:extLst xmlns:a="http://schemas.openxmlformats.org/drawingml/2006/main">
               <a:ext uri="{FF2B5EF4-FFF2-40B4-BE49-F238E27FC236}">
-                <a16:creationId xmlns:a16="http://schemas.microsoft.com/office/drawing/2014/main" id="{C1790A8E-B02A-4B02-885F-F0A4AFBF883A}"/>
+                <a16:creationId xmlns:a16="http://schemas.microsoft.com/office/drawing/2014/main" id="{6EFEBA85-28BF-4968-BC58-A192C52986EF}"/>
               </a:ext>
             </a:extLst>
           </p:cNvPr>
@@ -11495,7 +11495,7 @@
     </p:spTree>
     <p:extLst>
       <p:ext uri="{BB962C8B-B14F-4D97-AF65-F5344CB8AC3E}">
-        <p14:creationId xmlns:p14="http://schemas.microsoft.com/office/powerpoint/2010/main" val="1574897469"/>
+        <p14:creationId xmlns:p14="http://schemas.microsoft.com/office/powerpoint/2010/main" val="1072651394"/>
       </p:ext>
     </p:extLst>
   </p:cSld>
@@ -11526,7 +11526,7 @@
           <p:cNvPr id="56" name="kicker-7">
             <a:extLst xmlns:a="http://schemas.openxmlformats.org/drawingml/2006/main">
               <a:ext uri="{FF2B5EF4-FFF2-40B4-BE49-F238E27FC236}">
-                <a16:creationId xmlns:a16="http://schemas.microsoft.com/office/drawing/2014/main" id="{EE12F05F-A714-4417-B25A-DC01CC644453}"/>
+                <a16:creationId xmlns:a16="http://schemas.microsoft.com/office/drawing/2014/main" id="{F6A63D9A-2A21-4DEA-A40D-D57DC698C21D}"/>
               </a:ext>
             </a:extLst>
           </p:cNvPr>
@@ -11584,7 +11584,7 @@
           <p:cNvPr id="2" name="title-7">
             <a:extLst xmlns:a="http://schemas.openxmlformats.org/drawingml/2006/main">
               <a:ext uri="{FF2B5EF4-FFF2-40B4-BE49-F238E27FC236}">
-                <a16:creationId xmlns:a16="http://schemas.microsoft.com/office/drawing/2014/main" id="{1761E992-9D47-4C9A-9A32-896F63043CE6}"/>
+                <a16:creationId xmlns:a16="http://schemas.microsoft.com/office/drawing/2014/main" id="{668B6929-4193-4CBF-ADF4-7A56015E9BA5}"/>
               </a:ext>
             </a:extLst>
           </p:cNvPr>
@@ -11664,7 +11664,7 @@
           <p:cNvPr id="4" name="page-7">
             <a:extLst xmlns:a="http://schemas.openxmlformats.org/drawingml/2006/main">
               <a:ext uri="{FF2B5EF4-FFF2-40B4-BE49-F238E27FC236}">
-                <a16:creationId xmlns:a16="http://schemas.microsoft.com/office/drawing/2014/main" id="{7EF3BFE0-8D50-49CB-B081-6D7AA64CAEFC}"/>
+                <a16:creationId xmlns:a16="http://schemas.microsoft.com/office/drawing/2014/main" id="{AE02A60F-C378-4817-A22B-411C366623FB}"/>
               </a:ext>
             </a:extLst>
           </p:cNvPr>
@@ -11722,7 +11722,7 @@
           <p:cNvPr id="5" name="text-42-148">
             <a:extLst xmlns:a="http://schemas.openxmlformats.org/drawingml/2006/main">
               <a:ext uri="{FF2B5EF4-FFF2-40B4-BE49-F238E27FC236}">
-                <a16:creationId xmlns:a16="http://schemas.microsoft.com/office/drawing/2014/main" id="{D898B178-309F-4523-AAF7-97EDFAACB7D2}"/>
+                <a16:creationId xmlns:a16="http://schemas.microsoft.com/office/drawing/2014/main" id="{C7E396E6-71B7-4AEB-8D42-3915B0D85FE1}"/>
               </a:ext>
             </a:extLst>
           </p:cNvPr>
@@ -11770,7 +11770,7 @@
                 <a:ea typeface="Helvetica Neue"/>
                 <a:cs typeface="Helvetica Neue"/>
               </a:rPr>
-              <a:t>Y: last recorded population ÷ beginning population</a:t>
+              <a:t>Y: additional population loss after the review date</a:t>
             </a:r>
           </a:p>
         </p:txBody>
@@ -11780,7 +11780,7 @@
           <p:cNvPr id="6" name="text-42-184">
             <a:extLst xmlns:a="http://schemas.openxmlformats.org/drawingml/2006/main">
               <a:ext uri="{FF2B5EF4-FFF2-40B4-BE49-F238E27FC236}">
-                <a16:creationId xmlns:a16="http://schemas.microsoft.com/office/drawing/2014/main" id="{F3F840E6-49B5-4198-98EF-9AF7E35CB55E}"/>
+                <a16:creationId xmlns:a16="http://schemas.microsoft.com/office/drawing/2014/main" id="{8116B37A-5EA7-4B5B-9708-2A4E501DBCBE}"/>
               </a:ext>
             </a:extLst>
           </p:cNvPr>
@@ -11838,7 +11838,7 @@
           <p:cNvPr id="7" name="model-table-header-286">
             <a:extLst xmlns:a="http://schemas.openxmlformats.org/drawingml/2006/main">
               <a:ext uri="{FF2B5EF4-FFF2-40B4-BE49-F238E27FC236}">
-                <a16:creationId xmlns:a16="http://schemas.microsoft.com/office/drawing/2014/main" id="{30B3C579-F0B1-413F-8FB9-5CFC5A487996}"/>
+                <a16:creationId xmlns:a16="http://schemas.microsoft.com/office/drawing/2014/main" id="{0F5AA8F1-4868-46F3-B24C-292F4AB933C8}"/>
               </a:ext>
             </a:extLst>
           </p:cNvPr>
@@ -11869,7 +11869,7 @@
           <p:cNvPr id="8" name="text-50-296">
             <a:extLst xmlns:a="http://schemas.openxmlformats.org/drawingml/2006/main">
               <a:ext uri="{FF2B5EF4-FFF2-40B4-BE49-F238E27FC236}">
-                <a16:creationId xmlns:a16="http://schemas.microsoft.com/office/drawing/2014/main" id="{99A10A70-8CE9-4ABE-BFBD-65371E2D3CAB}"/>
+                <a16:creationId xmlns:a16="http://schemas.microsoft.com/office/drawing/2014/main" id="{316DE662-A7C3-4A58-9B9F-E6747FE0AAB1}"/>
               </a:ext>
             </a:extLst>
           </p:cNvPr>
@@ -11881,7 +11881,7 @@
         <p:spPr>
           <a:xfrm xmlns:a="http://schemas.openxmlformats.org/drawingml/2006/main">
             <a:off x="476250" y="2819400"/>
-            <a:ext cx="1485900" cy="209550"/>
+            <a:ext cx="1371600" cy="209550"/>
           </a:xfrm>
           <a:prstGeom xmlns:a="http://schemas.openxmlformats.org/drawingml/2006/main" prst="rect">
             <a:avLst/>
@@ -11924,21 +11924,21 @@
       </p:sp>
       <p:sp>
         <p:nvSpPr>
-          <p:cNvPr id="9" name="text-222-296">
-            <a:extLst xmlns:a="http://schemas.openxmlformats.org/drawingml/2006/main">
-              <a:ext uri="{FF2B5EF4-FFF2-40B4-BE49-F238E27FC236}">
-                <a16:creationId xmlns:a16="http://schemas.microsoft.com/office/drawing/2014/main" id="{B68D10EB-655B-472F-9402-9DACC14FDC82}"/>
-              </a:ext>
-            </a:extLst>
-          </p:cNvPr>
-          <p:cNvSpPr>
-            <a:spLocks xmlns:a="http://schemas.openxmlformats.org/drawingml/2006/main" noGrp="1"/>
-          </p:cNvSpPr>
-          <p:nvPr/>
-        </p:nvSpPr>
-        <p:spPr>
-          <a:xfrm xmlns:a="http://schemas.openxmlformats.org/drawingml/2006/main">
-            <a:off x="2114550" y="2819400"/>
+          <p:cNvPr id="9" name="text-210-296">
+            <a:extLst xmlns:a="http://schemas.openxmlformats.org/drawingml/2006/main">
+              <a:ext uri="{FF2B5EF4-FFF2-40B4-BE49-F238E27FC236}">
+                <a16:creationId xmlns:a16="http://schemas.microsoft.com/office/drawing/2014/main" id="{96585B78-8C2F-4756-ADC1-014FB9E80525}"/>
+              </a:ext>
+            </a:extLst>
+          </p:cNvPr>
+          <p:cNvSpPr>
+            <a:spLocks xmlns:a="http://schemas.openxmlformats.org/drawingml/2006/main" noGrp="1"/>
+          </p:cNvSpPr>
+          <p:nvPr/>
+        </p:nvSpPr>
+        <p:spPr>
+          <a:xfrm xmlns:a="http://schemas.openxmlformats.org/drawingml/2006/main">
+            <a:off x="2000250" y="2819400"/>
             <a:ext cx="685800" cy="209550"/>
           </a:xfrm>
           <a:prstGeom xmlns:a="http://schemas.openxmlformats.org/drawingml/2006/main" prst="rect">
@@ -11982,21 +11982,21 @@
       </p:sp>
       <p:sp>
         <p:nvSpPr>
-          <p:cNvPr id="10" name="text-310-296">
-            <a:extLst xmlns:a="http://schemas.openxmlformats.org/drawingml/2006/main">
-              <a:ext uri="{FF2B5EF4-FFF2-40B4-BE49-F238E27FC236}">
-                <a16:creationId xmlns:a16="http://schemas.microsoft.com/office/drawing/2014/main" id="{C3B853D1-98C3-4C10-9C1C-F39C79F7921C}"/>
-              </a:ext>
-            </a:extLst>
-          </p:cNvPr>
-          <p:cNvSpPr>
-            <a:spLocks xmlns:a="http://schemas.openxmlformats.org/drawingml/2006/main" noGrp="1"/>
-          </p:cNvSpPr>
-          <p:nvPr/>
-        </p:nvSpPr>
-        <p:spPr>
-          <a:xfrm xmlns:a="http://schemas.openxmlformats.org/drawingml/2006/main">
-            <a:off x="2952750" y="2819400"/>
+          <p:cNvPr id="10" name="text-298-296">
+            <a:extLst xmlns:a="http://schemas.openxmlformats.org/drawingml/2006/main">
+              <a:ext uri="{FF2B5EF4-FFF2-40B4-BE49-F238E27FC236}">
+                <a16:creationId xmlns:a16="http://schemas.microsoft.com/office/drawing/2014/main" id="{C71E40E1-796C-40E3-AB7D-FFDBC9DC4AC2}"/>
+              </a:ext>
+            </a:extLst>
+          </p:cNvPr>
+          <p:cNvSpPr>
+            <a:spLocks xmlns:a="http://schemas.openxmlformats.org/drawingml/2006/main" noGrp="1"/>
+          </p:cNvSpPr>
+          <p:nvPr/>
+        </p:nvSpPr>
+        <p:spPr>
+          <a:xfrm xmlns:a="http://schemas.openxmlformats.org/drawingml/2006/main">
+            <a:off x="2838450" y="2819400"/>
             <a:ext cx="628650" cy="209550"/>
           </a:xfrm>
           <a:prstGeom xmlns:a="http://schemas.openxmlformats.org/drawingml/2006/main" prst="rect">
@@ -12040,22 +12040,22 @@
       </p:sp>
       <p:sp>
         <p:nvSpPr>
-          <p:cNvPr id="11" name="text-392-296">
-            <a:extLst xmlns:a="http://schemas.openxmlformats.org/drawingml/2006/main">
-              <a:ext uri="{FF2B5EF4-FFF2-40B4-BE49-F238E27FC236}">
-                <a16:creationId xmlns:a16="http://schemas.microsoft.com/office/drawing/2014/main" id="{8DC45B21-9371-497C-83AD-D91E9AAE40C7}"/>
-              </a:ext>
-            </a:extLst>
-          </p:cNvPr>
-          <p:cNvSpPr>
-            <a:spLocks xmlns:a="http://schemas.openxmlformats.org/drawingml/2006/main" noGrp="1"/>
-          </p:cNvSpPr>
-          <p:nvPr/>
-        </p:nvSpPr>
-        <p:spPr>
-          <a:xfrm xmlns:a="http://schemas.openxmlformats.org/drawingml/2006/main">
-            <a:off x="3733800" y="2819400"/>
-            <a:ext cx="400050" cy="209550"/>
+          <p:cNvPr id="11" name="text-380-296">
+            <a:extLst xmlns:a="http://schemas.openxmlformats.org/drawingml/2006/main">
+              <a:ext uri="{FF2B5EF4-FFF2-40B4-BE49-F238E27FC236}">
+                <a16:creationId xmlns:a16="http://schemas.microsoft.com/office/drawing/2014/main" id="{D49F1718-2CD2-4555-9EEF-FF701F7D82D5}"/>
+              </a:ext>
+            </a:extLst>
+          </p:cNvPr>
+          <p:cNvSpPr>
+            <a:spLocks xmlns:a="http://schemas.openxmlformats.org/drawingml/2006/main" noGrp="1"/>
+          </p:cNvSpPr>
+          <p:nvPr/>
+        </p:nvSpPr>
+        <p:spPr>
+          <a:xfrm xmlns:a="http://schemas.openxmlformats.org/drawingml/2006/main">
+            <a:off x="3619500" y="2819400"/>
+            <a:ext cx="533400" cy="209550"/>
           </a:xfrm>
           <a:prstGeom xmlns:a="http://schemas.openxmlformats.org/drawingml/2006/main" prst="rect">
             <a:avLst/>
@@ -12098,22 +12098,22 @@
       </p:sp>
       <p:sp>
         <p:nvSpPr>
-          <p:cNvPr id="12" name="text-450-296">
-            <a:extLst xmlns:a="http://schemas.openxmlformats.org/drawingml/2006/main">
-              <a:ext uri="{FF2B5EF4-FFF2-40B4-BE49-F238E27FC236}">
-                <a16:creationId xmlns:a16="http://schemas.microsoft.com/office/drawing/2014/main" id="{B77FBF69-BEB5-4D1A-8799-5B42001DC6B4}"/>
-              </a:ext>
-            </a:extLst>
-          </p:cNvPr>
-          <p:cNvSpPr>
-            <a:spLocks xmlns:a="http://schemas.openxmlformats.org/drawingml/2006/main" noGrp="1"/>
-          </p:cNvSpPr>
-          <p:nvPr/>
-        </p:nvSpPr>
-        <p:spPr>
-          <a:xfrm xmlns:a="http://schemas.openxmlformats.org/drawingml/2006/main">
-            <a:off x="4286250" y="2819400"/>
-            <a:ext cx="971550" cy="209550"/>
+          <p:cNvPr id="12" name="text-452-296">
+            <a:extLst xmlns:a="http://schemas.openxmlformats.org/drawingml/2006/main">
+              <a:ext uri="{FF2B5EF4-FFF2-40B4-BE49-F238E27FC236}">
+                <a16:creationId xmlns:a16="http://schemas.microsoft.com/office/drawing/2014/main" id="{21F8DD7D-9D4D-439C-B042-21F2CB0423A5}"/>
+              </a:ext>
+            </a:extLst>
+          </p:cNvPr>
+          <p:cNvSpPr>
+            <a:spLocks xmlns:a="http://schemas.openxmlformats.org/drawingml/2006/main" noGrp="1"/>
+          </p:cNvSpPr>
+          <p:nvPr/>
+        </p:nvSpPr>
+        <p:spPr>
+          <a:xfrm xmlns:a="http://schemas.openxmlformats.org/drawingml/2006/main">
+            <a:off x="4305300" y="2819400"/>
+            <a:ext cx="952500" cy="209550"/>
           </a:xfrm>
           <a:prstGeom xmlns:a="http://schemas.openxmlformats.org/drawingml/2006/main" prst="rect">
             <a:avLst/>
@@ -12159,7 +12159,7 @@
           <p:cNvPr id="13" name="model-table-row-286-0">
             <a:extLst xmlns:a="http://schemas.openxmlformats.org/drawingml/2006/main">
               <a:ext uri="{FF2B5EF4-FFF2-40B4-BE49-F238E27FC236}">
-                <a16:creationId xmlns:a16="http://schemas.microsoft.com/office/drawing/2014/main" id="{3B87F192-452D-49CC-9BDA-FAA2416BA191}"/>
+                <a16:creationId xmlns:a16="http://schemas.microsoft.com/office/drawing/2014/main" id="{12B4E6D0-D8CC-4EE4-8869-9E2E997111C1}"/>
               </a:ext>
             </a:extLst>
           </p:cNvPr>
@@ -12212,7 +12212,7 @@
           <p:cNvPr id="15" name="text-50-338">
             <a:extLst xmlns:a="http://schemas.openxmlformats.org/drawingml/2006/main">
               <a:ext uri="{FF2B5EF4-FFF2-40B4-BE49-F238E27FC236}">
-                <a16:creationId xmlns:a16="http://schemas.microsoft.com/office/drawing/2014/main" id="{1A9B0B7D-5BBF-4878-AA54-E46313A99F1C}"/>
+                <a16:creationId xmlns:a16="http://schemas.microsoft.com/office/drawing/2014/main" id="{145B6D2F-5902-479F-8C44-80861FE8F28C}"/>
               </a:ext>
             </a:extLst>
           </p:cNvPr>
@@ -12224,64 +12224,64 @@
         <p:spPr>
           <a:xfrm xmlns:a="http://schemas.openxmlformats.org/drawingml/2006/main">
             <a:off x="476250" y="3219450"/>
-            <a:ext cx="1485900" cy="219075"/>
-          </a:xfrm>
-          <a:prstGeom xmlns:a="http://schemas.openxmlformats.org/drawingml/2006/main" prst="rect">
-            <a:avLst/>
-          </a:prstGeom>
-          <a:noFill xmlns:a="http://schemas.openxmlformats.org/drawingml/2006/main"/>
-          <a:ln xmlns:a="http://schemas.openxmlformats.org/drawingml/2006/main" w="0">
-            <a:noFill/>
-            <a:prstDash val="solid"/>
-          </a:ln>
-        </p:spPr>
-        <p:txBody>
-          <a:bodyPr xmlns:a="http://schemas.openxmlformats.org/drawingml/2006/main" wrap="square" lIns="0" tIns="0" rIns="0" bIns="0" anchor="t">
-            <a:normAutofit fontScale="100000"/>
-          </a:bodyPr>
-          <a:lstStyle xmlns:a="http://schemas.openxmlformats.org/drawingml/2006/main"/>
-          <a:p xmlns:a="http://schemas.openxmlformats.org/drawingml/2006/main">
-            <a:pPr algn="l">
-              <a:defRPr sz="1050" b="0">
-                <a:solidFill>
-                  <a:srgbClr val="111111"/>
-                </a:solidFill>
-                <a:latin typeface="Helvetica Neue"/>
-                <a:ea typeface="Helvetica Neue"/>
-                <a:cs typeface="Helvetica Neue"/>
-              </a:defRPr>
-            </a:pPr>
-            <a:r>
-              <a:rPr sz="1050" b="0">
-                <a:solidFill>
-                  <a:srgbClr val="111111"/>
-                </a:solidFill>
-                <a:latin typeface="Helvetica Neue"/>
-                <a:ea typeface="Helvetica Neue"/>
-                <a:cs typeface="Helvetica Neue"/>
-              </a:rPr>
-              <a:t>Historical mean</a:t>
-            </a:r>
-          </a:p>
-        </p:txBody>
-      </p:sp>
-      <p:sp>
-        <p:nvSpPr>
-          <p:cNvPr id="16" name="text-222-338">
-            <a:extLst xmlns:a="http://schemas.openxmlformats.org/drawingml/2006/main">
-              <a:ext uri="{FF2B5EF4-FFF2-40B4-BE49-F238E27FC236}">
-                <a16:creationId xmlns:a16="http://schemas.microsoft.com/office/drawing/2014/main" id="{FCF2E822-2F47-4D13-B100-85A2A431BBA4}"/>
-              </a:ext>
-            </a:extLst>
-          </p:cNvPr>
-          <p:cNvSpPr>
-            <a:spLocks xmlns:a="http://schemas.openxmlformats.org/drawingml/2006/main" noGrp="1"/>
-          </p:cNvSpPr>
-          <p:nvPr/>
-        </p:nvSpPr>
-        <p:spPr>
-          <a:xfrm xmlns:a="http://schemas.openxmlformats.org/drawingml/2006/main">
-            <a:off x="2114550" y="3219450"/>
+            <a:ext cx="1371600" cy="219075"/>
+          </a:xfrm>
+          <a:prstGeom xmlns:a="http://schemas.openxmlformats.org/drawingml/2006/main" prst="rect">
+            <a:avLst/>
+          </a:prstGeom>
+          <a:noFill xmlns:a="http://schemas.openxmlformats.org/drawingml/2006/main"/>
+          <a:ln xmlns:a="http://schemas.openxmlformats.org/drawingml/2006/main" w="0">
+            <a:noFill/>
+            <a:prstDash val="solid"/>
+          </a:ln>
+        </p:spPr>
+        <p:txBody>
+          <a:bodyPr xmlns:a="http://schemas.openxmlformats.org/drawingml/2006/main" wrap="square" lIns="0" tIns="0" rIns="0" bIns="0" anchor="t">
+            <a:normAutofit fontScale="100000"/>
+          </a:bodyPr>
+          <a:lstStyle xmlns:a="http://schemas.openxmlformats.org/drawingml/2006/main"/>
+          <a:p xmlns:a="http://schemas.openxmlformats.org/drawingml/2006/main">
+            <a:pPr algn="l">
+              <a:defRPr sz="1050" b="1">
+                <a:solidFill>
+                  <a:srgbClr val="174F3C"/>
+                </a:solidFill>
+                <a:latin typeface="Helvetica Neue"/>
+                <a:ea typeface="Helvetica Neue"/>
+                <a:cs typeface="Helvetica Neue"/>
+              </a:defRPr>
+            </a:pPr>
+            <a:r>
+              <a:rPr sz="1050" b="1">
+                <a:solidFill>
+                  <a:srgbClr val="174F3C"/>
+                </a:solidFill>
+                <a:latin typeface="Helvetica Neue"/>
+                <a:ea typeface="Helvetica Neue"/>
+                <a:cs typeface="Helvetica Neue"/>
+              </a:rPr>
+              <a:t>Age-band baseline</a:t>
+            </a:r>
+          </a:p>
+        </p:txBody>
+      </p:sp>
+      <p:sp>
+        <p:nvSpPr>
+          <p:cNvPr id="16" name="text-210-338">
+            <a:extLst xmlns:a="http://schemas.openxmlformats.org/drawingml/2006/main">
+              <a:ext uri="{FF2B5EF4-FFF2-40B4-BE49-F238E27FC236}">
+                <a16:creationId xmlns:a16="http://schemas.microsoft.com/office/drawing/2014/main" id="{31F63079-8D0C-404E-8846-7F5EAD73F80F}"/>
+              </a:ext>
+            </a:extLst>
+          </p:cNvPr>
+          <p:cNvSpPr>
+            <a:spLocks xmlns:a="http://schemas.openxmlformats.org/drawingml/2006/main" noGrp="1"/>
+          </p:cNvSpPr>
+          <p:nvPr/>
+        </p:nvSpPr>
+        <p:spPr>
+          <a:xfrm xmlns:a="http://schemas.openxmlformats.org/drawingml/2006/main">
+            <a:off x="2000250" y="3219450"/>
             <a:ext cx="685800" cy="219075"/>
           </a:xfrm>
           <a:prstGeom xmlns:a="http://schemas.openxmlformats.org/drawingml/2006/main" prst="rect">
@@ -12302,7 +12302,7 @@
             <a:pPr algn="r">
               <a:defRPr sz="1050" b="1">
                 <a:solidFill>
-                  <a:srgbClr val="111111"/>
+                  <a:srgbClr val="174F3C"/>
                 </a:solidFill>
                 <a:latin typeface="Helvetica Neue"/>
                 <a:ea typeface="Helvetica Neue"/>
@@ -12312,34 +12312,34 @@
             <a:r>
               <a:rPr sz="1050" b="1">
                 <a:solidFill>
-                  <a:srgbClr val="111111"/>
-                </a:solidFill>
-                <a:latin typeface="Helvetica Neue"/>
-                <a:ea typeface="Helvetica Neue"/>
-                <a:cs typeface="Helvetica Neue"/>
-              </a:rPr>
-              <a:t>1.73 pts</a:t>
-            </a:r>
-          </a:p>
-        </p:txBody>
-      </p:sp>
-      <p:sp>
-        <p:nvSpPr>
-          <p:cNvPr id="17" name="text-310-338">
-            <a:extLst xmlns:a="http://schemas.openxmlformats.org/drawingml/2006/main">
-              <a:ext uri="{FF2B5EF4-FFF2-40B4-BE49-F238E27FC236}">
-                <a16:creationId xmlns:a16="http://schemas.microsoft.com/office/drawing/2014/main" id="{D801C48D-22E0-40D5-8BAB-A60C8A041895}"/>
-              </a:ext>
-            </a:extLst>
-          </p:cNvPr>
-          <p:cNvSpPr>
-            <a:spLocks xmlns:a="http://schemas.openxmlformats.org/drawingml/2006/main" noGrp="1"/>
-          </p:cNvSpPr>
-          <p:nvPr/>
-        </p:nvSpPr>
-        <p:spPr>
-          <a:xfrm xmlns:a="http://schemas.openxmlformats.org/drawingml/2006/main">
-            <a:off x="2952750" y="3219450"/>
+                  <a:srgbClr val="174F3C"/>
+                </a:solidFill>
+                <a:latin typeface="Helvetica Neue"/>
+                <a:ea typeface="Helvetica Neue"/>
+                <a:cs typeface="Helvetica Neue"/>
+              </a:rPr>
+              <a:t>1.50 pts</a:t>
+            </a:r>
+          </a:p>
+        </p:txBody>
+      </p:sp>
+      <p:sp>
+        <p:nvSpPr>
+          <p:cNvPr id="17" name="text-298-338">
+            <a:extLst xmlns:a="http://schemas.openxmlformats.org/drawingml/2006/main">
+              <a:ext uri="{FF2B5EF4-FFF2-40B4-BE49-F238E27FC236}">
+                <a16:creationId xmlns:a16="http://schemas.microsoft.com/office/drawing/2014/main" id="{EB45FCAD-C087-461D-BCD0-2C08C6DA00FE}"/>
+              </a:ext>
+            </a:extLst>
+          </p:cNvPr>
+          <p:cNvSpPr>
+            <a:spLocks xmlns:a="http://schemas.openxmlformats.org/drawingml/2006/main" noGrp="1"/>
+          </p:cNvSpPr>
+          <p:nvPr/>
+        </p:nvSpPr>
+        <p:spPr>
+          <a:xfrm xmlns:a="http://schemas.openxmlformats.org/drawingml/2006/main">
+            <a:off x="2838450" y="3219450"/>
             <a:ext cx="628650" cy="219075"/>
           </a:xfrm>
           <a:prstGeom xmlns:a="http://schemas.openxmlformats.org/drawingml/2006/main" prst="rect">
@@ -12360,7 +12360,7 @@
             <a:pPr algn="r">
               <a:defRPr sz="1050" b="1">
                 <a:solidFill>
-                  <a:srgbClr val="111111"/>
+                  <a:srgbClr val="174F3C"/>
                 </a:solidFill>
                 <a:latin typeface="Helvetica Neue"/>
                 <a:ea typeface="Helvetica Neue"/>
@@ -12370,55 +12370,55 @@
             <a:r>
               <a:rPr sz="1050" b="1">
                 <a:solidFill>
-                  <a:srgbClr val="111111"/>
-                </a:solidFill>
-                <a:latin typeface="Helvetica Neue"/>
-                <a:ea typeface="Helvetica Neue"/>
-                <a:cs typeface="Helvetica Neue"/>
-              </a:rPr>
-              <a:t>2.17 pts</a:t>
-            </a:r>
-          </a:p>
-        </p:txBody>
-      </p:sp>
-      <p:sp>
-        <p:nvSpPr>
-          <p:cNvPr id="18" name="text-392-338">
-            <a:extLst xmlns:a="http://schemas.openxmlformats.org/drawingml/2006/main">
-              <a:ext uri="{FF2B5EF4-FFF2-40B4-BE49-F238E27FC236}">
-                <a16:creationId xmlns:a16="http://schemas.microsoft.com/office/drawing/2014/main" id="{04307AE9-3E61-4178-B9F4-F8DF7CC6AB48}"/>
-              </a:ext>
-            </a:extLst>
-          </p:cNvPr>
-          <p:cNvSpPr>
-            <a:spLocks xmlns:a="http://schemas.openxmlformats.org/drawingml/2006/main" noGrp="1"/>
-          </p:cNvSpPr>
-          <p:nvPr/>
-        </p:nvSpPr>
-        <p:spPr>
-          <a:xfrm xmlns:a="http://schemas.openxmlformats.org/drawingml/2006/main">
-            <a:off x="3733800" y="3219450"/>
-            <a:ext cx="400050" cy="219075"/>
-          </a:xfrm>
-          <a:prstGeom xmlns:a="http://schemas.openxmlformats.org/drawingml/2006/main" prst="rect">
-            <a:avLst/>
-          </a:prstGeom>
-          <a:noFill xmlns:a="http://schemas.openxmlformats.org/drawingml/2006/main"/>
-          <a:ln xmlns:a="http://schemas.openxmlformats.org/drawingml/2006/main" w="0">
-            <a:noFill/>
-            <a:prstDash val="solid"/>
-          </a:ln>
-        </p:spPr>
-        <p:txBody>
-          <a:bodyPr xmlns:a="http://schemas.openxmlformats.org/drawingml/2006/main" wrap="square" lIns="0" tIns="0" rIns="0" bIns="0" anchor="t">
-            <a:normAutofit fontScale="97411"/>
+                  <a:srgbClr val="174F3C"/>
+                </a:solidFill>
+                <a:latin typeface="Helvetica Neue"/>
+                <a:ea typeface="Helvetica Neue"/>
+                <a:cs typeface="Helvetica Neue"/>
+              </a:rPr>
+              <a:t>1.80 pts</a:t>
+            </a:r>
+          </a:p>
+        </p:txBody>
+      </p:sp>
+      <p:sp>
+        <p:nvSpPr>
+          <p:cNvPr id="18" name="text-380-338">
+            <a:extLst xmlns:a="http://schemas.openxmlformats.org/drawingml/2006/main">
+              <a:ext uri="{FF2B5EF4-FFF2-40B4-BE49-F238E27FC236}">
+                <a16:creationId xmlns:a16="http://schemas.microsoft.com/office/drawing/2014/main" id="{1B707BEC-36C2-4E89-9DD6-9EDC40E47BD1}"/>
+              </a:ext>
+            </a:extLst>
+          </p:cNvPr>
+          <p:cNvSpPr>
+            <a:spLocks xmlns:a="http://schemas.openxmlformats.org/drawingml/2006/main" noGrp="1"/>
+          </p:cNvSpPr>
+          <p:nvPr/>
+        </p:nvSpPr>
+        <p:spPr>
+          <a:xfrm xmlns:a="http://schemas.openxmlformats.org/drawingml/2006/main">
+            <a:off x="3619500" y="3219450"/>
+            <a:ext cx="533400" cy="219075"/>
+          </a:xfrm>
+          <a:prstGeom xmlns:a="http://schemas.openxmlformats.org/drawingml/2006/main" prst="rect">
+            <a:avLst/>
+          </a:prstGeom>
+          <a:noFill xmlns:a="http://schemas.openxmlformats.org/drawingml/2006/main"/>
+          <a:ln xmlns:a="http://schemas.openxmlformats.org/drawingml/2006/main" w="0">
+            <a:noFill/>
+            <a:prstDash val="solid"/>
+          </a:ln>
+        </p:spPr>
+        <p:txBody>
+          <a:bodyPr xmlns:a="http://schemas.openxmlformats.org/drawingml/2006/main" wrap="square" lIns="0" tIns="0" rIns="0" bIns="0" anchor="t">
+            <a:normAutofit fontScale="100000"/>
           </a:bodyPr>
           <a:lstStyle xmlns:a="http://schemas.openxmlformats.org/drawingml/2006/main"/>
           <a:p xmlns:a="http://schemas.openxmlformats.org/drawingml/2006/main">
             <a:pPr algn="r">
               <a:defRPr sz="1050" b="1">
                 <a:solidFill>
-                  <a:srgbClr val="111111"/>
+                  <a:srgbClr val="174F3C"/>
                 </a:solidFill>
                 <a:latin typeface="Helvetica Neue"/>
                 <a:ea typeface="Helvetica Neue"/>
@@ -12428,71 +12428,71 @@
             <a:r>
               <a:rPr sz="1050" b="1">
                 <a:solidFill>
-                  <a:srgbClr val="111111"/>
-                </a:solidFill>
-                <a:latin typeface="Helvetica Neue"/>
-                <a:ea typeface="Helvetica Neue"/>
-                <a:cs typeface="Helvetica Neue"/>
-              </a:rPr>
-              <a:t>−0.132</a:t>
-            </a:r>
-          </a:p>
-        </p:txBody>
-      </p:sp>
-      <p:sp>
-        <p:nvSpPr>
-          <p:cNvPr id="19" name="text-450-338">
-            <a:extLst xmlns:a="http://schemas.openxmlformats.org/drawingml/2006/main">
-              <a:ext uri="{FF2B5EF4-FFF2-40B4-BE49-F238E27FC236}">
-                <a16:creationId xmlns:a16="http://schemas.microsoft.com/office/drawing/2014/main" id="{98C958B8-4C5F-43B9-93E0-FA632D4633DF}"/>
-              </a:ext>
-            </a:extLst>
-          </p:cNvPr>
-          <p:cNvSpPr>
-            <a:spLocks xmlns:a="http://schemas.openxmlformats.org/drawingml/2006/main" noGrp="1"/>
-          </p:cNvSpPr>
-          <p:nvPr/>
-        </p:nvSpPr>
-        <p:spPr>
-          <a:xfrm xmlns:a="http://schemas.openxmlformats.org/drawingml/2006/main">
-            <a:off x="4286250" y="3219450"/>
-            <a:ext cx="971550" cy="219075"/>
-          </a:xfrm>
-          <a:prstGeom xmlns:a="http://schemas.openxmlformats.org/drawingml/2006/main" prst="rect">
-            <a:avLst/>
-          </a:prstGeom>
-          <a:noFill xmlns:a="http://schemas.openxmlformats.org/drawingml/2006/main"/>
-          <a:ln xmlns:a="http://schemas.openxmlformats.org/drawingml/2006/main" w="0">
-            <a:noFill/>
-            <a:prstDash val="solid"/>
-          </a:ln>
-        </p:spPr>
-        <p:txBody>
-          <a:bodyPr xmlns:a="http://schemas.openxmlformats.org/drawingml/2006/main" wrap="square" lIns="0" tIns="0" rIns="0" bIns="0" anchor="t">
-            <a:normAutofit fontScale="100000"/>
-          </a:bodyPr>
-          <a:lstStyle xmlns:a="http://schemas.openxmlformats.org/drawingml/2006/main"/>
-          <a:p xmlns:a="http://schemas.openxmlformats.org/drawingml/2006/main">
-            <a:pPr algn="l">
-              <a:defRPr sz="1050" b="0">
-                <a:solidFill>
-                  <a:srgbClr val="5E6864"/>
-                </a:solidFill>
-                <a:latin typeface="Helvetica Neue"/>
-                <a:ea typeface="Helvetica Neue"/>
-                <a:cs typeface="Helvetica Neue"/>
-              </a:defRPr>
-            </a:pPr>
-            <a:r>
-              <a:rPr sz="1050" b="0">
-                <a:solidFill>
-                  <a:srgbClr val="5E6864"/>
-                </a:solidFill>
-                <a:latin typeface="Helvetica Neue"/>
-                <a:ea typeface="Helvetica Neue"/>
-                <a:cs typeface="Helvetica Neue"/>
-              </a:rPr>
-              <a:t>Baseline</a:t>
+                  <a:srgbClr val="174F3C"/>
+                </a:solidFill>
+                <a:latin typeface="Helvetica Neue"/>
+                <a:ea typeface="Helvetica Neue"/>
+                <a:cs typeface="Helvetica Neue"/>
+              </a:rPr>
+              <a:t>0.222</a:t>
+            </a:r>
+          </a:p>
+        </p:txBody>
+      </p:sp>
+      <p:sp>
+        <p:nvSpPr>
+          <p:cNvPr id="19" name="text-452-338">
+            <a:extLst xmlns:a="http://schemas.openxmlformats.org/drawingml/2006/main">
+              <a:ext uri="{FF2B5EF4-FFF2-40B4-BE49-F238E27FC236}">
+                <a16:creationId xmlns:a16="http://schemas.microsoft.com/office/drawing/2014/main" id="{5B40D47F-E985-4F5B-97D9-201015489297}"/>
+              </a:ext>
+            </a:extLst>
+          </p:cNvPr>
+          <p:cNvSpPr>
+            <a:spLocks xmlns:a="http://schemas.openxmlformats.org/drawingml/2006/main" noGrp="1"/>
+          </p:cNvSpPr>
+          <p:nvPr/>
+        </p:nvSpPr>
+        <p:spPr>
+          <a:xfrm xmlns:a="http://schemas.openxmlformats.org/drawingml/2006/main">
+            <a:off x="4305300" y="3219450"/>
+            <a:ext cx="952500" cy="219075"/>
+          </a:xfrm>
+          <a:prstGeom xmlns:a="http://schemas.openxmlformats.org/drawingml/2006/main" prst="rect">
+            <a:avLst/>
+          </a:prstGeom>
+          <a:noFill xmlns:a="http://schemas.openxmlformats.org/drawingml/2006/main"/>
+          <a:ln xmlns:a="http://schemas.openxmlformats.org/drawingml/2006/main" w="0">
+            <a:noFill/>
+            <a:prstDash val="solid"/>
+          </a:ln>
+        </p:spPr>
+        <p:txBody>
+          <a:bodyPr xmlns:a="http://schemas.openxmlformats.org/drawingml/2006/main" wrap="square" lIns="0" tIns="0" rIns="0" bIns="0" anchor="t">
+            <a:normAutofit fontScale="100000"/>
+          </a:bodyPr>
+          <a:lstStyle xmlns:a="http://schemas.openxmlformats.org/drawingml/2006/main"/>
+          <a:p xmlns:a="http://schemas.openxmlformats.org/drawingml/2006/main">
+            <a:pPr algn="l">
+              <a:defRPr sz="1050" b="1">
+                <a:solidFill>
+                  <a:srgbClr val="174F3C"/>
+                </a:solidFill>
+                <a:latin typeface="Helvetica Neue"/>
+                <a:ea typeface="Helvetica Neue"/>
+                <a:cs typeface="Helvetica Neue"/>
+              </a:defRPr>
+            </a:pPr>
+            <a:r>
+              <a:rPr sz="1050" b="1">
+                <a:solidFill>
+                  <a:srgbClr val="174F3C"/>
+                </a:solidFill>
+                <a:latin typeface="Helvetica Neue"/>
+                <a:ea typeface="Helvetica Neue"/>
+                <a:cs typeface="Helvetica Neue"/>
+              </a:rPr>
+              <a:t>Selected</a:t>
             </a:r>
           </a:p>
         </p:txBody>
@@ -12502,7 +12502,7 @@
           <p:cNvPr id="20" name="model-table-row-286-1">
             <a:extLst xmlns:a="http://schemas.openxmlformats.org/drawingml/2006/main">
               <a:ext uri="{FF2B5EF4-FFF2-40B4-BE49-F238E27FC236}">
-                <a16:creationId xmlns:a16="http://schemas.microsoft.com/office/drawing/2014/main" id="{118ED843-A87C-4D9B-AB0F-B7C33036725D}"/>
+                <a16:creationId xmlns:a16="http://schemas.microsoft.com/office/drawing/2014/main" id="{30D935CB-8941-4C71-A420-FDA461176819}"/>
               </a:ext>
             </a:extLst>
           </p:cNvPr>
@@ -12555,7 +12555,7 @@
           <p:cNvPr id="22" name="text-50-381">
             <a:extLst xmlns:a="http://schemas.openxmlformats.org/drawingml/2006/main">
               <a:ext uri="{FF2B5EF4-FFF2-40B4-BE49-F238E27FC236}">
-                <a16:creationId xmlns:a16="http://schemas.microsoft.com/office/drawing/2014/main" id="{81C6B3C7-AB64-49F4-B901-2942026C814D}"/>
+                <a16:creationId xmlns:a16="http://schemas.microsoft.com/office/drawing/2014/main" id="{10108A61-67FD-4F39-AA76-36CD89EC689F}"/>
               </a:ext>
             </a:extLst>
           </p:cNvPr>
@@ -12567,37 +12567,37 @@
         <p:spPr>
           <a:xfrm xmlns:a="http://schemas.openxmlformats.org/drawingml/2006/main">
             <a:off x="476250" y="3629025"/>
-            <a:ext cx="1485900" cy="219075"/>
-          </a:xfrm>
-          <a:prstGeom xmlns:a="http://schemas.openxmlformats.org/drawingml/2006/main" prst="rect">
-            <a:avLst/>
-          </a:prstGeom>
-          <a:noFill xmlns:a="http://schemas.openxmlformats.org/drawingml/2006/main"/>
-          <a:ln xmlns:a="http://schemas.openxmlformats.org/drawingml/2006/main" w="0">
-            <a:noFill/>
-            <a:prstDash val="solid"/>
-          </a:ln>
-        </p:spPr>
-        <p:txBody>
-          <a:bodyPr xmlns:a="http://schemas.openxmlformats.org/drawingml/2006/main" wrap="square" lIns="0" tIns="0" rIns="0" bIns="0" anchor="t">
-            <a:normAutofit fontScale="100000"/>
-          </a:bodyPr>
-          <a:lstStyle xmlns:a="http://schemas.openxmlformats.org/drawingml/2006/main"/>
-          <a:p xmlns:a="http://schemas.openxmlformats.org/drawingml/2006/main">
-            <a:pPr algn="l">
-              <a:defRPr sz="1050" b="1">
-                <a:solidFill>
-                  <a:srgbClr val="174F3C"/>
-                </a:solidFill>
-                <a:latin typeface="Helvetica Neue"/>
-                <a:ea typeface="Helvetica Neue"/>
-                <a:cs typeface="Helvetica Neue"/>
-              </a:defRPr>
-            </a:pPr>
-            <a:r>
-              <a:rPr sz="1050" b="1">
-                <a:solidFill>
-                  <a:srgbClr val="174F3C"/>
+            <a:ext cx="1371600" cy="219075"/>
+          </a:xfrm>
+          <a:prstGeom xmlns:a="http://schemas.openxmlformats.org/drawingml/2006/main" prst="rect">
+            <a:avLst/>
+          </a:prstGeom>
+          <a:noFill xmlns:a="http://schemas.openxmlformats.org/drawingml/2006/main"/>
+          <a:ln xmlns:a="http://schemas.openxmlformats.org/drawingml/2006/main" w="0">
+            <a:noFill/>
+            <a:prstDash val="solid"/>
+          </a:ln>
+        </p:spPr>
+        <p:txBody>
+          <a:bodyPr xmlns:a="http://schemas.openxmlformats.org/drawingml/2006/main" wrap="square" lIns="0" tIns="0" rIns="0" bIns="0" anchor="t">
+            <a:normAutofit fontScale="100000"/>
+          </a:bodyPr>
+          <a:lstStyle xmlns:a="http://schemas.openxmlformats.org/drawingml/2006/main"/>
+          <a:p xmlns:a="http://schemas.openxmlformats.org/drawingml/2006/main">
+            <a:pPr algn="l">
+              <a:defRPr sz="1050" b="0">
+                <a:solidFill>
+                  <a:srgbClr val="111111"/>
+                </a:solidFill>
+                <a:latin typeface="Helvetica Neue"/>
+                <a:ea typeface="Helvetica Neue"/>
+                <a:cs typeface="Helvetica Neue"/>
+              </a:defRPr>
+            </a:pPr>
+            <a:r>
+              <a:rPr sz="1050" b="0">
+                <a:solidFill>
+                  <a:srgbClr val="111111"/>
                 </a:solidFill>
                 <a:latin typeface="Helvetica Neue"/>
                 <a:ea typeface="Helvetica Neue"/>
@@ -12610,21 +12610,21 @@
       </p:sp>
       <p:sp>
         <p:nvSpPr>
-          <p:cNvPr id="23" name="text-222-381">
-            <a:extLst xmlns:a="http://schemas.openxmlformats.org/drawingml/2006/main">
-              <a:ext uri="{FF2B5EF4-FFF2-40B4-BE49-F238E27FC236}">
-                <a16:creationId xmlns:a16="http://schemas.microsoft.com/office/drawing/2014/main" id="{5591E5FE-B17C-4A3D-B5BE-61C9775B38F8}"/>
-              </a:ext>
-            </a:extLst>
-          </p:cNvPr>
-          <p:cNvSpPr>
-            <a:spLocks xmlns:a="http://schemas.openxmlformats.org/drawingml/2006/main" noGrp="1"/>
-          </p:cNvSpPr>
-          <p:nvPr/>
-        </p:nvSpPr>
-        <p:spPr>
-          <a:xfrm xmlns:a="http://schemas.openxmlformats.org/drawingml/2006/main">
-            <a:off x="2114550" y="3629025"/>
+          <p:cNvPr id="23" name="text-210-381">
+            <a:extLst xmlns:a="http://schemas.openxmlformats.org/drawingml/2006/main">
+              <a:ext uri="{FF2B5EF4-FFF2-40B4-BE49-F238E27FC236}">
+                <a16:creationId xmlns:a16="http://schemas.microsoft.com/office/drawing/2014/main" id="{38488D50-33BC-4711-A290-F124545D4FC1}"/>
+              </a:ext>
+            </a:extLst>
+          </p:cNvPr>
+          <p:cNvSpPr>
+            <a:spLocks xmlns:a="http://schemas.openxmlformats.org/drawingml/2006/main" noGrp="1"/>
+          </p:cNvSpPr>
+          <p:nvPr/>
+        </p:nvSpPr>
+        <p:spPr>
+          <a:xfrm xmlns:a="http://schemas.openxmlformats.org/drawingml/2006/main">
+            <a:off x="2000250" y="3629025"/>
             <a:ext cx="685800" cy="219075"/>
           </a:xfrm>
           <a:prstGeom xmlns:a="http://schemas.openxmlformats.org/drawingml/2006/main" prst="rect">
@@ -12645,7 +12645,7 @@
             <a:pPr algn="r">
               <a:defRPr sz="1050" b="1">
                 <a:solidFill>
-                  <a:srgbClr val="174F3C"/>
+                  <a:srgbClr val="111111"/>
                 </a:solidFill>
                 <a:latin typeface="Helvetica Neue"/>
                 <a:ea typeface="Helvetica Neue"/>
@@ -12655,34 +12655,34 @@
             <a:r>
               <a:rPr sz="1050" b="1">
                 <a:solidFill>
-                  <a:srgbClr val="174F3C"/>
-                </a:solidFill>
-                <a:latin typeface="Helvetica Neue"/>
-                <a:ea typeface="Helvetica Neue"/>
-                <a:cs typeface="Helvetica Neue"/>
-              </a:rPr>
-              <a:t>1.48 pts</a:t>
-            </a:r>
-          </a:p>
-        </p:txBody>
-      </p:sp>
-      <p:sp>
-        <p:nvSpPr>
-          <p:cNvPr id="24" name="text-310-381">
-            <a:extLst xmlns:a="http://schemas.openxmlformats.org/drawingml/2006/main">
-              <a:ext uri="{FF2B5EF4-FFF2-40B4-BE49-F238E27FC236}">
-                <a16:creationId xmlns:a16="http://schemas.microsoft.com/office/drawing/2014/main" id="{D4AE9C7D-7651-47E2-82E7-F5F8099FFAFC}"/>
-              </a:ext>
-            </a:extLst>
-          </p:cNvPr>
-          <p:cNvSpPr>
-            <a:spLocks xmlns:a="http://schemas.openxmlformats.org/drawingml/2006/main" noGrp="1"/>
-          </p:cNvSpPr>
-          <p:nvPr/>
-        </p:nvSpPr>
-        <p:spPr>
-          <a:xfrm xmlns:a="http://schemas.openxmlformats.org/drawingml/2006/main">
-            <a:off x="2952750" y="3629025"/>
+                  <a:srgbClr val="111111"/>
+                </a:solidFill>
+                <a:latin typeface="Helvetica Neue"/>
+                <a:ea typeface="Helvetica Neue"/>
+                <a:cs typeface="Helvetica Neue"/>
+              </a:rPr>
+              <a:t>1.40 pts</a:t>
+            </a:r>
+          </a:p>
+        </p:txBody>
+      </p:sp>
+      <p:sp>
+        <p:nvSpPr>
+          <p:cNvPr id="24" name="text-298-381">
+            <a:extLst xmlns:a="http://schemas.openxmlformats.org/drawingml/2006/main">
+              <a:ext uri="{FF2B5EF4-FFF2-40B4-BE49-F238E27FC236}">
+                <a16:creationId xmlns:a16="http://schemas.microsoft.com/office/drawing/2014/main" id="{12679CBA-D7E7-4327-BC32-F61392BDB9B8}"/>
+              </a:ext>
+            </a:extLst>
+          </p:cNvPr>
+          <p:cNvSpPr>
+            <a:spLocks xmlns:a="http://schemas.openxmlformats.org/drawingml/2006/main" noGrp="1"/>
+          </p:cNvSpPr>
+          <p:nvPr/>
+        </p:nvSpPr>
+        <p:spPr>
+          <a:xfrm xmlns:a="http://schemas.openxmlformats.org/drawingml/2006/main">
+            <a:off x="2838450" y="3629025"/>
             <a:ext cx="628650" cy="219075"/>
           </a:xfrm>
           <a:prstGeom xmlns:a="http://schemas.openxmlformats.org/drawingml/2006/main" prst="rect">
@@ -12703,7 +12703,7 @@
             <a:pPr algn="r">
               <a:defRPr sz="1050" b="1">
                 <a:solidFill>
-                  <a:srgbClr val="174F3C"/>
+                  <a:srgbClr val="111111"/>
                 </a:solidFill>
                 <a:latin typeface="Helvetica Neue"/>
                 <a:ea typeface="Helvetica Neue"/>
@@ -12713,35 +12713,35 @@
             <a:r>
               <a:rPr sz="1050" b="1">
                 <a:solidFill>
-                  <a:srgbClr val="174F3C"/>
-                </a:solidFill>
-                <a:latin typeface="Helvetica Neue"/>
-                <a:ea typeface="Helvetica Neue"/>
-                <a:cs typeface="Helvetica Neue"/>
-              </a:rPr>
-              <a:t>1.84 pts</a:t>
-            </a:r>
-          </a:p>
-        </p:txBody>
-      </p:sp>
-      <p:sp>
-        <p:nvSpPr>
-          <p:cNvPr id="25" name="text-392-381">
-            <a:extLst xmlns:a="http://schemas.openxmlformats.org/drawingml/2006/main">
-              <a:ext uri="{FF2B5EF4-FFF2-40B4-BE49-F238E27FC236}">
-                <a16:creationId xmlns:a16="http://schemas.microsoft.com/office/drawing/2014/main" id="{0D36DDF3-E7BD-4019-A5FC-E5C4D56D56D8}"/>
-              </a:ext>
-            </a:extLst>
-          </p:cNvPr>
-          <p:cNvSpPr>
-            <a:spLocks xmlns:a="http://schemas.openxmlformats.org/drawingml/2006/main" noGrp="1"/>
-          </p:cNvSpPr>
-          <p:nvPr/>
-        </p:nvSpPr>
-        <p:spPr>
-          <a:xfrm xmlns:a="http://schemas.openxmlformats.org/drawingml/2006/main">
-            <a:off x="3733800" y="3629025"/>
-            <a:ext cx="400050" cy="219075"/>
+                  <a:srgbClr val="111111"/>
+                </a:solidFill>
+                <a:latin typeface="Helvetica Neue"/>
+                <a:ea typeface="Helvetica Neue"/>
+                <a:cs typeface="Helvetica Neue"/>
+              </a:rPr>
+              <a:t>1.80 pts</a:t>
+            </a:r>
+          </a:p>
+        </p:txBody>
+      </p:sp>
+      <p:sp>
+        <p:nvSpPr>
+          <p:cNvPr id="25" name="text-380-381">
+            <a:extLst xmlns:a="http://schemas.openxmlformats.org/drawingml/2006/main">
+              <a:ext uri="{FF2B5EF4-FFF2-40B4-BE49-F238E27FC236}">
+                <a16:creationId xmlns:a16="http://schemas.microsoft.com/office/drawing/2014/main" id="{66B16BE7-626D-4025-843D-24DE7BD02D82}"/>
+              </a:ext>
+            </a:extLst>
+          </p:cNvPr>
+          <p:cNvSpPr>
+            <a:spLocks xmlns:a="http://schemas.openxmlformats.org/drawingml/2006/main" noGrp="1"/>
+          </p:cNvSpPr>
+          <p:nvPr/>
+        </p:nvSpPr>
+        <p:spPr>
+          <a:xfrm xmlns:a="http://schemas.openxmlformats.org/drawingml/2006/main">
+            <a:off x="3619500" y="3629025"/>
+            <a:ext cx="533400" cy="219075"/>
           </a:xfrm>
           <a:prstGeom xmlns:a="http://schemas.openxmlformats.org/drawingml/2006/main" prst="rect">
             <a:avLst/>
@@ -12761,7 +12761,7 @@
             <a:pPr algn="r">
               <a:defRPr sz="1050" b="1">
                 <a:solidFill>
-                  <a:srgbClr val="174F3C"/>
+                  <a:srgbClr val="111111"/>
                 </a:solidFill>
                 <a:latin typeface="Helvetica Neue"/>
                 <a:ea typeface="Helvetica Neue"/>
@@ -12771,71 +12771,71 @@
             <a:r>
               <a:rPr sz="1050" b="1">
                 <a:solidFill>
-                  <a:srgbClr val="174F3C"/>
-                </a:solidFill>
-                <a:latin typeface="Helvetica Neue"/>
-                <a:ea typeface="Helvetica Neue"/>
-                <a:cs typeface="Helvetica Neue"/>
-              </a:rPr>
-              <a:t>0.189</a:t>
-            </a:r>
-          </a:p>
-        </p:txBody>
-      </p:sp>
-      <p:sp>
-        <p:nvSpPr>
-          <p:cNvPr id="26" name="text-450-381">
-            <a:extLst xmlns:a="http://schemas.openxmlformats.org/drawingml/2006/main">
-              <a:ext uri="{FF2B5EF4-FFF2-40B4-BE49-F238E27FC236}">
-                <a16:creationId xmlns:a16="http://schemas.microsoft.com/office/drawing/2014/main" id="{7E1FA335-9C60-4706-855E-BA7FC630BD72}"/>
-              </a:ext>
-            </a:extLst>
-          </p:cNvPr>
-          <p:cNvSpPr>
-            <a:spLocks xmlns:a="http://schemas.openxmlformats.org/drawingml/2006/main" noGrp="1"/>
-          </p:cNvSpPr>
-          <p:nvPr/>
-        </p:nvSpPr>
-        <p:spPr>
-          <a:xfrm xmlns:a="http://schemas.openxmlformats.org/drawingml/2006/main">
-            <a:off x="4286250" y="3629025"/>
-            <a:ext cx="971550" cy="219075"/>
-          </a:xfrm>
-          <a:prstGeom xmlns:a="http://schemas.openxmlformats.org/drawingml/2006/main" prst="rect">
-            <a:avLst/>
-          </a:prstGeom>
-          <a:noFill xmlns:a="http://schemas.openxmlformats.org/drawingml/2006/main"/>
-          <a:ln xmlns:a="http://schemas.openxmlformats.org/drawingml/2006/main" w="0">
-            <a:noFill/>
-            <a:prstDash val="solid"/>
-          </a:ln>
-        </p:spPr>
-        <p:txBody>
-          <a:bodyPr xmlns:a="http://schemas.openxmlformats.org/drawingml/2006/main" wrap="square" lIns="0" tIns="0" rIns="0" bIns="0" anchor="t">
-            <a:normAutofit fontScale="100000"/>
-          </a:bodyPr>
-          <a:lstStyle xmlns:a="http://schemas.openxmlformats.org/drawingml/2006/main"/>
-          <a:p xmlns:a="http://schemas.openxmlformats.org/drawingml/2006/main">
-            <a:pPr algn="l">
-              <a:defRPr sz="1050" b="1">
-                <a:solidFill>
-                  <a:srgbClr val="174F3C"/>
-                </a:solidFill>
-                <a:latin typeface="Helvetica Neue"/>
-                <a:ea typeface="Helvetica Neue"/>
-                <a:cs typeface="Helvetica Neue"/>
-              </a:defRPr>
-            </a:pPr>
-            <a:r>
-              <a:rPr sz="1050" b="1">
-                <a:solidFill>
-                  <a:srgbClr val="174F3C"/>
-                </a:solidFill>
-                <a:latin typeface="Helvetica Neue"/>
-                <a:ea typeface="Helvetica Neue"/>
-                <a:cs typeface="Helvetica Neue"/>
-              </a:rPr>
-              <a:t>Selected</a:t>
+                  <a:srgbClr val="111111"/>
+                </a:solidFill>
+                <a:latin typeface="Helvetica Neue"/>
+                <a:ea typeface="Helvetica Neue"/>
+                <a:cs typeface="Helvetica Neue"/>
+              </a:rPr>
+              <a:t>0.224</a:t>
+            </a:r>
+          </a:p>
+        </p:txBody>
+      </p:sp>
+      <p:sp>
+        <p:nvSpPr>
+          <p:cNvPr id="26" name="text-452-381">
+            <a:extLst xmlns:a="http://schemas.openxmlformats.org/drawingml/2006/main">
+              <a:ext uri="{FF2B5EF4-FFF2-40B4-BE49-F238E27FC236}">
+                <a16:creationId xmlns:a16="http://schemas.microsoft.com/office/drawing/2014/main" id="{3FB1BDF3-672B-4AA6-B225-39B383965BC4}"/>
+              </a:ext>
+            </a:extLst>
+          </p:cNvPr>
+          <p:cNvSpPr>
+            <a:spLocks xmlns:a="http://schemas.openxmlformats.org/drawingml/2006/main" noGrp="1"/>
+          </p:cNvSpPr>
+          <p:nvPr/>
+        </p:nvSpPr>
+        <p:spPr>
+          <a:xfrm xmlns:a="http://schemas.openxmlformats.org/drawingml/2006/main">
+            <a:off x="4305300" y="3629025"/>
+            <a:ext cx="952500" cy="219075"/>
+          </a:xfrm>
+          <a:prstGeom xmlns:a="http://schemas.openxmlformats.org/drawingml/2006/main" prst="rect">
+            <a:avLst/>
+          </a:prstGeom>
+          <a:noFill xmlns:a="http://schemas.openxmlformats.org/drawingml/2006/main"/>
+          <a:ln xmlns:a="http://schemas.openxmlformats.org/drawingml/2006/main" w="0">
+            <a:noFill/>
+            <a:prstDash val="solid"/>
+          </a:ln>
+        </p:spPr>
+        <p:txBody>
+          <a:bodyPr xmlns:a="http://schemas.openxmlformats.org/drawingml/2006/main" wrap="square" lIns="0" tIns="0" rIns="0" bIns="0" anchor="t">
+            <a:normAutofit fontScale="100000"/>
+          </a:bodyPr>
+          <a:lstStyle xmlns:a="http://schemas.openxmlformats.org/drawingml/2006/main"/>
+          <a:p xmlns:a="http://schemas.openxmlformats.org/drawingml/2006/main">
+            <a:pPr algn="l">
+              <a:defRPr sz="1050" b="0">
+                <a:solidFill>
+                  <a:srgbClr val="5E6864"/>
+                </a:solidFill>
+                <a:latin typeface="Helvetica Neue"/>
+                <a:ea typeface="Helvetica Neue"/>
+                <a:cs typeface="Helvetica Neue"/>
+              </a:defRPr>
+            </a:pPr>
+            <a:r>
+              <a:rPr sz="1050" b="0">
+                <a:solidFill>
+                  <a:srgbClr val="5E6864"/>
+                </a:solidFill>
+                <a:latin typeface="Helvetica Neue"/>
+                <a:ea typeface="Helvetica Neue"/>
+                <a:cs typeface="Helvetica Neue"/>
+              </a:rPr>
+              <a:t>Compared</a:t>
             </a:r>
           </a:p>
         </p:txBody>
@@ -12845,7 +12845,7 @@
           <p:cNvPr id="27" name="model-table-row-286-2">
             <a:extLst xmlns:a="http://schemas.openxmlformats.org/drawingml/2006/main">
               <a:ext uri="{FF2B5EF4-FFF2-40B4-BE49-F238E27FC236}">
-                <a16:creationId xmlns:a16="http://schemas.microsoft.com/office/drawing/2014/main" id="{45A7C716-95DB-40EB-8B7E-C47BCFC28D68}"/>
+                <a16:creationId xmlns:a16="http://schemas.microsoft.com/office/drawing/2014/main" id="{02BA0D01-0D14-4825-8F9F-2D8EBB468721}"/>
               </a:ext>
             </a:extLst>
           </p:cNvPr>
@@ -12898,7 +12898,7 @@
           <p:cNvPr id="29" name="text-50-424">
             <a:extLst xmlns:a="http://schemas.openxmlformats.org/drawingml/2006/main">
               <a:ext uri="{FF2B5EF4-FFF2-40B4-BE49-F238E27FC236}">
-                <a16:creationId xmlns:a16="http://schemas.microsoft.com/office/drawing/2014/main" id="{BB4CDEE9-4FBD-4340-84FD-C286C92CFFA7}"/>
+                <a16:creationId xmlns:a16="http://schemas.microsoft.com/office/drawing/2014/main" id="{B63D44F8-6DB4-4F60-8A1E-31C56F4A8BD3}"/>
               </a:ext>
             </a:extLst>
           </p:cNvPr>
@@ -12910,7 +12910,7 @@
         <p:spPr>
           <a:xfrm xmlns:a="http://schemas.openxmlformats.org/drawingml/2006/main">
             <a:off x="476250" y="4038600"/>
-            <a:ext cx="1485900" cy="219075"/>
+            <a:ext cx="1371600" cy="219075"/>
           </a:xfrm>
           <a:prstGeom xmlns:a="http://schemas.openxmlformats.org/drawingml/2006/main" prst="rect">
             <a:avLst/>
@@ -12946,28 +12946,28 @@
                 <a:ea typeface="Helvetica Neue"/>
                 <a:cs typeface="Helvetica Neue"/>
               </a:rPr>
-              <a:t>Compact Ridge</a:t>
-            </a:r>
-          </a:p>
-        </p:txBody>
-      </p:sp>
-      <p:sp>
-        <p:nvSpPr>
-          <p:cNvPr id="30" name="text-222-424">
-            <a:extLst xmlns:a="http://schemas.openxmlformats.org/drawingml/2006/main">
-              <a:ext uri="{FF2B5EF4-FFF2-40B4-BE49-F238E27FC236}">
-                <a16:creationId xmlns:a16="http://schemas.microsoft.com/office/drawing/2014/main" id="{F674FD8A-8462-4F9F-A1CA-4B57A4590661}"/>
-              </a:ext>
-            </a:extLst>
-          </p:cNvPr>
-          <p:cNvSpPr>
-            <a:spLocks xmlns:a="http://schemas.openxmlformats.org/drawingml/2006/main" noGrp="1"/>
-          </p:cNvSpPr>
-          <p:nvPr/>
-        </p:nvSpPr>
-        <p:spPr>
-          <a:xfrm xmlns:a="http://schemas.openxmlformats.org/drawingml/2006/main">
-            <a:off x="2114550" y="4038600"/>
+              <a:t>Ridge</a:t>
+            </a:r>
+          </a:p>
+        </p:txBody>
+      </p:sp>
+      <p:sp>
+        <p:nvSpPr>
+          <p:cNvPr id="30" name="text-210-424">
+            <a:extLst xmlns:a="http://schemas.openxmlformats.org/drawingml/2006/main">
+              <a:ext uri="{FF2B5EF4-FFF2-40B4-BE49-F238E27FC236}">
+                <a16:creationId xmlns:a16="http://schemas.microsoft.com/office/drawing/2014/main" id="{E85ED9DC-BB52-449B-8FA3-8395D294B044}"/>
+              </a:ext>
+            </a:extLst>
+          </p:cNvPr>
+          <p:cNvSpPr>
+            <a:spLocks xmlns:a="http://schemas.openxmlformats.org/drawingml/2006/main" noGrp="1"/>
+          </p:cNvSpPr>
+          <p:nvPr/>
+        </p:nvSpPr>
+        <p:spPr>
+          <a:xfrm xmlns:a="http://schemas.openxmlformats.org/drawingml/2006/main">
+            <a:off x="2000250" y="4038600"/>
             <a:ext cx="685800" cy="219075"/>
           </a:xfrm>
           <a:prstGeom xmlns:a="http://schemas.openxmlformats.org/drawingml/2006/main" prst="rect">
@@ -13004,28 +13004,28 @@
                 <a:ea typeface="Helvetica Neue"/>
                 <a:cs typeface="Helvetica Neue"/>
               </a:rPr>
-              <a:t>1.59 pts</a:t>
-            </a:r>
-          </a:p>
-        </p:txBody>
-      </p:sp>
-      <p:sp>
-        <p:nvSpPr>
-          <p:cNvPr id="31" name="text-310-424">
-            <a:extLst xmlns:a="http://schemas.openxmlformats.org/drawingml/2006/main">
-              <a:ext uri="{FF2B5EF4-FFF2-40B4-BE49-F238E27FC236}">
-                <a16:creationId xmlns:a16="http://schemas.microsoft.com/office/drawing/2014/main" id="{348728FA-E25F-4279-ABD5-CFB88AF89542}"/>
-              </a:ext>
-            </a:extLst>
-          </p:cNvPr>
-          <p:cNvSpPr>
-            <a:spLocks xmlns:a="http://schemas.openxmlformats.org/drawingml/2006/main" noGrp="1"/>
-          </p:cNvSpPr>
-          <p:nvPr/>
-        </p:nvSpPr>
-        <p:spPr>
-          <a:xfrm xmlns:a="http://schemas.openxmlformats.org/drawingml/2006/main">
-            <a:off x="2952750" y="4038600"/>
+              <a:t>1.43 pts</a:t>
+            </a:r>
+          </a:p>
+        </p:txBody>
+      </p:sp>
+      <p:sp>
+        <p:nvSpPr>
+          <p:cNvPr id="31" name="text-298-424">
+            <a:extLst xmlns:a="http://schemas.openxmlformats.org/drawingml/2006/main">
+              <a:ext uri="{FF2B5EF4-FFF2-40B4-BE49-F238E27FC236}">
+                <a16:creationId xmlns:a16="http://schemas.microsoft.com/office/drawing/2014/main" id="{176A12DA-3911-42F1-B3C4-9F4C9A3BC59C}"/>
+              </a:ext>
+            </a:extLst>
+          </p:cNvPr>
+          <p:cNvSpPr>
+            <a:spLocks xmlns:a="http://schemas.openxmlformats.org/drawingml/2006/main" noGrp="1"/>
+          </p:cNvSpPr>
+          <p:nvPr/>
+        </p:nvSpPr>
+        <p:spPr>
+          <a:xfrm xmlns:a="http://schemas.openxmlformats.org/drawingml/2006/main">
+            <a:off x="2838450" y="4038600"/>
             <a:ext cx="628650" cy="219075"/>
           </a:xfrm>
           <a:prstGeom xmlns:a="http://schemas.openxmlformats.org/drawingml/2006/main" prst="rect">
@@ -13062,29 +13062,29 @@
                 <a:ea typeface="Helvetica Neue"/>
                 <a:cs typeface="Helvetica Neue"/>
               </a:rPr>
-              <a:t>1.97 pts</a:t>
-            </a:r>
-          </a:p>
-        </p:txBody>
-      </p:sp>
-      <p:sp>
-        <p:nvSpPr>
-          <p:cNvPr id="32" name="text-392-424">
-            <a:extLst xmlns:a="http://schemas.openxmlformats.org/drawingml/2006/main">
-              <a:ext uri="{FF2B5EF4-FFF2-40B4-BE49-F238E27FC236}">
-                <a16:creationId xmlns:a16="http://schemas.microsoft.com/office/drawing/2014/main" id="{9C032FEE-A161-42B5-96CF-0D060C99F668}"/>
-              </a:ext>
-            </a:extLst>
-          </p:cNvPr>
-          <p:cNvSpPr>
-            <a:spLocks xmlns:a="http://schemas.openxmlformats.org/drawingml/2006/main" noGrp="1"/>
-          </p:cNvSpPr>
-          <p:nvPr/>
-        </p:nvSpPr>
-        <p:spPr>
-          <a:xfrm xmlns:a="http://schemas.openxmlformats.org/drawingml/2006/main">
-            <a:off x="3733800" y="4038600"/>
-            <a:ext cx="400050" cy="219075"/>
+              <a:t>1.82 pts</a:t>
+            </a:r>
+          </a:p>
+        </p:txBody>
+      </p:sp>
+      <p:sp>
+        <p:nvSpPr>
+          <p:cNvPr id="32" name="text-380-424">
+            <a:extLst xmlns:a="http://schemas.openxmlformats.org/drawingml/2006/main">
+              <a:ext uri="{FF2B5EF4-FFF2-40B4-BE49-F238E27FC236}">
+                <a16:creationId xmlns:a16="http://schemas.microsoft.com/office/drawing/2014/main" id="{0EB462FA-D526-4687-8114-6982091B6E89}"/>
+              </a:ext>
+            </a:extLst>
+          </p:cNvPr>
+          <p:cNvSpPr>
+            <a:spLocks xmlns:a="http://schemas.openxmlformats.org/drawingml/2006/main" noGrp="1"/>
+          </p:cNvSpPr>
+          <p:nvPr/>
+        </p:nvSpPr>
+        <p:spPr>
+          <a:xfrm xmlns:a="http://schemas.openxmlformats.org/drawingml/2006/main">
+            <a:off x="3619500" y="4038600"/>
+            <a:ext cx="533400" cy="219075"/>
           </a:xfrm>
           <a:prstGeom xmlns:a="http://schemas.openxmlformats.org/drawingml/2006/main" prst="rect">
             <a:avLst/>
@@ -13120,29 +13120,29 @@
                 <a:ea typeface="Helvetica Neue"/>
                 <a:cs typeface="Helvetica Neue"/>
               </a:rPr>
-              <a:t>0.070</a:t>
-            </a:r>
-          </a:p>
-        </p:txBody>
-      </p:sp>
-      <p:sp>
-        <p:nvSpPr>
-          <p:cNvPr id="33" name="text-450-424">
-            <a:extLst xmlns:a="http://schemas.openxmlformats.org/drawingml/2006/main">
-              <a:ext uri="{FF2B5EF4-FFF2-40B4-BE49-F238E27FC236}">
-                <a16:creationId xmlns:a16="http://schemas.microsoft.com/office/drawing/2014/main" id="{339DB68A-9B8B-409D-A007-5CE5CC211377}"/>
-              </a:ext>
-            </a:extLst>
-          </p:cNvPr>
-          <p:cNvSpPr>
-            <a:spLocks xmlns:a="http://schemas.openxmlformats.org/drawingml/2006/main" noGrp="1"/>
-          </p:cNvSpPr>
-          <p:nvPr/>
-        </p:nvSpPr>
-        <p:spPr>
-          <a:xfrm xmlns:a="http://schemas.openxmlformats.org/drawingml/2006/main">
-            <a:off x="4286250" y="4038600"/>
-            <a:ext cx="971550" cy="219075"/>
+              <a:t>0.207</a:t>
+            </a:r>
+          </a:p>
+        </p:txBody>
+      </p:sp>
+      <p:sp>
+        <p:nvSpPr>
+          <p:cNvPr id="33" name="text-452-424">
+            <a:extLst xmlns:a="http://schemas.openxmlformats.org/drawingml/2006/main">
+              <a:ext uri="{FF2B5EF4-FFF2-40B4-BE49-F238E27FC236}">
+                <a16:creationId xmlns:a16="http://schemas.microsoft.com/office/drawing/2014/main" id="{0E923B0B-E0FD-4CAD-ACAA-AC1394612055}"/>
+              </a:ext>
+            </a:extLst>
+          </p:cNvPr>
+          <p:cNvSpPr>
+            <a:spLocks xmlns:a="http://schemas.openxmlformats.org/drawingml/2006/main" noGrp="1"/>
+          </p:cNvSpPr>
+          <p:nvPr/>
+        </p:nvSpPr>
+        <p:spPr>
+          <a:xfrm xmlns:a="http://schemas.openxmlformats.org/drawingml/2006/main">
+            <a:off x="4305300" y="4038600"/>
+            <a:ext cx="952500" cy="219075"/>
           </a:xfrm>
           <a:prstGeom xmlns:a="http://schemas.openxmlformats.org/drawingml/2006/main" prst="rect">
             <a:avLst/>
@@ -13188,7 +13188,7 @@
           <p:cNvPr id="34" name="model-table-row-286-3">
             <a:extLst xmlns:a="http://schemas.openxmlformats.org/drawingml/2006/main">
               <a:ext uri="{FF2B5EF4-FFF2-40B4-BE49-F238E27FC236}">
-                <a16:creationId xmlns:a16="http://schemas.microsoft.com/office/drawing/2014/main" id="{34DE54E8-11A6-4626-A266-2E2AE48F8681}"/>
+                <a16:creationId xmlns:a16="http://schemas.microsoft.com/office/drawing/2014/main" id="{55F18CC4-FDDC-42DD-AF6C-E0ED21196BB4}"/>
               </a:ext>
             </a:extLst>
           </p:cNvPr>
@@ -13241,7 +13241,7 @@
           <p:cNvPr id="36" name="text-50-467">
             <a:extLst xmlns:a="http://schemas.openxmlformats.org/drawingml/2006/main">
               <a:ext uri="{FF2B5EF4-FFF2-40B4-BE49-F238E27FC236}">
-                <a16:creationId xmlns:a16="http://schemas.microsoft.com/office/drawing/2014/main" id="{30A7B254-A2C8-4057-AE64-D1A32056E0C6}"/>
+                <a16:creationId xmlns:a16="http://schemas.microsoft.com/office/drawing/2014/main" id="{280AE9E7-1E75-47D8-98A6-FAD9E85648A6}"/>
               </a:ext>
             </a:extLst>
           </p:cNvPr>
@@ -13253,7 +13253,7 @@
         <p:spPr>
           <a:xfrm xmlns:a="http://schemas.openxmlformats.org/drawingml/2006/main">
             <a:off x="476250" y="4448175"/>
-            <a:ext cx="1485900" cy="219075"/>
+            <a:ext cx="1371600" cy="219075"/>
           </a:xfrm>
           <a:prstGeom xmlns:a="http://schemas.openxmlformats.org/drawingml/2006/main" prst="rect">
             <a:avLst/>
@@ -13289,28 +13289,28 @@
                 <a:ea typeface="Helvetica Neue"/>
                 <a:cs typeface="Helvetica Neue"/>
               </a:rPr>
-              <a:t>Gradient Boosting</a:t>
-            </a:r>
-          </a:p>
-        </p:txBody>
-      </p:sp>
-      <p:sp>
-        <p:nvSpPr>
-          <p:cNvPr id="37" name="text-222-467">
-            <a:extLst xmlns:a="http://schemas.openxmlformats.org/drawingml/2006/main">
-              <a:ext uri="{FF2B5EF4-FFF2-40B4-BE49-F238E27FC236}">
-                <a16:creationId xmlns:a16="http://schemas.microsoft.com/office/drawing/2014/main" id="{01C32AED-402D-4D05-94C6-78FBCC295AA5}"/>
-              </a:ext>
-            </a:extLst>
-          </p:cNvPr>
-          <p:cNvSpPr>
-            <a:spLocks xmlns:a="http://schemas.openxmlformats.org/drawingml/2006/main" noGrp="1"/>
-          </p:cNvSpPr>
-          <p:nvPr/>
-        </p:nvSpPr>
-        <p:spPr>
-          <a:xfrm xmlns:a="http://schemas.openxmlformats.org/drawingml/2006/main">
-            <a:off x="2114550" y="4448175"/>
+              <a:t>Robust Huber</a:t>
+            </a:r>
+          </a:p>
+        </p:txBody>
+      </p:sp>
+      <p:sp>
+        <p:nvSpPr>
+          <p:cNvPr id="37" name="text-210-467">
+            <a:extLst xmlns:a="http://schemas.openxmlformats.org/drawingml/2006/main">
+              <a:ext uri="{FF2B5EF4-FFF2-40B4-BE49-F238E27FC236}">
+                <a16:creationId xmlns:a16="http://schemas.microsoft.com/office/drawing/2014/main" id="{4F475606-132D-4836-A24F-2EB18CA8D331}"/>
+              </a:ext>
+            </a:extLst>
+          </p:cNvPr>
+          <p:cNvSpPr>
+            <a:spLocks xmlns:a="http://schemas.openxmlformats.org/drawingml/2006/main" noGrp="1"/>
+          </p:cNvSpPr>
+          <p:nvPr/>
+        </p:nvSpPr>
+        <p:spPr>
+          <a:xfrm xmlns:a="http://schemas.openxmlformats.org/drawingml/2006/main">
+            <a:off x="2000250" y="4448175"/>
             <a:ext cx="685800" cy="219075"/>
           </a:xfrm>
           <a:prstGeom xmlns:a="http://schemas.openxmlformats.org/drawingml/2006/main" prst="rect">
@@ -13347,28 +13347,28 @@
                 <a:ea typeface="Helvetica Neue"/>
                 <a:cs typeface="Helvetica Neue"/>
               </a:rPr>
-              <a:t>1.66 pts</a:t>
-            </a:r>
-          </a:p>
-        </p:txBody>
-      </p:sp>
-      <p:sp>
-        <p:nvSpPr>
-          <p:cNvPr id="38" name="text-310-467">
-            <a:extLst xmlns:a="http://schemas.openxmlformats.org/drawingml/2006/main">
-              <a:ext uri="{FF2B5EF4-FFF2-40B4-BE49-F238E27FC236}">
-                <a16:creationId xmlns:a16="http://schemas.microsoft.com/office/drawing/2014/main" id="{69AA0764-E147-4D58-B5A8-BA7570F97111}"/>
-              </a:ext>
-            </a:extLst>
-          </p:cNvPr>
-          <p:cNvSpPr>
-            <a:spLocks xmlns:a="http://schemas.openxmlformats.org/drawingml/2006/main" noGrp="1"/>
-          </p:cNvSpPr>
-          <p:nvPr/>
-        </p:nvSpPr>
-        <p:spPr>
-          <a:xfrm xmlns:a="http://schemas.openxmlformats.org/drawingml/2006/main">
-            <a:off x="2952750" y="4448175"/>
+              <a:t>1.33 pts</a:t>
+            </a:r>
+          </a:p>
+        </p:txBody>
+      </p:sp>
+      <p:sp>
+        <p:nvSpPr>
+          <p:cNvPr id="38" name="text-298-467">
+            <a:extLst xmlns:a="http://schemas.openxmlformats.org/drawingml/2006/main">
+              <a:ext uri="{FF2B5EF4-FFF2-40B4-BE49-F238E27FC236}">
+                <a16:creationId xmlns:a16="http://schemas.microsoft.com/office/drawing/2014/main" id="{8F988AB7-CB7D-4B8D-B219-162E84B49BCD}"/>
+              </a:ext>
+            </a:extLst>
+          </p:cNvPr>
+          <p:cNvSpPr>
+            <a:spLocks xmlns:a="http://schemas.openxmlformats.org/drawingml/2006/main" noGrp="1"/>
+          </p:cNvSpPr>
+          <p:nvPr/>
+        </p:nvSpPr>
+        <p:spPr>
+          <a:xfrm xmlns:a="http://schemas.openxmlformats.org/drawingml/2006/main">
+            <a:off x="2838450" y="4448175"/>
             <a:ext cx="628650" cy="219075"/>
           </a:xfrm>
           <a:prstGeom xmlns:a="http://schemas.openxmlformats.org/drawingml/2006/main" prst="rect">
@@ -13405,42 +13405,42 @@
                 <a:ea typeface="Helvetica Neue"/>
                 <a:cs typeface="Helvetica Neue"/>
               </a:rPr>
-              <a:t>2.08 pts</a:t>
-            </a:r>
-          </a:p>
-        </p:txBody>
-      </p:sp>
-      <p:sp>
-        <p:nvSpPr>
-          <p:cNvPr id="39" name="text-392-467">
-            <a:extLst xmlns:a="http://schemas.openxmlformats.org/drawingml/2006/main">
-              <a:ext uri="{FF2B5EF4-FFF2-40B4-BE49-F238E27FC236}">
-                <a16:creationId xmlns:a16="http://schemas.microsoft.com/office/drawing/2014/main" id="{72356539-7C81-41E3-A50A-E057628DA6BA}"/>
-              </a:ext>
-            </a:extLst>
-          </p:cNvPr>
-          <p:cNvSpPr>
-            <a:spLocks xmlns:a="http://schemas.openxmlformats.org/drawingml/2006/main" noGrp="1"/>
-          </p:cNvSpPr>
-          <p:nvPr/>
-        </p:nvSpPr>
-        <p:spPr>
-          <a:xfrm xmlns:a="http://schemas.openxmlformats.org/drawingml/2006/main">
-            <a:off x="3733800" y="4448175"/>
-            <a:ext cx="400050" cy="219075"/>
-          </a:xfrm>
-          <a:prstGeom xmlns:a="http://schemas.openxmlformats.org/drawingml/2006/main" prst="rect">
-            <a:avLst/>
-          </a:prstGeom>
-          <a:noFill xmlns:a="http://schemas.openxmlformats.org/drawingml/2006/main"/>
-          <a:ln xmlns:a="http://schemas.openxmlformats.org/drawingml/2006/main" w="0">
-            <a:noFill/>
-            <a:prstDash val="solid"/>
-          </a:ln>
-        </p:spPr>
-        <p:txBody>
-          <a:bodyPr xmlns:a="http://schemas.openxmlformats.org/drawingml/2006/main" wrap="square" lIns="0" tIns="0" rIns="0" bIns="0" anchor="t">
-            <a:normAutofit fontScale="97411"/>
+              <a:t>1.76 pts</a:t>
+            </a:r>
+          </a:p>
+        </p:txBody>
+      </p:sp>
+      <p:sp>
+        <p:nvSpPr>
+          <p:cNvPr id="39" name="text-380-467">
+            <a:extLst xmlns:a="http://schemas.openxmlformats.org/drawingml/2006/main">
+              <a:ext uri="{FF2B5EF4-FFF2-40B4-BE49-F238E27FC236}">
+                <a16:creationId xmlns:a16="http://schemas.microsoft.com/office/drawing/2014/main" id="{F963DC27-70A5-4A3D-B392-A3A682ABDE3E}"/>
+              </a:ext>
+            </a:extLst>
+          </p:cNvPr>
+          <p:cNvSpPr>
+            <a:spLocks xmlns:a="http://schemas.openxmlformats.org/drawingml/2006/main" noGrp="1"/>
+          </p:cNvSpPr>
+          <p:nvPr/>
+        </p:nvSpPr>
+        <p:spPr>
+          <a:xfrm xmlns:a="http://schemas.openxmlformats.org/drawingml/2006/main">
+            <a:off x="3619500" y="4448175"/>
+            <a:ext cx="533400" cy="219075"/>
+          </a:xfrm>
+          <a:prstGeom xmlns:a="http://schemas.openxmlformats.org/drawingml/2006/main" prst="rect">
+            <a:avLst/>
+          </a:prstGeom>
+          <a:noFill xmlns:a="http://schemas.openxmlformats.org/drawingml/2006/main"/>
+          <a:ln xmlns:a="http://schemas.openxmlformats.org/drawingml/2006/main" w="0">
+            <a:noFill/>
+            <a:prstDash val="solid"/>
+          </a:ln>
+        </p:spPr>
+        <p:txBody>
+          <a:bodyPr xmlns:a="http://schemas.openxmlformats.org/drawingml/2006/main" wrap="square" lIns="0" tIns="0" rIns="0" bIns="0" anchor="t">
+            <a:normAutofit fontScale="100000"/>
           </a:bodyPr>
           <a:lstStyle xmlns:a="http://schemas.openxmlformats.org/drawingml/2006/main"/>
           <a:p xmlns:a="http://schemas.openxmlformats.org/drawingml/2006/main">
@@ -13463,29 +13463,29 @@
                 <a:ea typeface="Helvetica Neue"/>
                 <a:cs typeface="Helvetica Neue"/>
               </a:rPr>
-              <a:t>−0.041</a:t>
-            </a:r>
-          </a:p>
-        </p:txBody>
-      </p:sp>
-      <p:sp>
-        <p:nvSpPr>
-          <p:cNvPr id="40" name="text-450-467">
-            <a:extLst xmlns:a="http://schemas.openxmlformats.org/drawingml/2006/main">
-              <a:ext uri="{FF2B5EF4-FFF2-40B4-BE49-F238E27FC236}">
-                <a16:creationId xmlns:a16="http://schemas.microsoft.com/office/drawing/2014/main" id="{7D090CFD-3DD8-418E-B3E0-C2B6C83D0E81}"/>
-              </a:ext>
-            </a:extLst>
-          </p:cNvPr>
-          <p:cNvSpPr>
-            <a:spLocks xmlns:a="http://schemas.openxmlformats.org/drawingml/2006/main" noGrp="1"/>
-          </p:cNvSpPr>
-          <p:nvPr/>
-        </p:nvSpPr>
-        <p:spPr>
-          <a:xfrm xmlns:a="http://schemas.openxmlformats.org/drawingml/2006/main">
-            <a:off x="4286250" y="4448175"/>
-            <a:ext cx="971550" cy="219075"/>
+              <a:t>0.260</a:t>
+            </a:r>
+          </a:p>
+        </p:txBody>
+      </p:sp>
+      <p:sp>
+        <p:nvSpPr>
+          <p:cNvPr id="40" name="text-452-467">
+            <a:extLst xmlns:a="http://schemas.openxmlformats.org/drawingml/2006/main">
+              <a:ext uri="{FF2B5EF4-FFF2-40B4-BE49-F238E27FC236}">
+                <a16:creationId xmlns:a16="http://schemas.microsoft.com/office/drawing/2014/main" id="{6AA1E415-2407-4606-A592-544B547DCE7E}"/>
+              </a:ext>
+            </a:extLst>
+          </p:cNvPr>
+          <p:cNvSpPr>
+            <a:spLocks xmlns:a="http://schemas.openxmlformats.org/drawingml/2006/main" noGrp="1"/>
+          </p:cNvSpPr>
+          <p:nvPr/>
+        </p:nvSpPr>
+        <p:spPr>
+          <a:xfrm xmlns:a="http://schemas.openxmlformats.org/drawingml/2006/main">
+            <a:off x="4305300" y="4448175"/>
+            <a:ext cx="952500" cy="219075"/>
           </a:xfrm>
           <a:prstGeom xmlns:a="http://schemas.openxmlformats.org/drawingml/2006/main" prst="rect">
             <a:avLst/>
@@ -13521,7 +13521,7 @@
                 <a:ea typeface="Helvetica Neue"/>
                 <a:cs typeface="Helvetica Neue"/>
               </a:rPr>
-              <a:t>Compared</a:t>
+              <a:t>Best learned</a:t>
             </a:r>
           </a:p>
         </p:txBody>
@@ -13531,7 +13531,7 @@
           <p:cNvPr id="41" name="model-table-row-286-4">
             <a:extLst xmlns:a="http://schemas.openxmlformats.org/drawingml/2006/main">
               <a:ext uri="{FF2B5EF4-FFF2-40B4-BE49-F238E27FC236}">
-                <a16:creationId xmlns:a16="http://schemas.microsoft.com/office/drawing/2014/main" id="{41537DDC-7421-4530-89A1-6B61C803806D}"/>
+                <a16:creationId xmlns:a16="http://schemas.microsoft.com/office/drawing/2014/main" id="{A8E937C6-313B-42EA-BB58-046D91D65F57}"/>
               </a:ext>
             </a:extLst>
           </p:cNvPr>
@@ -13584,7 +13584,7 @@
           <p:cNvPr id="43" name="text-50-510">
             <a:extLst xmlns:a="http://schemas.openxmlformats.org/drawingml/2006/main">
               <a:ext uri="{FF2B5EF4-FFF2-40B4-BE49-F238E27FC236}">
-                <a16:creationId xmlns:a16="http://schemas.microsoft.com/office/drawing/2014/main" id="{FEDE98BC-7298-4358-9FD4-32F3414C14EF}"/>
+                <a16:creationId xmlns:a16="http://schemas.microsoft.com/office/drawing/2014/main" id="{BD50AD84-FCCF-4829-9D28-1B0B49E6BC79}"/>
               </a:ext>
             </a:extLst>
           </p:cNvPr>
@@ -13596,7 +13596,7 @@
         <p:spPr>
           <a:xfrm xmlns:a="http://schemas.openxmlformats.org/drawingml/2006/main">
             <a:off x="476250" y="4857750"/>
-            <a:ext cx="1485900" cy="219075"/>
+            <a:ext cx="1371600" cy="219075"/>
           </a:xfrm>
           <a:prstGeom xmlns:a="http://schemas.openxmlformats.org/drawingml/2006/main" prst="rect">
             <a:avLst/>
@@ -13632,28 +13632,28 @@
                 <a:ea typeface="Helvetica Neue"/>
                 <a:cs typeface="Helvetica Neue"/>
               </a:rPr>
-              <a:t>XGBoost</a:t>
-            </a:r>
-          </a:p>
-        </p:txBody>
-      </p:sp>
-      <p:sp>
-        <p:nvSpPr>
-          <p:cNvPr id="44" name="text-222-510">
-            <a:extLst xmlns:a="http://schemas.openxmlformats.org/drawingml/2006/main">
-              <a:ext uri="{FF2B5EF4-FFF2-40B4-BE49-F238E27FC236}">
-                <a16:creationId xmlns:a16="http://schemas.microsoft.com/office/drawing/2014/main" id="{376F4DEF-158E-4AD9-ADFE-308F371714C7}"/>
-              </a:ext>
-            </a:extLst>
-          </p:cNvPr>
-          <p:cNvSpPr>
-            <a:spLocks xmlns:a="http://schemas.openxmlformats.org/drawingml/2006/main" noGrp="1"/>
-          </p:cNvSpPr>
-          <p:nvPr/>
-        </p:nvSpPr>
-        <p:spPr>
-          <a:xfrm xmlns:a="http://schemas.openxmlformats.org/drawingml/2006/main">
-            <a:off x="2114550" y="4857750"/>
+              <a:t>Gradient Boosting</a:t>
+            </a:r>
+          </a:p>
+        </p:txBody>
+      </p:sp>
+      <p:sp>
+        <p:nvSpPr>
+          <p:cNvPr id="44" name="text-210-510">
+            <a:extLst xmlns:a="http://schemas.openxmlformats.org/drawingml/2006/main">
+              <a:ext uri="{FF2B5EF4-FFF2-40B4-BE49-F238E27FC236}">
+                <a16:creationId xmlns:a16="http://schemas.microsoft.com/office/drawing/2014/main" id="{709C2A68-93F6-4474-838B-0E5D63B54EEB}"/>
+              </a:ext>
+            </a:extLst>
+          </p:cNvPr>
+          <p:cNvSpPr>
+            <a:spLocks xmlns:a="http://schemas.openxmlformats.org/drawingml/2006/main" noGrp="1"/>
+          </p:cNvSpPr>
+          <p:nvPr/>
+        </p:nvSpPr>
+        <p:spPr>
+          <a:xfrm xmlns:a="http://schemas.openxmlformats.org/drawingml/2006/main">
+            <a:off x="2000250" y="4857750"/>
             <a:ext cx="685800" cy="219075"/>
           </a:xfrm>
           <a:prstGeom xmlns:a="http://schemas.openxmlformats.org/drawingml/2006/main" prst="rect">
@@ -13690,28 +13690,28 @@
                 <a:ea typeface="Helvetica Neue"/>
                 <a:cs typeface="Helvetica Neue"/>
               </a:rPr>
-              <a:t>—</a:t>
-            </a:r>
-          </a:p>
-        </p:txBody>
-      </p:sp>
-      <p:sp>
-        <p:nvSpPr>
-          <p:cNvPr id="45" name="text-310-510">
-            <a:extLst xmlns:a="http://schemas.openxmlformats.org/drawingml/2006/main">
-              <a:ext uri="{FF2B5EF4-FFF2-40B4-BE49-F238E27FC236}">
-                <a16:creationId xmlns:a16="http://schemas.microsoft.com/office/drawing/2014/main" id="{0B4CFF97-9B72-4C0D-8E31-817BC9A6B312}"/>
-              </a:ext>
-            </a:extLst>
-          </p:cNvPr>
-          <p:cNvSpPr>
-            <a:spLocks xmlns:a="http://schemas.openxmlformats.org/drawingml/2006/main" noGrp="1"/>
-          </p:cNvSpPr>
-          <p:nvPr/>
-        </p:nvSpPr>
-        <p:spPr>
-          <a:xfrm xmlns:a="http://schemas.openxmlformats.org/drawingml/2006/main">
-            <a:off x="2952750" y="4857750"/>
+              <a:t>1.37 pts</a:t>
+            </a:r>
+          </a:p>
+        </p:txBody>
+      </p:sp>
+      <p:sp>
+        <p:nvSpPr>
+          <p:cNvPr id="45" name="text-298-510">
+            <a:extLst xmlns:a="http://schemas.openxmlformats.org/drawingml/2006/main">
+              <a:ext uri="{FF2B5EF4-FFF2-40B4-BE49-F238E27FC236}">
+                <a16:creationId xmlns:a16="http://schemas.microsoft.com/office/drawing/2014/main" id="{3F8B5298-9616-45A8-BD30-658C9CF9D4A4}"/>
+              </a:ext>
+            </a:extLst>
+          </p:cNvPr>
+          <p:cNvSpPr>
+            <a:spLocks xmlns:a="http://schemas.openxmlformats.org/drawingml/2006/main" noGrp="1"/>
+          </p:cNvSpPr>
+          <p:nvPr/>
+        </p:nvSpPr>
+        <p:spPr>
+          <a:xfrm xmlns:a="http://schemas.openxmlformats.org/drawingml/2006/main">
+            <a:off x="2838450" y="4857750"/>
             <a:ext cx="628650" cy="219075"/>
           </a:xfrm>
           <a:prstGeom xmlns:a="http://schemas.openxmlformats.org/drawingml/2006/main" prst="rect">
@@ -13748,29 +13748,29 @@
                 <a:ea typeface="Helvetica Neue"/>
                 <a:cs typeface="Helvetica Neue"/>
               </a:rPr>
-              <a:t>—</a:t>
-            </a:r>
-          </a:p>
-        </p:txBody>
-      </p:sp>
-      <p:sp>
-        <p:nvSpPr>
-          <p:cNvPr id="46" name="text-392-510">
-            <a:extLst xmlns:a="http://schemas.openxmlformats.org/drawingml/2006/main">
-              <a:ext uri="{FF2B5EF4-FFF2-40B4-BE49-F238E27FC236}">
-                <a16:creationId xmlns:a16="http://schemas.microsoft.com/office/drawing/2014/main" id="{564E8E32-8522-4823-BD15-ACE388119ADA}"/>
-              </a:ext>
-            </a:extLst>
-          </p:cNvPr>
-          <p:cNvSpPr>
-            <a:spLocks xmlns:a="http://schemas.openxmlformats.org/drawingml/2006/main" noGrp="1"/>
-          </p:cNvSpPr>
-          <p:nvPr/>
-        </p:nvSpPr>
-        <p:spPr>
-          <a:xfrm xmlns:a="http://schemas.openxmlformats.org/drawingml/2006/main">
-            <a:off x="3733800" y="4857750"/>
-            <a:ext cx="400050" cy="219075"/>
+              <a:t>1.78 pts</a:t>
+            </a:r>
+          </a:p>
+        </p:txBody>
+      </p:sp>
+      <p:sp>
+        <p:nvSpPr>
+          <p:cNvPr id="46" name="text-380-510">
+            <a:extLst xmlns:a="http://schemas.openxmlformats.org/drawingml/2006/main">
+              <a:ext uri="{FF2B5EF4-FFF2-40B4-BE49-F238E27FC236}">
+                <a16:creationId xmlns:a16="http://schemas.microsoft.com/office/drawing/2014/main" id="{9AC73B5F-CADD-4E09-BF78-59B90350F22A}"/>
+              </a:ext>
+            </a:extLst>
+          </p:cNvPr>
+          <p:cNvSpPr>
+            <a:spLocks xmlns:a="http://schemas.openxmlformats.org/drawingml/2006/main" noGrp="1"/>
+          </p:cNvSpPr>
+          <p:nvPr/>
+        </p:nvSpPr>
+        <p:spPr>
+          <a:xfrm xmlns:a="http://schemas.openxmlformats.org/drawingml/2006/main">
+            <a:off x="3619500" y="4857750"/>
+            <a:ext cx="533400" cy="219075"/>
           </a:xfrm>
           <a:prstGeom xmlns:a="http://schemas.openxmlformats.org/drawingml/2006/main" prst="rect">
             <a:avLst/>
@@ -13806,29 +13806,29 @@
                 <a:ea typeface="Helvetica Neue"/>
                 <a:cs typeface="Helvetica Neue"/>
               </a:rPr>
-              <a:t>—</a:t>
-            </a:r>
-          </a:p>
-        </p:txBody>
-      </p:sp>
-      <p:sp>
-        <p:nvSpPr>
-          <p:cNvPr id="47" name="text-450-510">
-            <a:extLst xmlns:a="http://schemas.openxmlformats.org/drawingml/2006/main">
-              <a:ext uri="{FF2B5EF4-FFF2-40B4-BE49-F238E27FC236}">
-                <a16:creationId xmlns:a16="http://schemas.microsoft.com/office/drawing/2014/main" id="{A79A3D65-FD6D-4C21-97EE-2334611625D3}"/>
-              </a:ext>
-            </a:extLst>
-          </p:cNvPr>
-          <p:cNvSpPr>
-            <a:spLocks xmlns:a="http://schemas.openxmlformats.org/drawingml/2006/main" noGrp="1"/>
-          </p:cNvSpPr>
-          <p:nvPr/>
-        </p:nvSpPr>
-        <p:spPr>
-          <a:xfrm xmlns:a="http://schemas.openxmlformats.org/drawingml/2006/main">
-            <a:off x="4286250" y="4857750"/>
-            <a:ext cx="971550" cy="219075"/>
+              <a:t>0.243</a:t>
+            </a:r>
+          </a:p>
+        </p:txBody>
+      </p:sp>
+      <p:sp>
+        <p:nvSpPr>
+          <p:cNvPr id="47" name="text-452-510">
+            <a:extLst xmlns:a="http://schemas.openxmlformats.org/drawingml/2006/main">
+              <a:ext uri="{FF2B5EF4-FFF2-40B4-BE49-F238E27FC236}">
+                <a16:creationId xmlns:a16="http://schemas.microsoft.com/office/drawing/2014/main" id="{F09DBF70-62B6-4F6F-922C-DE048B9CBFD3}"/>
+              </a:ext>
+            </a:extLst>
+          </p:cNvPr>
+          <p:cNvSpPr>
+            <a:spLocks xmlns:a="http://schemas.openxmlformats.org/drawingml/2006/main" noGrp="1"/>
+          </p:cNvSpPr>
+          <p:nvPr/>
+        </p:nvSpPr>
+        <p:spPr>
+          <a:xfrm xmlns:a="http://schemas.openxmlformats.org/drawingml/2006/main">
+            <a:off x="4305300" y="4857750"/>
+            <a:ext cx="952500" cy="219075"/>
           </a:xfrm>
           <a:prstGeom xmlns:a="http://schemas.openxmlformats.org/drawingml/2006/main" prst="rect">
             <a:avLst/>
@@ -13864,7 +13864,7 @@
                 <a:ea typeface="Helvetica Neue"/>
                 <a:cs typeface="Helvetica Neue"/>
               </a:rPr>
-              <a:t>Unavailable</a:t>
+              <a:t>Compared</a:t>
             </a:r>
           </a:p>
         </p:txBody>
@@ -13874,7 +13874,7 @@
           <p:cNvPr id="48" name="text-760-188">
             <a:extLst xmlns:a="http://schemas.openxmlformats.org/drawingml/2006/main">
               <a:ext uri="{FF2B5EF4-FFF2-40B4-BE49-F238E27FC236}">
-                <a16:creationId xmlns:a16="http://schemas.microsoft.com/office/drawing/2014/main" id="{A1A22837-AA51-499C-AEB1-E191EF72CD78}"/>
+                <a16:creationId xmlns:a16="http://schemas.microsoft.com/office/drawing/2014/main" id="{B219D814-69ED-4747-AF1A-F313E7D0708B}"/>
               </a:ext>
             </a:extLst>
           </p:cNvPr>
@@ -13922,7 +13922,7 @@
                 <a:ea typeface="Helvetica Neue"/>
                 <a:cs typeface="Helvetica Neue"/>
               </a:rPr>
-              <a:t>1.37 pts</a:t>
+              <a:t>1.40 pts</a:t>
             </a:r>
           </a:p>
         </p:txBody>
@@ -13932,7 +13932,7 @@
           <p:cNvPr id="49" name="text-760-254">
             <a:extLst xmlns:a="http://schemas.openxmlformats.org/drawingml/2006/main">
               <a:ext uri="{FF2B5EF4-FFF2-40B4-BE49-F238E27FC236}">
-                <a16:creationId xmlns:a16="http://schemas.microsoft.com/office/drawing/2014/main" id="{45DEC49E-86D4-4871-BE64-E3A3738BD30B}"/>
+                <a16:creationId xmlns:a16="http://schemas.microsoft.com/office/drawing/2014/main" id="{D8CCFDA0-6130-4F72-9143-EF8B795386C1}"/>
               </a:ext>
             </a:extLst>
           </p:cNvPr>
@@ -13980,7 +13980,7 @@
                 <a:ea typeface="Helvetica Neue"/>
                 <a:cs typeface="Helvetica Neue"/>
               </a:rPr>
-              <a:t>overall mean absolute error</a:t>
+              <a:t>operational overall mean absolute error</a:t>
             </a:r>
           </a:p>
         </p:txBody>
@@ -13990,7 +13990,7 @@
           <p:cNvPr id="50" name="text-760-330">
             <a:extLst xmlns:a="http://schemas.openxmlformats.org/drawingml/2006/main">
               <a:ext uri="{FF2B5EF4-FFF2-40B4-BE49-F238E27FC236}">
-                <a16:creationId xmlns:a16="http://schemas.microsoft.com/office/drawing/2014/main" id="{4C83F39D-2144-4629-B660-2E023D7BDEFC}"/>
+                <a16:creationId xmlns:a16="http://schemas.microsoft.com/office/drawing/2014/main" id="{8C0B5B37-B346-4DE3-8934-6E3205DB8D62}"/>
               </a:ext>
             </a:extLst>
           </p:cNvPr>
@@ -14038,7 +14038,7 @@
                 <a:ea typeface="Helvetica Neue"/>
                 <a:cs typeface="Helvetica Neue"/>
               </a:rPr>
-              <a:t>1.65 pts</a:t>
+              <a:t>1.40 pts</a:t>
             </a:r>
           </a:p>
         </p:txBody>
@@ -14048,7 +14048,7 @@
           <p:cNvPr id="51" name="text-760-396">
             <a:extLst xmlns:a="http://schemas.openxmlformats.org/drawingml/2006/main">
               <a:ext uri="{FF2B5EF4-FFF2-40B4-BE49-F238E27FC236}">
-                <a16:creationId xmlns:a16="http://schemas.microsoft.com/office/drawing/2014/main" id="{61424181-39D9-4D26-94C8-97095BBFC3E9}"/>
+                <a16:creationId xmlns:a16="http://schemas.microsoft.com/office/drawing/2014/main" id="{7E373DD5-B4B8-4726-92DC-40A8DD1740B3}"/>
               </a:ext>
             </a:extLst>
           </p:cNvPr>
@@ -14106,7 +14106,7 @@
           <p:cNvPr id="52" name="text-760-472">
             <a:extLst xmlns:a="http://schemas.openxmlformats.org/drawingml/2006/main">
               <a:ext uri="{FF2B5EF4-FFF2-40B4-BE49-F238E27FC236}">
-                <a16:creationId xmlns:a16="http://schemas.microsoft.com/office/drawing/2014/main" id="{78D75FAD-B178-4253-892F-8974874F1A21}"/>
+                <a16:creationId xmlns:a16="http://schemas.microsoft.com/office/drawing/2014/main" id="{BA4810CB-5436-47FC-896A-F2FF59BFBB03}"/>
               </a:ext>
             </a:extLst>
           </p:cNvPr>
@@ -14154,7 +14154,7 @@
                 <a:ea typeface="Helvetica Neue"/>
                 <a:cs typeface="Helvetica Neue"/>
               </a:rPr>
-              <a:t>14.5%</a:t>
+              <a:t>11.2%</a:t>
             </a:r>
           </a:p>
         </p:txBody>
@@ -14164,7 +14164,7 @@
           <p:cNvPr id="53" name="text-760-538">
             <a:extLst xmlns:a="http://schemas.openxmlformats.org/drawingml/2006/main">
               <a:ext uri="{FF2B5EF4-FFF2-40B4-BE49-F238E27FC236}">
-                <a16:creationId xmlns:a16="http://schemas.microsoft.com/office/drawing/2014/main" id="{D3966A64-83B6-47B6-994C-F98B39078468}"/>
+                <a16:creationId xmlns:a16="http://schemas.microsoft.com/office/drawing/2014/main" id="{E35D9CB2-15B3-4FC1-85EA-1B0C62F3DFF2}"/>
               </a:ext>
             </a:extLst>
           </p:cNvPr>
@@ -14212,7 +14212,7 @@
                 <a:ea typeface="Helvetica Neue"/>
                 <a:cs typeface="Helvetica Neue"/>
               </a:rPr>
-              <a:t>cycle-MAE improvement versus baseline</a:t>
+              <a:t>Huber cycle-MAE improvement versus baseline</a:t>
             </a:r>
           </a:p>
         </p:txBody>
@@ -14222,7 +14222,7 @@
           <p:cNvPr id="54" name="recovery-warning">
             <a:extLst xmlns:a="http://schemas.openxmlformats.org/drawingml/2006/main">
               <a:ext uri="{FF2B5EF4-FFF2-40B4-BE49-F238E27FC236}">
-                <a16:creationId xmlns:a16="http://schemas.microsoft.com/office/drawing/2014/main" id="{93221820-B39D-4C5B-B5E3-A92785E9B4AE}"/>
+                <a16:creationId xmlns:a16="http://schemas.microsoft.com/office/drawing/2014/main" id="{0AD3658E-F39C-4A05-A6B4-443502809EF4}"/>
               </a:ext>
             </a:extLst>
           </p:cNvPr>
@@ -14253,7 +14253,7 @@
           <p:cNvPr id="55" name="text-772-596">
             <a:extLst xmlns:a="http://schemas.openxmlformats.org/drawingml/2006/main">
               <a:ext uri="{FF2B5EF4-FFF2-40B4-BE49-F238E27FC236}">
-                <a16:creationId xmlns:a16="http://schemas.microsoft.com/office/drawing/2014/main" id="{2B9EF202-E0CA-4686-8C11-96BC52BFAEE4}"/>
+                <a16:creationId xmlns:a16="http://schemas.microsoft.com/office/drawing/2014/main" id="{2F6B6E4D-FFB1-4384-BB56-74975EB71387}"/>
               </a:ext>
             </a:extLst>
           </p:cNvPr>
@@ -14301,7 +14301,7 @@
                 <a:ea typeface="Helvetica Neue"/>
                 <a:cs typeface="Helvetica Neue"/>
               </a:rPr>
-              <a:t>Continuous-estimate gate passed. 95% target classification gate failed: target-side accuracy remains below the majority baseline.</a:t>
+              <a:t>Huber improves MAE, but fails the full deployment gate: rolling-origin stability and 95% target classification remain weak.</a:t>
             </a:r>
           </a:p>
         </p:txBody>
@@ -14309,7 +14309,7 @@
     </p:spTree>
     <p:extLst>
       <p:ext uri="{BB962C8B-B14F-4D97-AF65-F5344CB8AC3E}">
-        <p14:creationId xmlns:p14="http://schemas.microsoft.com/office/powerpoint/2010/main" val="95215169"/>
+        <p14:creationId xmlns:p14="http://schemas.microsoft.com/office/powerpoint/2010/main" val="61335252"/>
       </p:ext>
     </p:extLst>
   </p:cSld>
@@ -14340,7 +14340,7 @@
           <p:cNvPr id="23" name="kicker-8">
             <a:extLst xmlns:a="http://schemas.openxmlformats.org/drawingml/2006/main">
               <a:ext uri="{FF2B5EF4-FFF2-40B4-BE49-F238E27FC236}">
-                <a16:creationId xmlns:a16="http://schemas.microsoft.com/office/drawing/2014/main" id="{62099374-A5BF-4221-AEFB-9C907A1D83B2}"/>
+                <a16:creationId xmlns:a16="http://schemas.microsoft.com/office/drawing/2014/main" id="{D1356037-A60E-42E8-851A-A7A78E8A9678}"/>
               </a:ext>
             </a:extLst>
           </p:cNvPr>
@@ -14398,7 +14398,7 @@
           <p:cNvPr id="2" name="title-8">
             <a:extLst xmlns:a="http://schemas.openxmlformats.org/drawingml/2006/main">
               <a:ext uri="{FF2B5EF4-FFF2-40B4-BE49-F238E27FC236}">
-                <a16:creationId xmlns:a16="http://schemas.microsoft.com/office/drawing/2014/main" id="{7BD1BB86-0B86-4EF7-912C-4E63F036DB67}"/>
+                <a16:creationId xmlns:a16="http://schemas.microsoft.com/office/drawing/2014/main" id="{2C40FC5F-D7BC-478F-A502-C9B06FC897B6}"/>
               </a:ext>
             </a:extLst>
           </p:cNvPr>
@@ -14478,7 +14478,7 @@
           <p:cNvPr id="4" name="page-8">
             <a:extLst xmlns:a="http://schemas.openxmlformats.org/drawingml/2006/main">
               <a:ext uri="{FF2B5EF4-FFF2-40B4-BE49-F238E27FC236}">
-                <a16:creationId xmlns:a16="http://schemas.microsoft.com/office/drawing/2014/main" id="{D2EBEE68-EBE6-4A54-8540-2DF2FB0D7338}"/>
+                <a16:creationId xmlns:a16="http://schemas.microsoft.com/office/drawing/2014/main" id="{58802A89-F662-4C15-95D3-69978273C465}"/>
               </a:ext>
             </a:extLst>
           </p:cNvPr>
@@ -14536,7 +14536,7 @@
           <p:cNvPr id="5" name="">
             <a:extLst xmlns:a="http://schemas.openxmlformats.org/drawingml/2006/main">
               <a:ext uri="{FF2B5EF4-FFF2-40B4-BE49-F238E27FC236}">
-                <a16:creationId xmlns:a16="http://schemas.microsoft.com/office/drawing/2014/main" id="{AF9C1661-538A-477B-8507-EF957F422679}"/>
+                <a16:creationId xmlns:a16="http://schemas.microsoft.com/office/drawing/2014/main" id="{A27344BB-E4F1-4820-918F-9428E1387792}"/>
               </a:ext>
             </a:extLst>
           </p:cNvPr>
@@ -14567,7 +14567,7 @@
           <p:cNvPr id="6" name="">
             <a:extLst xmlns:a="http://schemas.openxmlformats.org/drawingml/2006/main">
               <a:ext uri="{FF2B5EF4-FFF2-40B4-BE49-F238E27FC236}">
-                <a16:creationId xmlns:a16="http://schemas.microsoft.com/office/drawing/2014/main" id="{43A43179-247E-414F-97F0-11CA4C9A85B9}"/>
+                <a16:creationId xmlns:a16="http://schemas.microsoft.com/office/drawing/2014/main" id="{DCB7E5D6-659E-4B40-A514-F8D46A2E241A}"/>
               </a:ext>
             </a:extLst>
           </p:cNvPr>
@@ -14598,7 +14598,7 @@
           <p:cNvPr id="7" name="text-62-196">
             <a:extLst xmlns:a="http://schemas.openxmlformats.org/drawingml/2006/main">
               <a:ext uri="{FF2B5EF4-FFF2-40B4-BE49-F238E27FC236}">
-                <a16:creationId xmlns:a16="http://schemas.microsoft.com/office/drawing/2014/main" id="{2FA50FB7-6DDF-4959-8EE4-E8FD0019E36F}"/>
+                <a16:creationId xmlns:a16="http://schemas.microsoft.com/office/drawing/2014/main" id="{C37499EE-C7C3-4AAC-854E-E26A0FC43E96}"/>
               </a:ext>
             </a:extLst>
           </p:cNvPr>
@@ -14656,7 +14656,7 @@
           <p:cNvPr id="8" name="text-62-248">
             <a:extLst xmlns:a="http://schemas.openxmlformats.org/drawingml/2006/main">
               <a:ext uri="{FF2B5EF4-FFF2-40B4-BE49-F238E27FC236}">
-                <a16:creationId xmlns:a16="http://schemas.microsoft.com/office/drawing/2014/main" id="{6D9F0AA6-4233-41F4-83EC-6A71B29BABD7}"/>
+                <a16:creationId xmlns:a16="http://schemas.microsoft.com/office/drawing/2014/main" id="{FD98735F-BD0E-4E8A-9428-E40C55BC388E}"/>
               </a:ext>
             </a:extLst>
           </p:cNvPr>
@@ -14736,7 +14736,7 @@
           <p:cNvPr id="10" name="text-62-350">
             <a:extLst xmlns:a="http://schemas.openxmlformats.org/drawingml/2006/main">
               <a:ext uri="{FF2B5EF4-FFF2-40B4-BE49-F238E27FC236}">
-                <a16:creationId xmlns:a16="http://schemas.microsoft.com/office/drawing/2014/main" id="{81EDD1AC-036F-47E7-B3AC-FDB3A6BA0BAB}"/>
+                <a16:creationId xmlns:a16="http://schemas.microsoft.com/office/drawing/2014/main" id="{78ABCCA3-33CB-4443-BDAA-29FEB02C4E9A}"/>
               </a:ext>
             </a:extLst>
           </p:cNvPr>
@@ -14794,7 +14794,7 @@
           <p:cNvPr id="11" name="text-454-196">
             <a:extLst xmlns:a="http://schemas.openxmlformats.org/drawingml/2006/main">
               <a:ext uri="{FF2B5EF4-FFF2-40B4-BE49-F238E27FC236}">
-                <a16:creationId xmlns:a16="http://schemas.microsoft.com/office/drawing/2014/main" id="{0A3EEA01-35A0-4CE3-94DD-F0672865BB3B}"/>
+                <a16:creationId xmlns:a16="http://schemas.microsoft.com/office/drawing/2014/main" id="{7B3D659A-F9DD-4871-8C97-51E8924CFE60}"/>
               </a:ext>
             </a:extLst>
           </p:cNvPr>
@@ -14852,7 +14852,7 @@
           <p:cNvPr id="12" name="text-454-248">
             <a:extLst xmlns:a="http://schemas.openxmlformats.org/drawingml/2006/main">
               <a:ext uri="{FF2B5EF4-FFF2-40B4-BE49-F238E27FC236}">
-                <a16:creationId xmlns:a16="http://schemas.microsoft.com/office/drawing/2014/main" id="{FE3D3E18-03C3-49F1-82FB-54F3AF09AC3B}"/>
+                <a16:creationId xmlns:a16="http://schemas.microsoft.com/office/drawing/2014/main" id="{FE2314AB-E3E0-4F17-B97E-0368FBC46BCA}"/>
               </a:ext>
             </a:extLst>
           </p:cNvPr>
@@ -14932,7 +14932,7 @@
           <p:cNvPr id="14" name="text-454-350">
             <a:extLst xmlns:a="http://schemas.openxmlformats.org/drawingml/2006/main">
               <a:ext uri="{FF2B5EF4-FFF2-40B4-BE49-F238E27FC236}">
-                <a16:creationId xmlns:a16="http://schemas.microsoft.com/office/drawing/2014/main" id="{77A77A9B-14BF-4293-A341-4776495A7872}"/>
+                <a16:creationId xmlns:a16="http://schemas.microsoft.com/office/drawing/2014/main" id="{104CA9FE-CEDB-4DAA-B52C-4629508DC3F8}"/>
               </a:ext>
             </a:extLst>
           </p:cNvPr>
@@ -14990,7 +14990,7 @@
           <p:cNvPr id="15" name="text-846-196">
             <a:extLst xmlns:a="http://schemas.openxmlformats.org/drawingml/2006/main">
               <a:ext uri="{FF2B5EF4-FFF2-40B4-BE49-F238E27FC236}">
-                <a16:creationId xmlns:a16="http://schemas.microsoft.com/office/drawing/2014/main" id="{120B5649-3A4E-4FD3-AA10-28ECE28B2345}"/>
+                <a16:creationId xmlns:a16="http://schemas.microsoft.com/office/drawing/2014/main" id="{22668076-776A-43B9-B973-60BCEE8EB645}"/>
               </a:ext>
             </a:extLst>
           </p:cNvPr>
@@ -15048,7 +15048,7 @@
           <p:cNvPr id="16" name="text-846-248">
             <a:extLst xmlns:a="http://schemas.openxmlformats.org/drawingml/2006/main">
               <a:ext uri="{FF2B5EF4-FFF2-40B4-BE49-F238E27FC236}">
-                <a16:creationId xmlns:a16="http://schemas.microsoft.com/office/drawing/2014/main" id="{4AFB6F60-F36C-4D24-9CA8-95A44B502A95}"/>
+                <a16:creationId xmlns:a16="http://schemas.microsoft.com/office/drawing/2014/main" id="{BD23B170-F314-4DB1-858A-DC5B123581B8}"/>
               </a:ext>
             </a:extLst>
           </p:cNvPr>
@@ -15128,7 +15128,7 @@
           <p:cNvPr id="18" name="text-846-350">
             <a:extLst xmlns:a="http://schemas.openxmlformats.org/drawingml/2006/main">
               <a:ext uri="{FF2B5EF4-FFF2-40B4-BE49-F238E27FC236}">
-                <a16:creationId xmlns:a16="http://schemas.microsoft.com/office/drawing/2014/main" id="{F4A18DF5-78C9-47CE-94EB-2BEBC5AECE0D}"/>
+                <a16:creationId xmlns:a16="http://schemas.microsoft.com/office/drawing/2014/main" id="{3C42B369-6CE0-4890-B2FE-0FCA570FD807}"/>
               </a:ext>
             </a:extLst>
           </p:cNvPr>
@@ -15186,7 +15186,7 @@
           <p:cNvPr id="19" name="action-example">
             <a:extLst xmlns:a="http://schemas.openxmlformats.org/drawingml/2006/main">
               <a:ext uri="{FF2B5EF4-FFF2-40B4-BE49-F238E27FC236}">
-                <a16:creationId xmlns:a16="http://schemas.microsoft.com/office/drawing/2014/main" id="{E60732D0-D928-4724-81ED-FFC5D02537F9}"/>
+                <a16:creationId xmlns:a16="http://schemas.microsoft.com/office/drawing/2014/main" id="{D226EA59-FDBA-4BCD-AEF6-900E71C0B656}"/>
               </a:ext>
             </a:extLst>
           </p:cNvPr>
@@ -15217,7 +15217,7 @@
           <p:cNvPr id="20" name="text-86-532">
             <a:extLst xmlns:a="http://schemas.openxmlformats.org/drawingml/2006/main">
               <a:ext uri="{FF2B5EF4-FFF2-40B4-BE49-F238E27FC236}">
-                <a16:creationId xmlns:a16="http://schemas.microsoft.com/office/drawing/2014/main" id="{3449F5B9-5DBC-41F0-84A3-0AEC43CAFC30}"/>
+                <a16:creationId xmlns:a16="http://schemas.microsoft.com/office/drawing/2014/main" id="{F87D8429-2265-44AB-82B4-5388E991EAC1}"/>
               </a:ext>
             </a:extLst>
           </p:cNvPr>
@@ -15275,7 +15275,7 @@
           <p:cNvPr id="21" name="text-346-526">
             <a:extLst xmlns:a="http://schemas.openxmlformats.org/drawingml/2006/main">
               <a:ext uri="{FF2B5EF4-FFF2-40B4-BE49-F238E27FC236}">
-                <a16:creationId xmlns:a16="http://schemas.microsoft.com/office/drawing/2014/main" id="{34FA989D-7632-4D27-B5BD-A64B6C80F006}"/>
+                <a16:creationId xmlns:a16="http://schemas.microsoft.com/office/drawing/2014/main" id="{401DA4AF-06BE-4415-BED2-B8AA2864C850}"/>
               </a:ext>
             </a:extLst>
           </p:cNvPr>
@@ -15333,7 +15333,7 @@
           <p:cNvPr id="22" name="text-346-588">
             <a:extLst xmlns:a="http://schemas.openxmlformats.org/drawingml/2006/main">
               <a:ext uri="{FF2B5EF4-FFF2-40B4-BE49-F238E27FC236}">
-                <a16:creationId xmlns:a16="http://schemas.microsoft.com/office/drawing/2014/main" id="{E9CE28BB-0131-4D36-9A86-FB26142A12E4}"/>
+                <a16:creationId xmlns:a16="http://schemas.microsoft.com/office/drawing/2014/main" id="{F9D0E6C4-56BB-4766-A1F4-C565CF6B8B90}"/>
               </a:ext>
             </a:extLst>
           </p:cNvPr>
@@ -15389,7 +15389,7 @@
     </p:spTree>
     <p:extLst>
       <p:ext uri="{BB962C8B-B14F-4D97-AF65-F5344CB8AC3E}">
-        <p14:creationId xmlns:p14="http://schemas.microsoft.com/office/powerpoint/2010/main" val="1007900104"/>
+        <p14:creationId xmlns:p14="http://schemas.microsoft.com/office/powerpoint/2010/main" val="1868748965"/>
       </p:ext>
     </p:extLst>
   </p:cSld>
@@ -15420,7 +15420,7 @@
           <p:cNvPr id="32" name="kicker-9">
             <a:extLst xmlns:a="http://schemas.openxmlformats.org/drawingml/2006/main">
               <a:ext uri="{FF2B5EF4-FFF2-40B4-BE49-F238E27FC236}">
-                <a16:creationId xmlns:a16="http://schemas.microsoft.com/office/drawing/2014/main" id="{E782CE93-071E-4DE0-995B-7A14892CAB29}"/>
+                <a16:creationId xmlns:a16="http://schemas.microsoft.com/office/drawing/2014/main" id="{C1A6455E-C863-41AD-894B-62188970FB6C}"/>
               </a:ext>
             </a:extLst>
           </p:cNvPr>
@@ -15478,7 +15478,7 @@
           <p:cNvPr id="2" name="title-9">
             <a:extLst xmlns:a="http://schemas.openxmlformats.org/drawingml/2006/main">
               <a:ext uri="{FF2B5EF4-FFF2-40B4-BE49-F238E27FC236}">
-                <a16:creationId xmlns:a16="http://schemas.microsoft.com/office/drawing/2014/main" id="{91FEFB04-4935-4DA9-B1E6-35F57B67AB62}"/>
+                <a16:creationId xmlns:a16="http://schemas.microsoft.com/office/drawing/2014/main" id="{1E123410-87C0-4A9E-AC0D-0B5308E23941}"/>
               </a:ext>
             </a:extLst>
           </p:cNvPr>
@@ -15558,7 +15558,7 @@
           <p:cNvPr id="4" name="page-9">
             <a:extLst xmlns:a="http://schemas.openxmlformats.org/drawingml/2006/main">
               <a:ext uri="{FF2B5EF4-FFF2-40B4-BE49-F238E27FC236}">
-                <a16:creationId xmlns:a16="http://schemas.microsoft.com/office/drawing/2014/main" id="{95E748CF-6042-44D0-92AE-7DD497EF0BF8}"/>
+                <a16:creationId xmlns:a16="http://schemas.microsoft.com/office/drawing/2014/main" id="{2CE4F82C-C3D2-48DD-ACC2-ECBE91309C26}"/>
               </a:ext>
             </a:extLst>
           </p:cNvPr>
@@ -15616,7 +15616,7 @@
           <p:cNvPr id="5" name="text-42-164">
             <a:extLst xmlns:a="http://schemas.openxmlformats.org/drawingml/2006/main">
               <a:ext uri="{FF2B5EF4-FFF2-40B4-BE49-F238E27FC236}">
-                <a16:creationId xmlns:a16="http://schemas.microsoft.com/office/drawing/2014/main" id="{7EE3E3A9-CFED-4AEE-81D8-FF6407839FE4}"/>
+                <a16:creationId xmlns:a16="http://schemas.microsoft.com/office/drawing/2014/main" id="{A2DDED3D-F9C3-4514-92CE-E407CE99EC3D}"/>
               </a:ext>
             </a:extLst>
           </p:cNvPr>
@@ -15674,7 +15674,7 @@
           <p:cNvPr id="6" name="text-42-198">
             <a:extLst xmlns:a="http://schemas.openxmlformats.org/drawingml/2006/main">
               <a:ext uri="{FF2B5EF4-FFF2-40B4-BE49-F238E27FC236}">
-                <a16:creationId xmlns:a16="http://schemas.microsoft.com/office/drawing/2014/main" id="{2F051459-0EBA-4DF9-AFFF-F40613BEF231}"/>
+                <a16:creationId xmlns:a16="http://schemas.microsoft.com/office/drawing/2014/main" id="{2E0415A5-600D-4014-9261-0933878F8C8C}"/>
               </a:ext>
             </a:extLst>
           </p:cNvPr>
@@ -15732,7 +15732,7 @@
           <p:cNvPr id="7" name="text-42-276">
             <a:extLst xmlns:a="http://schemas.openxmlformats.org/drawingml/2006/main">
               <a:ext uri="{FF2B5EF4-FFF2-40B4-BE49-F238E27FC236}">
-                <a16:creationId xmlns:a16="http://schemas.microsoft.com/office/drawing/2014/main" id="{8A4CECF2-FB9A-40F7-8369-F2A60C20D3C0}"/>
+                <a16:creationId xmlns:a16="http://schemas.microsoft.com/office/drawing/2014/main" id="{8FD6B5AC-6669-4F85-A9A2-38F2B272A2F8}"/>
               </a:ext>
             </a:extLst>
           </p:cNvPr>
@@ -15812,7 +15812,7 @@
           <p:cNvPr id="9" name="text-42-354">
             <a:extLst xmlns:a="http://schemas.openxmlformats.org/drawingml/2006/main">
               <a:ext uri="{FF2B5EF4-FFF2-40B4-BE49-F238E27FC236}">
-                <a16:creationId xmlns:a16="http://schemas.microsoft.com/office/drawing/2014/main" id="{0947BF6E-B449-42D5-8B04-C6A4AEE372A3}"/>
+                <a16:creationId xmlns:a16="http://schemas.microsoft.com/office/drawing/2014/main" id="{07985E1D-D458-4BAA-A4DE-5C5D1DE32153}"/>
               </a:ext>
             </a:extLst>
           </p:cNvPr>
@@ -15870,7 +15870,7 @@
           <p:cNvPr id="10" name="text-232-354">
             <a:extLst xmlns:a="http://schemas.openxmlformats.org/drawingml/2006/main">
               <a:ext uri="{FF2B5EF4-FFF2-40B4-BE49-F238E27FC236}">
-                <a16:creationId xmlns:a16="http://schemas.microsoft.com/office/drawing/2014/main" id="{12A2A2F0-CE5F-4F0C-9DF9-0D93BEF037C6}"/>
+                <a16:creationId xmlns:a16="http://schemas.microsoft.com/office/drawing/2014/main" id="{3C24BC07-0403-4555-8D45-3205AA3B1401}"/>
               </a:ext>
             </a:extLst>
           </p:cNvPr>
@@ -15928,7 +15928,7 @@
           <p:cNvPr id="11" name="text-474-354">
             <a:extLst xmlns:a="http://schemas.openxmlformats.org/drawingml/2006/main">
               <a:ext uri="{FF2B5EF4-FFF2-40B4-BE49-F238E27FC236}">
-                <a16:creationId xmlns:a16="http://schemas.microsoft.com/office/drawing/2014/main" id="{C334A30E-3A05-4DDC-90C8-18BDC79AA26A}"/>
+                <a16:creationId xmlns:a16="http://schemas.microsoft.com/office/drawing/2014/main" id="{A6B3D70D-C77B-4ADB-A5FD-563487DC1C32}"/>
               </a:ext>
             </a:extLst>
           </p:cNvPr>
@@ -16008,7 +16008,7 @@
           <p:cNvPr id="13" name="text-42-418">
             <a:extLst xmlns:a="http://schemas.openxmlformats.org/drawingml/2006/main">
               <a:ext uri="{FF2B5EF4-FFF2-40B4-BE49-F238E27FC236}">
-                <a16:creationId xmlns:a16="http://schemas.microsoft.com/office/drawing/2014/main" id="{61ACEC62-ED5F-4752-A60B-04A1869D1AAF}"/>
+                <a16:creationId xmlns:a16="http://schemas.microsoft.com/office/drawing/2014/main" id="{E719E028-D156-4E9E-8201-24D05C96EE48}"/>
               </a:ext>
             </a:extLst>
           </p:cNvPr>
@@ -16066,7 +16066,7 @@
           <p:cNvPr id="14" name="text-232-418">
             <a:extLst xmlns:a="http://schemas.openxmlformats.org/drawingml/2006/main">
               <a:ext uri="{FF2B5EF4-FFF2-40B4-BE49-F238E27FC236}">
-                <a16:creationId xmlns:a16="http://schemas.microsoft.com/office/drawing/2014/main" id="{2B8FCCF3-70DC-4455-A202-9B5AFF5F6404}"/>
+                <a16:creationId xmlns:a16="http://schemas.microsoft.com/office/drawing/2014/main" id="{CE049E00-0F02-4C3E-BFDC-20C42CD8CD97}"/>
               </a:ext>
             </a:extLst>
           </p:cNvPr>
@@ -16124,7 +16124,7 @@
           <p:cNvPr id="15" name="text-474-418">
             <a:extLst xmlns:a="http://schemas.openxmlformats.org/drawingml/2006/main">
               <a:ext uri="{FF2B5EF4-FFF2-40B4-BE49-F238E27FC236}">
-                <a16:creationId xmlns:a16="http://schemas.microsoft.com/office/drawing/2014/main" id="{116F6B8E-166E-4DFC-8618-DFC5061094B1}"/>
+                <a16:creationId xmlns:a16="http://schemas.microsoft.com/office/drawing/2014/main" id="{C79CC3F8-406A-47C2-8956-E0B7CC3012BE}"/>
               </a:ext>
             </a:extLst>
           </p:cNvPr>
@@ -16204,7 +16204,7 @@
           <p:cNvPr id="17" name="text-42-482">
             <a:extLst xmlns:a="http://schemas.openxmlformats.org/drawingml/2006/main">
               <a:ext uri="{FF2B5EF4-FFF2-40B4-BE49-F238E27FC236}">
-                <a16:creationId xmlns:a16="http://schemas.microsoft.com/office/drawing/2014/main" id="{64DEC9B1-41A2-4421-B033-D3B38306FDE6}"/>
+                <a16:creationId xmlns:a16="http://schemas.microsoft.com/office/drawing/2014/main" id="{D2D399A8-D086-48BB-B3B1-E509A9C5AB8D}"/>
               </a:ext>
             </a:extLst>
           </p:cNvPr>
@@ -16262,7 +16262,7 @@
           <p:cNvPr id="18" name="text-232-482">
             <a:extLst xmlns:a="http://schemas.openxmlformats.org/drawingml/2006/main">
               <a:ext uri="{FF2B5EF4-FFF2-40B4-BE49-F238E27FC236}">
-                <a16:creationId xmlns:a16="http://schemas.microsoft.com/office/drawing/2014/main" id="{59BD56EC-D22E-415A-9271-6700511CD7DC}"/>
+                <a16:creationId xmlns:a16="http://schemas.microsoft.com/office/drawing/2014/main" id="{6E910AD6-577A-42B8-ABF0-EFC1B36A5F44}"/>
               </a:ext>
             </a:extLst>
           </p:cNvPr>
@@ -16320,7 +16320,7 @@
           <p:cNvPr id="19" name="text-474-482">
             <a:extLst xmlns:a="http://schemas.openxmlformats.org/drawingml/2006/main">
               <a:ext uri="{FF2B5EF4-FFF2-40B4-BE49-F238E27FC236}">
-                <a16:creationId xmlns:a16="http://schemas.microsoft.com/office/drawing/2014/main" id="{C7A39704-C036-424F-B75D-D20208D3042C}"/>
+                <a16:creationId xmlns:a16="http://schemas.microsoft.com/office/drawing/2014/main" id="{A3706C21-9AC8-4F09-8739-DC32170F09BA}"/>
               </a:ext>
             </a:extLst>
           </p:cNvPr>
@@ -16400,7 +16400,7 @@
           <p:cNvPr id="21" name="text-42-546">
             <a:extLst xmlns:a="http://schemas.openxmlformats.org/drawingml/2006/main">
               <a:ext uri="{FF2B5EF4-FFF2-40B4-BE49-F238E27FC236}">
-                <a16:creationId xmlns:a16="http://schemas.microsoft.com/office/drawing/2014/main" id="{89938D92-305D-4741-920D-91C9A7E209D0}"/>
+                <a16:creationId xmlns:a16="http://schemas.microsoft.com/office/drawing/2014/main" id="{B55944CF-0549-4429-95B3-8C853DD186A9}"/>
               </a:ext>
             </a:extLst>
           </p:cNvPr>
@@ -16458,7 +16458,7 @@
           <p:cNvPr id="22" name="text-232-546">
             <a:extLst xmlns:a="http://schemas.openxmlformats.org/drawingml/2006/main">
               <a:ext uri="{FF2B5EF4-FFF2-40B4-BE49-F238E27FC236}">
-                <a16:creationId xmlns:a16="http://schemas.microsoft.com/office/drawing/2014/main" id="{43A98637-EB10-4F6E-A32F-48DD5227775F}"/>
+                <a16:creationId xmlns:a16="http://schemas.microsoft.com/office/drawing/2014/main" id="{A7890626-5462-4E6B-83C5-9B2F200B0678}"/>
               </a:ext>
             </a:extLst>
           </p:cNvPr>
@@ -16516,7 +16516,7 @@
           <p:cNvPr id="23" name="text-474-546">
             <a:extLst xmlns:a="http://schemas.openxmlformats.org/drawingml/2006/main">
               <a:ext uri="{FF2B5EF4-FFF2-40B4-BE49-F238E27FC236}">
-                <a16:creationId xmlns:a16="http://schemas.microsoft.com/office/drawing/2014/main" id="{A5CFD3BD-DC97-48DA-9842-636391F7A18A}"/>
+                <a16:creationId xmlns:a16="http://schemas.microsoft.com/office/drawing/2014/main" id="{E6B7A32C-81DF-4D38-8970-F618E4E08B41}"/>
               </a:ext>
             </a:extLst>
           </p:cNvPr>
@@ -16596,7 +16596,7 @@
           <p:cNvPr id="25" name="text-678-174">
             <a:extLst xmlns:a="http://schemas.openxmlformats.org/drawingml/2006/main">
               <a:ext uri="{FF2B5EF4-FFF2-40B4-BE49-F238E27FC236}">
-                <a16:creationId xmlns:a16="http://schemas.microsoft.com/office/drawing/2014/main" id="{993F8FB4-F860-40BA-B703-FA60D85343C0}"/>
+                <a16:creationId xmlns:a16="http://schemas.microsoft.com/office/drawing/2014/main" id="{A0A39801-EF25-46F4-A2A8-6C4AAE1B52DC}"/>
               </a:ext>
             </a:extLst>
           </p:cNvPr>
@@ -16654,7 +16654,7 @@
           <p:cNvPr id="26" name="text-678-240">
             <a:extLst xmlns:a="http://schemas.openxmlformats.org/drawingml/2006/main">
               <a:ext uri="{FF2B5EF4-FFF2-40B4-BE49-F238E27FC236}">
-                <a16:creationId xmlns:a16="http://schemas.microsoft.com/office/drawing/2014/main" id="{843F444C-62C0-4A84-B886-9224975B1507}"/>
+                <a16:creationId xmlns:a16="http://schemas.microsoft.com/office/drawing/2014/main" id="{98FA9A54-2F5C-4859-A451-0C7130C74A36}"/>
               </a:ext>
             </a:extLst>
           </p:cNvPr>
@@ -16735,7 +16735,7 @@
           <p:cNvPr id="27" name="text-678-334">
             <a:extLst xmlns:a="http://schemas.openxmlformats.org/drawingml/2006/main">
               <a:ext uri="{FF2B5EF4-FFF2-40B4-BE49-F238E27FC236}">
-                <a16:creationId xmlns:a16="http://schemas.microsoft.com/office/drawing/2014/main" id="{A284EF53-DD98-4410-81B2-930649CE8CDA}"/>
+                <a16:creationId xmlns:a16="http://schemas.microsoft.com/office/drawing/2014/main" id="{7325153F-DA3D-49D0-8B1D-EC6688E23253}"/>
               </a:ext>
             </a:extLst>
           </p:cNvPr>
@@ -16793,7 +16793,7 @@
           <p:cNvPr id="28" name="text-678-400">
             <a:extLst xmlns:a="http://schemas.openxmlformats.org/drawingml/2006/main">
               <a:ext uri="{FF2B5EF4-FFF2-40B4-BE49-F238E27FC236}">
-                <a16:creationId xmlns:a16="http://schemas.microsoft.com/office/drawing/2014/main" id="{3969E925-F9E2-4A7D-AC01-1AEA3B63D3C8}"/>
+                <a16:creationId xmlns:a16="http://schemas.microsoft.com/office/drawing/2014/main" id="{F26BA067-E0B3-41FB-8617-5CCB25A6A9A0}"/>
               </a:ext>
             </a:extLst>
           </p:cNvPr>
@@ -16874,7 +16874,7 @@
           <p:cNvPr id="29" name="text-678-508">
             <a:extLst xmlns:a="http://schemas.openxmlformats.org/drawingml/2006/main">
               <a:ext uri="{FF2B5EF4-FFF2-40B4-BE49-F238E27FC236}">
-                <a16:creationId xmlns:a16="http://schemas.microsoft.com/office/drawing/2014/main" id="{173BA85F-D79B-4972-8911-61ABF08AEC77}"/>
+                <a16:creationId xmlns:a16="http://schemas.microsoft.com/office/drawing/2014/main" id="{89D4983E-C67A-4D71-9306-29CF673B9B63}"/>
               </a:ext>
             </a:extLst>
           </p:cNvPr>
@@ -16932,7 +16932,7 @@
           <p:cNvPr id="30" name="text-678-544">
             <a:extLst xmlns:a="http://schemas.openxmlformats.org/drawingml/2006/main">
               <a:ext uri="{FF2B5EF4-FFF2-40B4-BE49-F238E27FC236}">
-                <a16:creationId xmlns:a16="http://schemas.microsoft.com/office/drawing/2014/main" id="{083CE6BC-6437-42E8-93A2-CFCBB44A6081}"/>
+                <a16:creationId xmlns:a16="http://schemas.microsoft.com/office/drawing/2014/main" id="{D9033B5F-CFCA-4DD3-A62D-C47C0BE6F2F9}"/>
               </a:ext>
             </a:extLst>
           </p:cNvPr>
@@ -16990,7 +16990,7 @@
           <p:cNvPr id="31" name="text-678-642">
             <a:extLst xmlns:a="http://schemas.openxmlformats.org/drawingml/2006/main">
               <a:ext uri="{FF2B5EF4-FFF2-40B4-BE49-F238E27FC236}">
-                <a16:creationId xmlns:a16="http://schemas.microsoft.com/office/drawing/2014/main" id="{C55A32E7-4753-4DFF-80AB-C3C6449958D2}"/>
+                <a16:creationId xmlns:a16="http://schemas.microsoft.com/office/drawing/2014/main" id="{C8AC3548-2428-48A5-83EE-97AE3CF396F2}"/>
               </a:ext>
             </a:extLst>
           </p:cNvPr>
@@ -17046,7 +17046,7 @@
     </p:spTree>
     <p:extLst>
       <p:ext uri="{BB962C8B-B14F-4D97-AF65-F5344CB8AC3E}">
-        <p14:creationId xmlns:p14="http://schemas.microsoft.com/office/powerpoint/2010/main" val="855662613"/>
+        <p14:creationId xmlns:p14="http://schemas.microsoft.com/office/powerpoint/2010/main" val="177284556"/>
       </p:ext>
     </p:extLst>
   </p:cSld>

</xml_diff>